<commit_message>
Add PPT generator web app with T-Mobile Magenta theme
</commit_message>
<xml_diff>
--- a/template.pptx
+++ b/template.pptx
@@ -221,1692 +221,12 @@
 <file path=ppt/changesInfos/changesInfo1.xml><?xml version="1.0" encoding="utf-8"?>
 <pc:chgInfo xmlns:a="http://schemas.openxmlformats.org/drawingml/2006/main" xmlns:r="http://schemas.openxmlformats.org/officeDocument/2006/relationships" xmlns:ac="http://schemas.microsoft.com/office/drawing/2013/main/command" xmlns:pc="http://schemas.microsoft.com/office/powerpoint/2013/main/command">
   <pc:docChgLst>
-    <pc:chgData name="Hernan Ramirez Diaz" userId="0b0763af-8f1b-4303-84e1-6429285cc810" providerId="ADAL" clId="{42163F52-BB8D-4D37-ACEA-9F3481FEDAF8}"/>
-    <pc:docChg chg="undo redo custSel addSld delSld modSld sldOrd modSection">
-      <pc:chgData name="Hernan Ramirez Diaz" userId="0b0763af-8f1b-4303-84e1-6429285cc810" providerId="ADAL" clId="{42163F52-BB8D-4D37-ACEA-9F3481FEDAF8}" dt="2025-10-09T23:46:55.071" v="23066" actId="47"/>
-      <pc:docMkLst>
-        <pc:docMk/>
-      </pc:docMkLst>
-      <pc:sldChg chg="ord">
-        <pc:chgData name="Hernan Ramirez Diaz" userId="0b0763af-8f1b-4303-84e1-6429285cc810" providerId="ADAL" clId="{42163F52-BB8D-4D37-ACEA-9F3481FEDAF8}" dt="2025-10-03T21:28:29.889" v="12946"/>
-        <pc:sldMkLst>
-          <pc:docMk/>
-          <pc:sldMk cId="0" sldId="274"/>
-        </pc:sldMkLst>
-      </pc:sldChg>
-      <pc:sldChg chg="modSp mod">
-        <pc:chgData name="Hernan Ramirez Diaz" userId="0b0763af-8f1b-4303-84e1-6429285cc810" providerId="ADAL" clId="{42163F52-BB8D-4D37-ACEA-9F3481FEDAF8}" dt="2025-10-09T17:08:26.822" v="22799" actId="20577"/>
-        <pc:sldMkLst>
-          <pc:docMk/>
-          <pc:sldMk cId="0" sldId="275"/>
-        </pc:sldMkLst>
-      </pc:sldChg>
-      <pc:sldChg chg="add">
-        <pc:chgData name="Hernan Ramirez Diaz" userId="0b0763af-8f1b-4303-84e1-6429285cc810" providerId="ADAL" clId="{42163F52-BB8D-4D37-ACEA-9F3481FEDAF8}" dt="2025-09-30T22:48:51.036" v="3291"/>
-        <pc:sldMkLst>
-          <pc:docMk/>
-          <pc:sldMk cId="1802258249" sldId="280"/>
-        </pc:sldMkLst>
-      </pc:sldChg>
-      <pc:sldChg chg="modSp mod">
-        <pc:chgData name="Hernan Ramirez Diaz" userId="0b0763af-8f1b-4303-84e1-6429285cc810" providerId="ADAL" clId="{42163F52-BB8D-4D37-ACEA-9F3481FEDAF8}" dt="2025-10-09T18:04:53.412" v="22846" actId="20577"/>
-        <pc:sldMkLst>
-          <pc:docMk/>
-          <pc:sldMk cId="1694384516" sldId="285"/>
-        </pc:sldMkLst>
-      </pc:sldChg>
-      <pc:sldChg chg="add">
-        <pc:chgData name="Hernan Ramirez Diaz" userId="0b0763af-8f1b-4303-84e1-6429285cc810" providerId="ADAL" clId="{42163F52-BB8D-4D37-ACEA-9F3481FEDAF8}" dt="2025-09-30T22:48:51.036" v="3291"/>
-        <pc:sldMkLst>
-          <pc:docMk/>
-          <pc:sldMk cId="1946109353" sldId="355"/>
-        </pc:sldMkLst>
-      </pc:sldChg>
-      <pc:sldChg chg="addSp delSp modSp mod">
-        <pc:chgData name="Hernan Ramirez Diaz" userId="0b0763af-8f1b-4303-84e1-6429285cc810" providerId="ADAL" clId="{42163F52-BB8D-4D37-ACEA-9F3481FEDAF8}" dt="2025-09-26T19:17:47.895" v="1246" actId="478"/>
-        <pc:sldMkLst>
-          <pc:docMk/>
-          <pc:sldMk cId="2675615646" sldId="419"/>
-        </pc:sldMkLst>
-      </pc:sldChg>
-      <pc:sldChg chg="addSp delSp modSp add mod modCm modNotesTx">
-        <pc:chgData name="Hernan Ramirez Diaz" userId="0b0763af-8f1b-4303-84e1-6429285cc810" providerId="ADAL" clId="{42163F52-BB8D-4D37-ACEA-9F3481FEDAF8}" dt="2025-10-09T18:32:21.559" v="22854" actId="255"/>
-        <pc:sldMkLst>
-          <pc:docMk/>
-          <pc:sldMk cId="1299622664" sldId="434"/>
-        </pc:sldMkLst>
-        <pc:extLst>
-          <p:ext xmlns:p="http://schemas.openxmlformats.org/presentationml/2006/main" uri="{D6D511B9-2390-475A-947B-AFAB55BFBCF1}">
-            <pc226:cmChg xmlns:pc226="http://schemas.microsoft.com/office/powerpoint/2022/06/main/command" chg="mod">
-              <pc226:chgData name="Hernan Ramirez Diaz" userId="0b0763af-8f1b-4303-84e1-6429285cc810" providerId="ADAL" clId="{42163F52-BB8D-4D37-ACEA-9F3481FEDAF8}" dt="2025-10-09T18:32:19.001" v="22853" actId="20577"/>
-              <pc2:cmMkLst xmlns:pc2="http://schemas.microsoft.com/office/powerpoint/2019/9/main/command">
-                <pc:docMk/>
-                <pc:sldMk cId="1299622664" sldId="434"/>
-                <pc2:cmMk id="{9C52BFDD-9F11-4C01-8EA9-393721749318}"/>
-              </pc2:cmMkLst>
-            </pc226:cmChg>
-          </p:ext>
-        </pc:extLst>
-      </pc:sldChg>
-      <pc:sldChg chg="addSp delSp modSp mod">
-        <pc:chgData name="Hernan Ramirez Diaz" userId="0b0763af-8f1b-4303-84e1-6429285cc810" providerId="ADAL" clId="{42163F52-BB8D-4D37-ACEA-9F3481FEDAF8}" dt="2025-10-04T05:39:23.308" v="18433" actId="20577"/>
-        <pc:sldMkLst>
-          <pc:docMk/>
-          <pc:sldMk cId="2761368814" sldId="2147481181"/>
-        </pc:sldMkLst>
-      </pc:sldChg>
-      <pc:sldChg chg="ord">
-        <pc:chgData name="Hernan Ramirez Diaz" userId="0b0763af-8f1b-4303-84e1-6429285cc810" providerId="ADAL" clId="{42163F52-BB8D-4D37-ACEA-9F3481FEDAF8}" dt="2025-09-26T17:01:54.525" v="385"/>
-        <pc:sldMkLst>
-          <pc:docMk/>
-          <pc:sldMk cId="1105021549" sldId="2147481210"/>
-        </pc:sldMkLst>
-      </pc:sldChg>
-      <pc:sldChg chg="modSp mod modCm">
-        <pc:chgData name="Hernan Ramirez Diaz" userId="0b0763af-8f1b-4303-84e1-6429285cc810" providerId="ADAL" clId="{42163F52-BB8D-4D37-ACEA-9F3481FEDAF8}" dt="2025-10-03T16:10:51.912" v="10625" actId="14100"/>
-        <pc:sldMkLst>
-          <pc:docMk/>
-          <pc:sldMk cId="323746144" sldId="2147481211"/>
-        </pc:sldMkLst>
-        <pc:extLst>
-          <p:ext xmlns:p="http://schemas.openxmlformats.org/presentationml/2006/main" uri="{D6D511B9-2390-475A-947B-AFAB55BFBCF1}">
-            <pc226:cmChg xmlns:pc226="http://schemas.microsoft.com/office/powerpoint/2022/06/main/command" chg="mod">
-              <pc226:chgData name="Hernan Ramirez Diaz" userId="0b0763af-8f1b-4303-84e1-6429285cc810" providerId="ADAL" clId="{42163F52-BB8D-4D37-ACEA-9F3481FEDAF8}" dt="2025-10-02T22:39:01.158" v="9248" actId="20577"/>
-              <pc2:cmMkLst xmlns:pc2="http://schemas.microsoft.com/office/powerpoint/2019/9/main/command">
-                <pc:docMk/>
-                <pc:sldMk cId="323746144" sldId="2147481211"/>
-                <pc2:cmMk id="{39EB2F37-B8FD-49D1-A4FF-14B267B24A40}"/>
-              </pc2:cmMkLst>
-            </pc226:cmChg>
-          </p:ext>
-        </pc:extLst>
-      </pc:sldChg>
-      <pc:sldChg chg="modSp mod">
-        <pc:chgData name="Hernan Ramirez Diaz" userId="0b0763af-8f1b-4303-84e1-6429285cc810" providerId="ADAL" clId="{42163F52-BB8D-4D37-ACEA-9F3481FEDAF8}" dt="2025-10-09T04:58:22.879" v="22528" actId="1035"/>
-        <pc:sldMkLst>
-          <pc:docMk/>
-          <pc:sldMk cId="83366420" sldId="2147481212"/>
-        </pc:sldMkLst>
-      </pc:sldChg>
-      <pc:sldChg chg="delSp modSp mod">
-        <pc:chgData name="Hernan Ramirez Diaz" userId="0b0763af-8f1b-4303-84e1-6429285cc810" providerId="ADAL" clId="{42163F52-BB8D-4D37-ACEA-9F3481FEDAF8}" dt="2025-10-09T17:03:58.170" v="22792" actId="20577"/>
-        <pc:sldMkLst>
-          <pc:docMk/>
-          <pc:sldMk cId="1270242671" sldId="2147481213"/>
-        </pc:sldMkLst>
-        <pc:spChg chg="mod">
-          <ac:chgData name="Hernan Ramirez Diaz" userId="0b0763af-8f1b-4303-84e1-6429285cc810" providerId="ADAL" clId="{42163F52-BB8D-4D37-ACEA-9F3481FEDAF8}" dt="2025-10-09T17:03:58.170" v="22792" actId="20577"/>
-          <ac:spMkLst>
-            <pc:docMk/>
-            <pc:sldMk cId="1270242671" sldId="2147481213"/>
-            <ac:spMk id="4" creationId="{F93D6D7D-FF3F-82F6-14A4-6285C0323998}"/>
-          </ac:spMkLst>
-        </pc:spChg>
-        <pc:graphicFrameChg chg="mod modGraphic">
-          <ac:chgData name="Hernan Ramirez Diaz" userId="0b0763af-8f1b-4303-84e1-6429285cc810" providerId="ADAL" clId="{42163F52-BB8D-4D37-ACEA-9F3481FEDAF8}" dt="2025-10-03T22:43:17.109" v="14321" actId="207"/>
-          <ac:graphicFrameMkLst>
-            <pc:docMk/>
-            <pc:sldMk cId="1270242671" sldId="2147481213"/>
-            <ac:graphicFrameMk id="2" creationId="{38F22EE9-DEDC-E1DA-1E19-E1758E9C192D}"/>
-          </ac:graphicFrameMkLst>
-        </pc:graphicFrameChg>
-      </pc:sldChg>
-      <pc:sldChg chg="delSp modSp mod">
-        <pc:chgData name="Hernan Ramirez Diaz" userId="0b0763af-8f1b-4303-84e1-6429285cc810" providerId="ADAL" clId="{42163F52-BB8D-4D37-ACEA-9F3481FEDAF8}" dt="2025-10-09T05:00:32.384" v="22644" actId="1035"/>
-        <pc:sldMkLst>
-          <pc:docMk/>
-          <pc:sldMk cId="1389874235" sldId="2147481214"/>
-        </pc:sldMkLst>
-      </pc:sldChg>
-      <pc:sldChg chg="modSp add mod">
-        <pc:chgData name="Hernan Ramirez Diaz" userId="0b0763af-8f1b-4303-84e1-6429285cc810" providerId="ADAL" clId="{42163F52-BB8D-4D37-ACEA-9F3481FEDAF8}" dt="2025-10-03T19:58:25.863" v="12889" actId="14100"/>
-        <pc:sldMkLst>
-          <pc:docMk/>
-          <pc:sldMk cId="300876207" sldId="2147481215"/>
-        </pc:sldMkLst>
-      </pc:sldChg>
-      <pc:sldChg chg="add del ord">
-        <pc:chgData name="Hernan Ramirez Diaz" userId="0b0763af-8f1b-4303-84e1-6429285cc810" providerId="ADAL" clId="{42163F52-BB8D-4D37-ACEA-9F3481FEDAF8}" dt="2025-10-03T19:19:44.098" v="12538" actId="2696"/>
-        <pc:sldMkLst>
-          <pc:docMk/>
-          <pc:sldMk cId="3040778351" sldId="2147481215"/>
-        </pc:sldMkLst>
-      </pc:sldChg>
-      <pc:sldChg chg="del">
-        <pc:chgData name="Hernan Ramirez Diaz" userId="0b0763af-8f1b-4303-84e1-6429285cc810" providerId="ADAL" clId="{42163F52-BB8D-4D37-ACEA-9F3481FEDAF8}" dt="2025-10-01T19:52:59.448" v="3710" actId="47"/>
-        <pc:sldMkLst>
-          <pc:docMk/>
-          <pc:sldMk cId="1707149320" sldId="2147481216"/>
-        </pc:sldMkLst>
-      </pc:sldChg>
-      <pc:sldChg chg="addSp delSp modSp mod ord modCm">
-        <pc:chgData name="Hernan Ramirez Diaz" userId="0b0763af-8f1b-4303-84e1-6429285cc810" providerId="ADAL" clId="{42163F52-BB8D-4D37-ACEA-9F3481FEDAF8}" dt="2025-10-09T17:24:41.542" v="22829" actId="20577"/>
-        <pc:sldMkLst>
-          <pc:docMk/>
-          <pc:sldMk cId="3892756515" sldId="2147481219"/>
-        </pc:sldMkLst>
-        <pc:extLst>
-          <p:ext xmlns:p="http://schemas.openxmlformats.org/presentationml/2006/main" uri="{D6D511B9-2390-475A-947B-AFAB55BFBCF1}">
-            <pc226:cmChg xmlns:pc226="http://schemas.microsoft.com/office/powerpoint/2022/06/main/command" chg="mod">
-              <pc226:chgData name="Hernan Ramirez Diaz" userId="0b0763af-8f1b-4303-84e1-6429285cc810" providerId="ADAL" clId="{42163F52-BB8D-4D37-ACEA-9F3481FEDAF8}" dt="2025-10-09T17:24:41.542" v="22829" actId="20577"/>
-              <pc2:cmMkLst xmlns:pc2="http://schemas.microsoft.com/office/powerpoint/2019/9/main/command">
-                <pc:docMk/>
-                <pc:sldMk cId="3892756515" sldId="2147481219"/>
-                <pc2:cmMk id="{E4D7CC20-49CD-274F-A77F-C5E4F47D747E}"/>
-              </pc2:cmMkLst>
-            </pc226:cmChg>
-          </p:ext>
-        </pc:extLst>
-      </pc:sldChg>
-      <pc:sldChg chg="modSp mod modCm">
-        <pc:chgData name="Hernan Ramirez Diaz" userId="0b0763af-8f1b-4303-84e1-6429285cc810" providerId="ADAL" clId="{42163F52-BB8D-4D37-ACEA-9F3481FEDAF8}" dt="2025-10-09T04:59:47.752" v="22596" actId="1035"/>
-        <pc:sldMkLst>
-          <pc:docMk/>
-          <pc:sldMk cId="1157813500" sldId="2147481222"/>
-        </pc:sldMkLst>
-        <pc:extLst>
-          <p:ext xmlns:p="http://schemas.openxmlformats.org/presentationml/2006/main" uri="{D6D511B9-2390-475A-947B-AFAB55BFBCF1}">
-            <pc226:cmChg xmlns:pc226="http://schemas.microsoft.com/office/powerpoint/2022/06/main/command" chg="mod">
-              <pc226:chgData name="Hernan Ramirez Diaz" userId="0b0763af-8f1b-4303-84e1-6429285cc810" providerId="ADAL" clId="{42163F52-BB8D-4D37-ACEA-9F3481FEDAF8}" dt="2025-10-07T18:20:22.027" v="21107" actId="20577"/>
-              <pc2:cmMkLst xmlns:pc2="http://schemas.microsoft.com/office/powerpoint/2019/9/main/command">
-                <pc:docMk/>
-                <pc:sldMk cId="1157813500" sldId="2147481222"/>
-                <pc2:cmMk id="{0E9EAFC1-53E0-4A88-9A39-BCE44D7D16F2}"/>
-              </pc2:cmMkLst>
-            </pc226:cmChg>
-          </p:ext>
-        </pc:extLst>
-      </pc:sldChg>
-      <pc:sldChg chg="modSp mod">
-        <pc:chgData name="Hernan Ramirez Diaz" userId="0b0763af-8f1b-4303-84e1-6429285cc810" providerId="ADAL" clId="{42163F52-BB8D-4D37-ACEA-9F3481FEDAF8}" dt="2025-10-09T04:59:40.805" v="22590" actId="1035"/>
-        <pc:sldMkLst>
-          <pc:docMk/>
-          <pc:sldMk cId="4242413873" sldId="2147481223"/>
-        </pc:sldMkLst>
-      </pc:sldChg>
-      <pc:sldChg chg="ord">
-        <pc:chgData name="Hernan Ramirez Diaz" userId="0b0763af-8f1b-4303-84e1-6429285cc810" providerId="ADAL" clId="{42163F52-BB8D-4D37-ACEA-9F3481FEDAF8}" dt="2025-09-26T17:20:04.965" v="447"/>
-        <pc:sldMkLst>
-          <pc:docMk/>
-          <pc:sldMk cId="3621352377" sldId="2147481224"/>
-        </pc:sldMkLst>
-      </pc:sldChg>
-      <pc:sldChg chg="ord">
-        <pc:chgData name="Hernan Ramirez Diaz" userId="0b0763af-8f1b-4303-84e1-6429285cc810" providerId="ADAL" clId="{42163F52-BB8D-4D37-ACEA-9F3481FEDAF8}" dt="2025-09-26T17:01:54.525" v="385"/>
-        <pc:sldMkLst>
-          <pc:docMk/>
-          <pc:sldMk cId="2178493738" sldId="2147481225"/>
-        </pc:sldMkLst>
-      </pc:sldChg>
-      <pc:sldChg chg="addSp delSp modSp mod ord modCm">
-        <pc:chgData name="Hernan Ramirez Diaz" userId="0b0763af-8f1b-4303-84e1-6429285cc810" providerId="ADAL" clId="{42163F52-BB8D-4D37-ACEA-9F3481FEDAF8}" dt="2025-10-09T17:15:40.602" v="22819" actId="20577"/>
-        <pc:sldMkLst>
-          <pc:docMk/>
-          <pc:sldMk cId="2560992972" sldId="2147481227"/>
-        </pc:sldMkLst>
-        <pc:extLst>
-          <p:ext xmlns:p="http://schemas.openxmlformats.org/presentationml/2006/main" uri="{D6D511B9-2390-475A-947B-AFAB55BFBCF1}">
-            <pc226:cmChg xmlns:pc226="http://schemas.microsoft.com/office/powerpoint/2022/06/main/command" chg="mod">
-              <pc226:chgData name="Hernan Ramirez Diaz" userId="0b0763af-8f1b-4303-84e1-6429285cc810" providerId="ADAL" clId="{42163F52-BB8D-4D37-ACEA-9F3481FEDAF8}" dt="2025-10-09T17:15:40.602" v="22819" actId="20577"/>
-              <pc2:cmMkLst xmlns:pc2="http://schemas.microsoft.com/office/powerpoint/2019/9/main/command">
-                <pc:docMk/>
-                <pc:sldMk cId="2560992972" sldId="2147481227"/>
-                <pc2:cmMk id="{72D62EF9-F7A0-4789-9637-4F84044DA606}"/>
-              </pc2:cmMkLst>
-            </pc226:cmChg>
-          </p:ext>
-        </pc:extLst>
-      </pc:sldChg>
-      <pc:sldChg chg="addSp delSp modSp mod ord">
-        <pc:chgData name="Hernan Ramirez Diaz" userId="0b0763af-8f1b-4303-84e1-6429285cc810" providerId="ADAL" clId="{42163F52-BB8D-4D37-ACEA-9F3481FEDAF8}" dt="2025-10-09T19:32:50.791" v="23064" actId="1037"/>
-        <pc:sldMkLst>
-          <pc:docMk/>
-          <pc:sldMk cId="427855662" sldId="2147481228"/>
-        </pc:sldMkLst>
-      </pc:sldChg>
-      <pc:sldChg chg="modSp mod ord modNotesTx">
-        <pc:chgData name="Hernan Ramirez Diaz" userId="0b0763af-8f1b-4303-84e1-6429285cc810" providerId="ADAL" clId="{42163F52-BB8D-4D37-ACEA-9F3481FEDAF8}" dt="2025-10-09T04:57:52.012" v="22487" actId="1035"/>
-        <pc:sldMkLst>
-          <pc:docMk/>
-          <pc:sldMk cId="1426298556" sldId="2147481229"/>
-        </pc:sldMkLst>
-      </pc:sldChg>
-      <pc:sldChg chg="addSp delSp modSp mod">
-        <pc:chgData name="Hernan Ramirez Diaz" userId="0b0763af-8f1b-4303-84e1-6429285cc810" providerId="ADAL" clId="{42163F52-BB8D-4D37-ACEA-9F3481FEDAF8}" dt="2025-10-09T04:57:58.079" v="22501" actId="1035"/>
-        <pc:sldMkLst>
-          <pc:docMk/>
-          <pc:sldMk cId="3134119948" sldId="2147481230"/>
-        </pc:sldMkLst>
-      </pc:sldChg>
-      <pc:sldChg chg="delSp modSp del mod">
-        <pc:chgData name="Hernan Ramirez Diaz" userId="0b0763af-8f1b-4303-84e1-6429285cc810" providerId="ADAL" clId="{42163F52-BB8D-4D37-ACEA-9F3481FEDAF8}" dt="2025-10-02T20:26:03.335" v="8228" actId="47"/>
-        <pc:sldMkLst>
-          <pc:docMk/>
-          <pc:sldMk cId="1129204174" sldId="2147481231"/>
-        </pc:sldMkLst>
-      </pc:sldChg>
-      <pc:sldChg chg="addSp delSp modSp mod modCm">
-        <pc:chgData name="Hernan Ramirez Diaz" userId="0b0763af-8f1b-4303-84e1-6429285cc810" providerId="ADAL" clId="{42163F52-BB8D-4D37-ACEA-9F3481FEDAF8}" dt="2025-10-09T18:59:36.975" v="22935" actId="20577"/>
-        <pc:sldMkLst>
-          <pc:docMk/>
-          <pc:sldMk cId="1893241687" sldId="2147481232"/>
-        </pc:sldMkLst>
-        <pc:extLst>
-          <p:ext xmlns:p="http://schemas.openxmlformats.org/presentationml/2006/main" uri="{D6D511B9-2390-475A-947B-AFAB55BFBCF1}">
-            <pc226:cmChg xmlns:pc226="http://schemas.microsoft.com/office/powerpoint/2022/06/main/command" chg="mod">
-              <pc226:chgData name="Hernan Ramirez Diaz" userId="0b0763af-8f1b-4303-84e1-6429285cc810" providerId="ADAL" clId="{42163F52-BB8D-4D37-ACEA-9F3481FEDAF8}" dt="2025-10-07T18:08:32.590" v="21033" actId="20577"/>
-              <pc2:cmMkLst xmlns:pc2="http://schemas.microsoft.com/office/powerpoint/2019/9/main/command">
-                <pc:docMk/>
-                <pc:sldMk cId="1893241687" sldId="2147481232"/>
-                <pc2:cmMk id="{29037932-B4DA-4A44-A2AC-7D730AFE600D}"/>
-              </pc2:cmMkLst>
-            </pc226:cmChg>
-          </p:ext>
-        </pc:extLst>
-      </pc:sldChg>
-      <pc:sldChg chg="addSp delSp modSp new mod ord">
-        <pc:chgData name="Hernan Ramirez Diaz" userId="0b0763af-8f1b-4303-84e1-6429285cc810" providerId="ADAL" clId="{42163F52-BB8D-4D37-ACEA-9F3481FEDAF8}" dt="2025-10-01T19:15:27.007" v="3709"/>
-        <pc:sldMkLst>
-          <pc:docMk/>
-          <pc:sldMk cId="4253379048" sldId="2147481233"/>
-        </pc:sldMkLst>
-      </pc:sldChg>
-      <pc:sldChg chg="modSp mod">
-        <pc:chgData name="Hernan Ramirez Diaz" userId="0b0763af-8f1b-4303-84e1-6429285cc810" providerId="ADAL" clId="{42163F52-BB8D-4D37-ACEA-9F3481FEDAF8}" dt="2025-10-02T18:50:50.363" v="7266" actId="1036"/>
-        <pc:sldMkLst>
-          <pc:docMk/>
-          <pc:sldMk cId="3872972120" sldId="2147481234"/>
-        </pc:sldMkLst>
-      </pc:sldChg>
-      <pc:sldChg chg="modSp mod">
-        <pc:chgData name="Hernan Ramirez Diaz" userId="0b0763af-8f1b-4303-84e1-6429285cc810" providerId="ADAL" clId="{42163F52-BB8D-4D37-ACEA-9F3481FEDAF8}" dt="2025-09-30T18:22:12.515" v="2442" actId="20577"/>
-        <pc:sldMkLst>
-          <pc:docMk/>
-          <pc:sldMk cId="2664751740" sldId="2147481235"/>
-        </pc:sldMkLst>
-      </pc:sldChg>
-      <pc:sldChg chg="addSp delSp mod ord">
-        <pc:chgData name="Hernan Ramirez Diaz" userId="0b0763af-8f1b-4303-84e1-6429285cc810" providerId="ADAL" clId="{42163F52-BB8D-4D37-ACEA-9F3481FEDAF8}" dt="2025-10-03T17:59:31.126" v="12393"/>
-        <pc:sldMkLst>
-          <pc:docMk/>
-          <pc:sldMk cId="1567322584" sldId="2147481236"/>
-        </pc:sldMkLst>
-      </pc:sldChg>
-      <pc:sldChg chg="mod ord modShow">
-        <pc:chgData name="Hernan Ramirez Diaz" userId="0b0763af-8f1b-4303-84e1-6429285cc810" providerId="ADAL" clId="{42163F52-BB8D-4D37-ACEA-9F3481FEDAF8}" dt="2025-10-02T00:31:30.415" v="4706"/>
-        <pc:sldMkLst>
-          <pc:docMk/>
-          <pc:sldMk cId="229596941" sldId="2147481237"/>
-        </pc:sldMkLst>
-      </pc:sldChg>
-      <pc:sldChg chg="mod ord modShow">
-        <pc:chgData name="Hernan Ramirez Diaz" userId="0b0763af-8f1b-4303-84e1-6429285cc810" providerId="ADAL" clId="{42163F52-BB8D-4D37-ACEA-9F3481FEDAF8}" dt="2025-10-02T00:11:50.455" v="4246"/>
-        <pc:sldMkLst>
-          <pc:docMk/>
-          <pc:sldMk cId="3130016136" sldId="2147481241"/>
-        </pc:sldMkLst>
-      </pc:sldChg>
-      <pc:sldChg chg="addSp delSp modSp mod ord modNotesTx">
-        <pc:chgData name="Hernan Ramirez Diaz" userId="0b0763af-8f1b-4303-84e1-6429285cc810" providerId="ADAL" clId="{42163F52-BB8D-4D37-ACEA-9F3481FEDAF8}" dt="2025-10-09T04:50:09.294" v="22073" actId="1035"/>
-        <pc:sldMkLst>
-          <pc:docMk/>
-          <pc:sldMk cId="3576209394" sldId="2147481243"/>
-        </pc:sldMkLst>
-      </pc:sldChg>
-      <pc:sldChg chg="addSp delSp modSp mod ord modShow">
-        <pc:chgData name="Hernan Ramirez Diaz" userId="0b0763af-8f1b-4303-84e1-6429285cc810" providerId="ADAL" clId="{42163F52-BB8D-4D37-ACEA-9F3481FEDAF8}" dt="2025-10-09T04:55:44.808" v="22353" actId="1035"/>
-        <pc:sldMkLst>
-          <pc:docMk/>
-          <pc:sldMk cId="2460346233" sldId="2147481244"/>
-        </pc:sldMkLst>
-      </pc:sldChg>
-      <pc:sldChg chg="delSp modSp add mod">
-        <pc:chgData name="Hernan Ramirez Diaz" userId="0b0763af-8f1b-4303-84e1-6429285cc810" providerId="ADAL" clId="{42163F52-BB8D-4D37-ACEA-9F3481FEDAF8}" dt="2025-10-02T22:44:15.905" v="9401" actId="207"/>
-        <pc:sldMkLst>
-          <pc:docMk/>
-          <pc:sldMk cId="3253257184" sldId="2147481245"/>
-        </pc:sldMkLst>
-      </pc:sldChg>
-      <pc:sldChg chg="delSp modSp add mod">
-        <pc:chgData name="Hernan Ramirez Diaz" userId="0b0763af-8f1b-4303-84e1-6429285cc810" providerId="ADAL" clId="{42163F52-BB8D-4D37-ACEA-9F3481FEDAF8}" dt="2025-09-30T22:49:21.331" v="3295" actId="478"/>
-        <pc:sldMkLst>
-          <pc:docMk/>
-          <pc:sldMk cId="3132776874" sldId="2147481246"/>
-        </pc:sldMkLst>
-      </pc:sldChg>
-      <pc:sldChg chg="modSp mod">
-        <pc:chgData name="Hernan Ramirez Diaz" userId="0b0763af-8f1b-4303-84e1-6429285cc810" providerId="ADAL" clId="{42163F52-BB8D-4D37-ACEA-9F3481FEDAF8}" dt="2025-10-02T21:02:50.516" v="8870" actId="1036"/>
-        <pc:sldMkLst>
-          <pc:docMk/>
-          <pc:sldMk cId="1484297181" sldId="2147481247"/>
-        </pc:sldMkLst>
-      </pc:sldChg>
-      <pc:sldChg chg="addSp delSp modSp add mod">
-        <pc:chgData name="Hernan Ramirez Diaz" userId="0b0763af-8f1b-4303-84e1-6429285cc810" providerId="ADAL" clId="{42163F52-BB8D-4D37-ACEA-9F3481FEDAF8}" dt="2025-10-09T04:25:13.090" v="21978" actId="1035"/>
-        <pc:sldMkLst>
-          <pc:docMk/>
-          <pc:sldMk cId="2852939510" sldId="2147481248"/>
-        </pc:sldMkLst>
-      </pc:sldChg>
-      <pc:sldChg chg="modSp mod ord">
-        <pc:chgData name="Hernan Ramirez Diaz" userId="0b0763af-8f1b-4303-84e1-6429285cc810" providerId="ADAL" clId="{42163F52-BB8D-4D37-ACEA-9F3481FEDAF8}" dt="2025-10-09T04:58:28.772" v="22530" actId="1035"/>
-        <pc:sldMkLst>
-          <pc:docMk/>
-          <pc:sldMk cId="25791284" sldId="2147481249"/>
-        </pc:sldMkLst>
-      </pc:sldChg>
-      <pc:sldChg chg="addSp delSp modSp add mod ord modNotesTx">
-        <pc:chgData name="Hernan Ramirez Diaz" userId="0b0763af-8f1b-4303-84e1-6429285cc810" providerId="ADAL" clId="{42163F52-BB8D-4D37-ACEA-9F3481FEDAF8}" dt="2025-10-02T19:20:52.887" v="7370"/>
-        <pc:sldMkLst>
-          <pc:docMk/>
-          <pc:sldMk cId="2176796729" sldId="2147481250"/>
-        </pc:sldMkLst>
-      </pc:sldChg>
-      <pc:sldChg chg="addSp delSp modSp add del mod ord">
-        <pc:chgData name="Hernan Ramirez Diaz" userId="0b0763af-8f1b-4303-84e1-6429285cc810" providerId="ADAL" clId="{42163F52-BB8D-4D37-ACEA-9F3481FEDAF8}" dt="2025-10-01T01:45:35.806" v="3698" actId="47"/>
-        <pc:sldMkLst>
-          <pc:docMk/>
-          <pc:sldMk cId="1939539720" sldId="2147481251"/>
-        </pc:sldMkLst>
-      </pc:sldChg>
-      <pc:sldChg chg="addSp modSp mod ord">
-        <pc:chgData name="Hernan Ramirez Diaz" userId="0b0763af-8f1b-4303-84e1-6429285cc810" providerId="ADAL" clId="{42163F52-BB8D-4D37-ACEA-9F3481FEDAF8}" dt="2025-10-09T19:29:16.947" v="22953" actId="27918"/>
-        <pc:sldMkLst>
-          <pc:docMk/>
-          <pc:sldMk cId="3718838375" sldId="2147481253"/>
-        </pc:sldMkLst>
-      </pc:sldChg>
-      <pc:sldChg chg="addSp modSp new mod">
-        <pc:chgData name="Hernan Ramirez Diaz" userId="0b0763af-8f1b-4303-84e1-6429285cc810" providerId="ADAL" clId="{42163F52-BB8D-4D37-ACEA-9F3481FEDAF8}" dt="2025-10-04T05:38:27.615" v="18257" actId="20577"/>
-        <pc:sldMkLst>
-          <pc:docMk/>
-          <pc:sldMk cId="988488" sldId="2147481255"/>
-        </pc:sldMkLst>
-      </pc:sldChg>
-      <pc:sldChg chg="new del">
-        <pc:chgData name="Hernan Ramirez Diaz" userId="0b0763af-8f1b-4303-84e1-6429285cc810" providerId="ADAL" clId="{42163F52-BB8D-4D37-ACEA-9F3481FEDAF8}" dt="2025-10-04T00:12:44.661" v="16123" actId="47"/>
-        <pc:sldMkLst>
-          <pc:docMk/>
-          <pc:sldMk cId="2390622337" sldId="2147481256"/>
-        </pc:sldMkLst>
-      </pc:sldChg>
-      <pc:sldChg chg="delSp modSp add mod">
-        <pc:chgData name="Hernan Ramirez Diaz" userId="0b0763af-8f1b-4303-84e1-6429285cc810" providerId="ADAL" clId="{42163F52-BB8D-4D37-ACEA-9F3481FEDAF8}" dt="2025-10-09T18:48:15.920" v="22884" actId="20577"/>
-        <pc:sldMkLst>
-          <pc:docMk/>
-          <pc:sldMk cId="2682905776" sldId="2147481257"/>
-        </pc:sldMkLst>
-      </pc:sldChg>
-      <pc:sldChg chg="addSp delSp modSp add mod modNotesTx">
-        <pc:chgData name="Hernan Ramirez Diaz" userId="0b0763af-8f1b-4303-84e1-6429285cc810" providerId="ADAL" clId="{42163F52-BB8D-4D37-ACEA-9F3481FEDAF8}" dt="2025-10-09T19:06:07.148" v="22938" actId="20577"/>
-        <pc:sldMkLst>
-          <pc:docMk/>
-          <pc:sldMk cId="2763871" sldId="2147481258"/>
-        </pc:sldMkLst>
-      </pc:sldChg>
-      <pc:sldChg chg="delSp modSp del mod">
-        <pc:chgData name="Hernan Ramirez Diaz" userId="0b0763af-8f1b-4303-84e1-6429285cc810" providerId="ADAL" clId="{42163F52-BB8D-4D37-ACEA-9F3481FEDAF8}" dt="2025-10-03T16:59:58.268" v="11141" actId="47"/>
-        <pc:sldMkLst>
-          <pc:docMk/>
-          <pc:sldMk cId="2295337202" sldId="2147481259"/>
-        </pc:sldMkLst>
-      </pc:sldChg>
-      <pc:sldChg chg="addSp delSp modSp mod modNotesTx">
-        <pc:chgData name="Hernan Ramirez Diaz" userId="0b0763af-8f1b-4303-84e1-6429285cc810" providerId="ADAL" clId="{42163F52-BB8D-4D37-ACEA-9F3481FEDAF8}" dt="2025-10-09T19:21:31.977" v="22951" actId="20577"/>
-        <pc:sldMkLst>
-          <pc:docMk/>
-          <pc:sldMk cId="2022463905" sldId="2147481260"/>
-        </pc:sldMkLst>
-      </pc:sldChg>
-      <pc:sldChg chg="addSp delSp modSp mod">
-        <pc:chgData name="Hernan Ramirez Diaz" userId="0b0763af-8f1b-4303-84e1-6429285cc810" providerId="ADAL" clId="{42163F52-BB8D-4D37-ACEA-9F3481FEDAF8}" dt="2025-10-09T04:58:46.353" v="22549" actId="14100"/>
-        <pc:sldMkLst>
-          <pc:docMk/>
-          <pc:sldMk cId="648698299" sldId="2147481261"/>
-        </pc:sldMkLst>
-      </pc:sldChg>
-      <pc:sldChg chg="addSp delSp modSp add mod modNotesTx">
-        <pc:chgData name="Hernan Ramirez Diaz" userId="0b0763af-8f1b-4303-84e1-6429285cc810" providerId="ADAL" clId="{42163F52-BB8D-4D37-ACEA-9F3481FEDAF8}" dt="2025-10-09T04:59:29.596" v="22587" actId="1035"/>
-        <pc:sldMkLst>
-          <pc:docMk/>
-          <pc:sldMk cId="4145473322" sldId="2147481262"/>
-        </pc:sldMkLst>
-      </pc:sldChg>
-      <pc:sldChg chg="addSp delSp modSp add mod">
-        <pc:chgData name="Hernan Ramirez Diaz" userId="0b0763af-8f1b-4303-84e1-6429285cc810" providerId="ADAL" clId="{42163F52-BB8D-4D37-ACEA-9F3481FEDAF8}" dt="2025-10-09T05:00:17.277" v="22629" actId="1035"/>
-        <pc:sldMkLst>
-          <pc:docMk/>
-          <pc:sldMk cId="345488764" sldId="2147481264"/>
-        </pc:sldMkLst>
-      </pc:sldChg>
-      <pc:sldChg chg="addSp delSp modSp mod ord">
-        <pc:chgData name="Hernan Ramirez Diaz" userId="0b0763af-8f1b-4303-84e1-6429285cc810" providerId="ADAL" clId="{42163F52-BB8D-4D37-ACEA-9F3481FEDAF8}" dt="2025-10-04T04:45:30.488" v="17443"/>
-        <pc:sldMkLst>
-          <pc:docMk/>
-          <pc:sldMk cId="2503961039" sldId="2147481265"/>
-        </pc:sldMkLst>
-      </pc:sldChg>
-      <pc:sldChg chg="modSp add mod">
-        <pc:chgData name="Hernan Ramirez Diaz" userId="0b0763af-8f1b-4303-84e1-6429285cc810" providerId="ADAL" clId="{42163F52-BB8D-4D37-ACEA-9F3481FEDAF8}" dt="2025-10-03T19:58:37.894" v="12890" actId="14100"/>
-        <pc:sldMkLst>
-          <pc:docMk/>
-          <pc:sldMk cId="863687252" sldId="2147481266"/>
-        </pc:sldMkLst>
-      </pc:sldChg>
-      <pc:sldChg chg="modSp add mod">
-        <pc:chgData name="Hernan Ramirez Diaz" userId="0b0763af-8f1b-4303-84e1-6429285cc810" providerId="ADAL" clId="{42163F52-BB8D-4D37-ACEA-9F3481FEDAF8}" dt="2025-10-03T19:22:30.157" v="12629" actId="20577"/>
-        <pc:sldMkLst>
-          <pc:docMk/>
-          <pc:sldMk cId="1129400367" sldId="2147481267"/>
-        </pc:sldMkLst>
-      </pc:sldChg>
-      <pc:sldChg chg="modSp add mod">
-        <pc:chgData name="Hernan Ramirez Diaz" userId="0b0763af-8f1b-4303-84e1-6429285cc810" providerId="ADAL" clId="{42163F52-BB8D-4D37-ACEA-9F3481FEDAF8}" dt="2025-10-03T22:38:00.493" v="14302" actId="20577"/>
-        <pc:sldMkLst>
-          <pc:docMk/>
-          <pc:sldMk cId="645413853" sldId="2147481268"/>
-        </pc:sldMkLst>
-      </pc:sldChg>
-      <pc:sldChg chg="modSp add mod">
-        <pc:chgData name="Hernan Ramirez Diaz" userId="0b0763af-8f1b-4303-84e1-6429285cc810" providerId="ADAL" clId="{42163F52-BB8D-4D37-ACEA-9F3481FEDAF8}" dt="2025-10-03T19:58:45.624" v="12891" actId="14100"/>
-        <pc:sldMkLst>
-          <pc:docMk/>
-          <pc:sldMk cId="3907743225" sldId="2147481269"/>
-        </pc:sldMkLst>
-      </pc:sldChg>
-      <pc:sldChg chg="modSp add mod">
-        <pc:chgData name="Hernan Ramirez Diaz" userId="0b0763af-8f1b-4303-84e1-6429285cc810" providerId="ADAL" clId="{42163F52-BB8D-4D37-ACEA-9F3481FEDAF8}" dt="2025-10-03T19:58:54.074" v="12892" actId="14100"/>
-        <pc:sldMkLst>
-          <pc:docMk/>
-          <pc:sldMk cId="2080702279" sldId="2147481270"/>
-        </pc:sldMkLst>
-      </pc:sldChg>
-      <pc:sldChg chg="addSp delSp modSp mod ord">
-        <pc:chgData name="Hernan Ramirez Diaz" userId="0b0763af-8f1b-4303-84e1-6429285cc810" providerId="ADAL" clId="{42163F52-BB8D-4D37-ACEA-9F3481FEDAF8}" dt="2025-10-09T04:58:07.039" v="22505" actId="1035"/>
-        <pc:sldMkLst>
-          <pc:docMk/>
-          <pc:sldMk cId="869299062" sldId="2147481271"/>
-        </pc:sldMkLst>
-      </pc:sldChg>
-      <pc:sldChg chg="modSp new del mod">
-        <pc:chgData name="Hernan Ramirez Diaz" userId="0b0763af-8f1b-4303-84e1-6429285cc810" providerId="ADAL" clId="{42163F52-BB8D-4D37-ACEA-9F3481FEDAF8}" dt="2025-10-04T06:03:41.892" v="18453" actId="47"/>
-        <pc:sldMkLst>
-          <pc:docMk/>
-          <pc:sldMk cId="3779341304" sldId="2147481272"/>
-        </pc:sldMkLst>
-      </pc:sldChg>
-      <pc:sldChg chg="new">
-        <pc:chgData name="Hernan Ramirez Diaz" userId="0b0763af-8f1b-4303-84e1-6429285cc810" providerId="ADAL" clId="{42163F52-BB8D-4D37-ACEA-9F3481FEDAF8}" dt="2025-10-03T22:57:27.833" v="14445" actId="680"/>
-        <pc:sldMkLst>
-          <pc:docMk/>
-          <pc:sldMk cId="1252616050" sldId="2147481273"/>
-        </pc:sldMkLst>
-      </pc:sldChg>
-      <pc:sldChg chg="addSp delSp modSp add mod ord">
-        <pc:chgData name="Hernan Ramirez Diaz" userId="0b0763af-8f1b-4303-84e1-6429285cc810" providerId="ADAL" clId="{42163F52-BB8D-4D37-ACEA-9F3481FEDAF8}" dt="2025-10-04T00:27:05.972" v="16436" actId="1076"/>
-        <pc:sldMkLst>
-          <pc:docMk/>
-          <pc:sldMk cId="1976876559" sldId="2147481274"/>
-        </pc:sldMkLst>
-      </pc:sldChg>
-      <pc:sldChg chg="delSp add mod ord">
-        <pc:chgData name="Hernan Ramirez Diaz" userId="0b0763af-8f1b-4303-84e1-6429285cc810" providerId="ADAL" clId="{42163F52-BB8D-4D37-ACEA-9F3481FEDAF8}" dt="2025-10-04T00:21:17.826" v="16356"/>
-        <pc:sldMkLst>
-          <pc:docMk/>
-          <pc:sldMk cId="68822884" sldId="2147481275"/>
-        </pc:sldMkLst>
-      </pc:sldChg>
-      <pc:sldChg chg="addSp delSp modSp add mod">
-        <pc:chgData name="Hernan Ramirez Diaz" userId="0b0763af-8f1b-4303-84e1-6429285cc810" providerId="ADAL" clId="{42163F52-BB8D-4D37-ACEA-9F3481FEDAF8}" dt="2025-10-08T18:03:35.166" v="21342" actId="1076"/>
-        <pc:sldMkLst>
-          <pc:docMk/>
-          <pc:sldMk cId="926817997" sldId="2147481276"/>
-        </pc:sldMkLst>
-      </pc:sldChg>
-      <pc:sldChg chg="delSp modSp add del mod ord">
-        <pc:chgData name="Hernan Ramirez Diaz" userId="0b0763af-8f1b-4303-84e1-6429285cc810" providerId="ADAL" clId="{42163F52-BB8D-4D37-ACEA-9F3481FEDAF8}" dt="2025-10-04T06:05:30.878" v="18628" actId="47"/>
-        <pc:sldMkLst>
-          <pc:docMk/>
-          <pc:sldMk cId="938116946" sldId="2147481277"/>
-        </pc:sldMkLst>
-      </pc:sldChg>
-      <pc:sldChg chg="addSp delSp modSp add mod ord">
-        <pc:chgData name="Hernan Ramirez Diaz" userId="0b0763af-8f1b-4303-84e1-6429285cc810" providerId="ADAL" clId="{42163F52-BB8D-4D37-ACEA-9F3481FEDAF8}" dt="2025-10-09T19:19:56.706" v="22940" actId="115"/>
-        <pc:sldMkLst>
-          <pc:docMk/>
-          <pc:sldMk cId="2350308366" sldId="2147481278"/>
-        </pc:sldMkLst>
-      </pc:sldChg>
-      <pc:sldChg chg="modSp mod">
-        <pc:chgData name="Hernan Ramirez Diaz" userId="0b0763af-8f1b-4303-84e1-6429285cc810" providerId="ADAL" clId="{42163F52-BB8D-4D37-ACEA-9F3481FEDAF8}" dt="2025-10-09T16:55:50.150" v="22770" actId="1035"/>
-        <pc:sldMkLst>
-          <pc:docMk/>
-          <pc:sldMk cId="1618464510" sldId="2147481280"/>
-        </pc:sldMkLst>
-      </pc:sldChg>
-      <pc:sldChg chg="modSp mod">
-        <pc:chgData name="Hernan Ramirez Diaz" userId="0b0763af-8f1b-4303-84e1-6429285cc810" providerId="ADAL" clId="{42163F52-BB8D-4D37-ACEA-9F3481FEDAF8}" dt="2025-10-09T17:04:19.208" v="22794" actId="20577"/>
-        <pc:sldMkLst>
-          <pc:docMk/>
-          <pc:sldMk cId="2379161747" sldId="2147481286"/>
-        </pc:sldMkLst>
-      </pc:sldChg>
-      <pc:sldChg chg="modSp mod">
-        <pc:chgData name="Hernan Ramirez Diaz" userId="0b0763af-8f1b-4303-84e1-6429285cc810" providerId="ADAL" clId="{42163F52-BB8D-4D37-ACEA-9F3481FEDAF8}" dt="2025-10-09T17:04:16.565" v="22793" actId="20577"/>
-        <pc:sldMkLst>
-          <pc:docMk/>
-          <pc:sldMk cId="2042423855" sldId="2147481287"/>
-        </pc:sldMkLst>
-      </pc:sldChg>
-      <pc:sldChg chg="modSp mod">
-        <pc:chgData name="Hernan Ramirez Diaz" userId="0b0763af-8f1b-4303-84e1-6429285cc810" providerId="ADAL" clId="{42163F52-BB8D-4D37-ACEA-9F3481FEDAF8}" dt="2025-10-08T18:04:09.094" v="21366" actId="1076"/>
-        <pc:sldMkLst>
-          <pc:docMk/>
-          <pc:sldMk cId="1156650361" sldId="2147481291"/>
-        </pc:sldMkLst>
-      </pc:sldChg>
-      <pc:sldChg chg="modSp mod ord">
-        <pc:chgData name="Hernan Ramirez Diaz" userId="0b0763af-8f1b-4303-84e1-6429285cc810" providerId="ADAL" clId="{42163F52-BB8D-4D37-ACEA-9F3481FEDAF8}" dt="2025-10-08T18:09:50.816" v="21544"/>
-        <pc:sldMkLst>
-          <pc:docMk/>
-          <pc:sldMk cId="277216321" sldId="2147481295"/>
-        </pc:sldMkLst>
-      </pc:sldChg>
-      <pc:sldChg chg="add del">
-        <pc:chgData name="Hernan Ramirez Diaz" userId="0b0763af-8f1b-4303-84e1-6429285cc810" providerId="ADAL" clId="{42163F52-BB8D-4D37-ACEA-9F3481FEDAF8}" dt="2025-10-09T23:46:55.071" v="23066" actId="47"/>
-        <pc:sldMkLst>
-          <pc:docMk/>
-          <pc:sldMk cId="3933677755" sldId="2147481297"/>
-        </pc:sldMkLst>
-      </pc:sldChg>
-    </pc:docChg>
-  </pc:docChgLst>
-  <pc:docChgLst>
-    <pc:chgData name="Michael Bruno" userId="ed6069a4-1fcb-46c4-b4b7-85c279acb11e" providerId="ADAL" clId="{613589E5-1A9A-41C5-92C9-D44D19F40B73}"/>
-    <pc:docChg chg="custSel modSld">
-      <pc:chgData name="Michael Bruno" userId="ed6069a4-1fcb-46c4-b4b7-85c279acb11e" providerId="ADAL" clId="{613589E5-1A9A-41C5-92C9-D44D19F40B73}" dt="2025-10-10T20:06:34.494" v="3" actId="13926"/>
-      <pc:docMkLst>
-        <pc:docMk/>
-      </pc:docMkLst>
-      <pc:sldChg chg="delSp modSp mod">
-        <pc:chgData name="Michael Bruno" userId="ed6069a4-1fcb-46c4-b4b7-85c279acb11e" providerId="ADAL" clId="{613589E5-1A9A-41C5-92C9-D44D19F40B73}" dt="2025-10-09T23:11:36.343" v="2" actId="478"/>
-        <pc:sldMkLst>
-          <pc:docMk/>
-          <pc:sldMk cId="0" sldId="260"/>
-        </pc:sldMkLst>
-      </pc:sldChg>
-      <pc:sldChg chg="modSp mod">
-        <pc:chgData name="Michael Bruno" userId="ed6069a4-1fcb-46c4-b4b7-85c279acb11e" providerId="ADAL" clId="{613589E5-1A9A-41C5-92C9-D44D19F40B73}" dt="2025-10-10T20:06:34.494" v="3" actId="13926"/>
-        <pc:sldMkLst>
-          <pc:docMk/>
-          <pc:sldMk cId="829862625" sldId="2147481206"/>
-        </pc:sldMkLst>
-      </pc:sldChg>
-    </pc:docChg>
-  </pc:docChgLst>
-  <pc:docChgLst>
-    <pc:chgData name="Ridhima Dhawan" userId="41b5bd7b-df07-43ed-9321-8df1cf164a12" providerId="ADAL" clId="{454EBA3A-CFA7-4557-80A3-8406924164EC}"/>
-    <pc:docChg chg="undo custSel addSld delSld modSld sldOrd delSection modSection">
-      <pc:chgData name="Ridhima Dhawan" userId="41b5bd7b-df07-43ed-9321-8df1cf164a12" providerId="ADAL" clId="{454EBA3A-CFA7-4557-80A3-8406924164EC}" dt="2025-09-26T16:50:09.182" v="9258" actId="20577"/>
-      <pc:docMkLst>
-        <pc:docMk/>
-      </pc:docMkLst>
-      <pc:sldChg chg="modSp mod">
-        <pc:chgData name="Ridhima Dhawan" userId="41b5bd7b-df07-43ed-9321-8df1cf164a12" providerId="ADAL" clId="{454EBA3A-CFA7-4557-80A3-8406924164EC}" dt="2025-09-19T04:20:02.730" v="1329" actId="20577"/>
-        <pc:sldMkLst>
-          <pc:docMk/>
-          <pc:sldMk cId="0" sldId="274"/>
-        </pc:sldMkLst>
-      </pc:sldChg>
-      <pc:sldChg chg="modSp mod">
-        <pc:chgData name="Ridhima Dhawan" userId="41b5bd7b-df07-43ed-9321-8df1cf164a12" providerId="ADAL" clId="{454EBA3A-CFA7-4557-80A3-8406924164EC}" dt="2025-09-17T17:37:21.941" v="5" actId="20577"/>
-        <pc:sldMkLst>
-          <pc:docMk/>
-          <pc:sldMk cId="0" sldId="275"/>
-        </pc:sldMkLst>
-      </pc:sldChg>
-      <pc:sldChg chg="addSp delSp modSp mod">
-        <pc:chgData name="Ridhima Dhawan" userId="41b5bd7b-df07-43ed-9321-8df1cf164a12" providerId="ADAL" clId="{454EBA3A-CFA7-4557-80A3-8406924164EC}" dt="2025-09-23T16:11:19.018" v="2066" actId="14100"/>
-        <pc:sldMkLst>
-          <pc:docMk/>
-          <pc:sldMk cId="1694384516" sldId="285"/>
-        </pc:sldMkLst>
-      </pc:sldChg>
-      <pc:sldChg chg="addSp delSp modSp mod modNotesTx">
-        <pc:chgData name="Ridhima Dhawan" userId="41b5bd7b-df07-43ed-9321-8df1cf164a12" providerId="ADAL" clId="{454EBA3A-CFA7-4557-80A3-8406924164EC}" dt="2025-09-19T03:52:27.481" v="1232" actId="20577"/>
-        <pc:sldMkLst>
-          <pc:docMk/>
-          <pc:sldMk cId="3180984745" sldId="333"/>
-        </pc:sldMkLst>
-      </pc:sldChg>
-      <pc:sldChg chg="addSp delSp modSp mod ord modNotesTx">
-        <pc:chgData name="Ridhima Dhawan" userId="41b5bd7b-df07-43ed-9321-8df1cf164a12" providerId="ADAL" clId="{454EBA3A-CFA7-4557-80A3-8406924164EC}" dt="2025-09-25T15:58:08.681" v="9002" actId="20577"/>
-        <pc:sldMkLst>
-          <pc:docMk/>
-          <pc:sldMk cId="2675615646" sldId="419"/>
-        </pc:sldMkLst>
-      </pc:sldChg>
-      <pc:sldChg chg="del">
-        <pc:chgData name="Ridhima Dhawan" userId="41b5bd7b-df07-43ed-9321-8df1cf164a12" providerId="ADAL" clId="{454EBA3A-CFA7-4557-80A3-8406924164EC}" dt="2025-09-17T17:41:25.728" v="134" actId="47"/>
-        <pc:sldMkLst>
-          <pc:docMk/>
-          <pc:sldMk cId="1299622664" sldId="434"/>
-        </pc:sldMkLst>
-      </pc:sldChg>
-      <pc:sldChg chg="addSp delSp modSp add mod">
-        <pc:chgData name="Ridhima Dhawan" userId="41b5bd7b-df07-43ed-9321-8df1cf164a12" providerId="ADAL" clId="{454EBA3A-CFA7-4557-80A3-8406924164EC}" dt="2025-09-23T19:05:17.611" v="6364" actId="20577"/>
-        <pc:sldMkLst>
-          <pc:docMk/>
-          <pc:sldMk cId="2128657008" sldId="2147481209"/>
-        </pc:sldMkLst>
-      </pc:sldChg>
-      <pc:sldChg chg="addSp delSp modSp new mod ord">
-        <pc:chgData name="Ridhima Dhawan" userId="41b5bd7b-df07-43ed-9321-8df1cf164a12" providerId="ADAL" clId="{454EBA3A-CFA7-4557-80A3-8406924164EC}" dt="2025-09-25T15:39:08.861" v="8952" actId="1076"/>
-        <pc:sldMkLst>
-          <pc:docMk/>
-          <pc:sldMk cId="1105021549" sldId="2147481210"/>
-        </pc:sldMkLst>
-      </pc:sldChg>
-      <pc:sldChg chg="addSp delSp modSp add mod">
-        <pc:chgData name="Ridhima Dhawan" userId="41b5bd7b-df07-43ed-9321-8df1cf164a12" providerId="ADAL" clId="{454EBA3A-CFA7-4557-80A3-8406924164EC}" dt="2025-09-26T06:42:10.782" v="9233" actId="20577"/>
-        <pc:sldMkLst>
-          <pc:docMk/>
-          <pc:sldMk cId="323746144" sldId="2147481211"/>
-        </pc:sldMkLst>
-      </pc:sldChg>
-      <pc:sldChg chg="addSp delSp modSp add mod">
-        <pc:chgData name="Ridhima Dhawan" userId="41b5bd7b-df07-43ed-9321-8df1cf164a12" providerId="ADAL" clId="{454EBA3A-CFA7-4557-80A3-8406924164EC}" dt="2025-09-23T16:39:12.998" v="3725" actId="1076"/>
-        <pc:sldMkLst>
-          <pc:docMk/>
-          <pc:sldMk cId="83366420" sldId="2147481212"/>
-        </pc:sldMkLst>
-      </pc:sldChg>
-      <pc:sldChg chg="addSp delSp modSp add mod">
-        <pc:chgData name="Ridhima Dhawan" userId="41b5bd7b-df07-43ed-9321-8df1cf164a12" providerId="ADAL" clId="{454EBA3A-CFA7-4557-80A3-8406924164EC}" dt="2025-09-26T06:45:21.549" v="9234" actId="1076"/>
-        <pc:sldMkLst>
-          <pc:docMk/>
-          <pc:sldMk cId="1270242671" sldId="2147481213"/>
-        </pc:sldMkLst>
-        <pc:spChg chg="mod">
-          <ac:chgData name="Ridhima Dhawan" userId="41b5bd7b-df07-43ed-9321-8df1cf164a12" providerId="ADAL" clId="{454EBA3A-CFA7-4557-80A3-8406924164EC}" dt="2025-09-23T16:51:56.192" v="3918" actId="20577"/>
-          <ac:spMkLst>
-            <pc:docMk/>
-            <pc:sldMk cId="1270242671" sldId="2147481213"/>
-            <ac:spMk id="3" creationId="{BF8AA7B9-40BC-BD5B-A38F-B69FFA6E6319}"/>
-          </ac:spMkLst>
-        </pc:spChg>
-        <pc:spChg chg="add mod">
-          <ac:chgData name="Ridhima Dhawan" userId="41b5bd7b-df07-43ed-9321-8df1cf164a12" providerId="ADAL" clId="{454EBA3A-CFA7-4557-80A3-8406924164EC}" dt="2025-09-26T06:45:21.549" v="9234" actId="1076"/>
-          <ac:spMkLst>
-            <pc:docMk/>
-            <pc:sldMk cId="1270242671" sldId="2147481213"/>
-            <ac:spMk id="4" creationId="{F93D6D7D-FF3F-82F6-14A4-6285C0323998}"/>
-          </ac:spMkLst>
-        </pc:spChg>
-        <pc:graphicFrameChg chg="add mod modGraphic">
-          <ac:chgData name="Ridhima Dhawan" userId="41b5bd7b-df07-43ed-9321-8df1cf164a12" providerId="ADAL" clId="{454EBA3A-CFA7-4557-80A3-8406924164EC}" dt="2025-09-23T23:14:56.318" v="7961" actId="1076"/>
-          <ac:graphicFrameMkLst>
-            <pc:docMk/>
-            <pc:sldMk cId="1270242671" sldId="2147481213"/>
-            <ac:graphicFrameMk id="2" creationId="{38F22EE9-DEDC-E1DA-1E19-E1758E9C192D}"/>
-          </ac:graphicFrameMkLst>
-        </pc:graphicFrameChg>
-      </pc:sldChg>
-      <pc:sldChg chg="addSp delSp modSp add mod">
-        <pc:chgData name="Ridhima Dhawan" userId="41b5bd7b-df07-43ed-9321-8df1cf164a12" providerId="ADAL" clId="{454EBA3A-CFA7-4557-80A3-8406924164EC}" dt="2025-09-23T18:42:17.814" v="6250" actId="20577"/>
-        <pc:sldMkLst>
-          <pc:docMk/>
-          <pc:sldMk cId="1389874235" sldId="2147481214"/>
-        </pc:sldMkLst>
-      </pc:sldChg>
-      <pc:sldChg chg="modSp add mod">
-        <pc:chgData name="Ridhima Dhawan" userId="41b5bd7b-df07-43ed-9321-8df1cf164a12" providerId="ADAL" clId="{454EBA3A-CFA7-4557-80A3-8406924164EC}" dt="2025-09-17T17:51:09.912" v="323" actId="20577"/>
-        <pc:sldMkLst>
-          <pc:docMk/>
-          <pc:sldMk cId="3040778351" sldId="2147481215"/>
-        </pc:sldMkLst>
-      </pc:sldChg>
-      <pc:sldChg chg="delSp modSp add mod ord">
-        <pc:chgData name="Ridhima Dhawan" userId="41b5bd7b-df07-43ed-9321-8df1cf164a12" providerId="ADAL" clId="{454EBA3A-CFA7-4557-80A3-8406924164EC}" dt="2025-09-17T20:05:15.773" v="1049" actId="313"/>
-        <pc:sldMkLst>
-          <pc:docMk/>
-          <pc:sldMk cId="1707149320" sldId="2147481216"/>
-        </pc:sldMkLst>
-      </pc:sldChg>
-      <pc:sldChg chg="add">
-        <pc:chgData name="Ridhima Dhawan" userId="41b5bd7b-df07-43ed-9321-8df1cf164a12" providerId="ADAL" clId="{454EBA3A-CFA7-4557-80A3-8406924164EC}" dt="2025-09-19T04:19:51.802" v="1315" actId="2890"/>
-        <pc:sldMkLst>
-          <pc:docMk/>
-          <pc:sldMk cId="2307073506" sldId="2147481217"/>
-        </pc:sldMkLst>
-      </pc:sldChg>
-      <pc:sldChg chg="addSp delSp modSp add mod">
-        <pc:chgData name="Ridhima Dhawan" userId="41b5bd7b-df07-43ed-9321-8df1cf164a12" providerId="ADAL" clId="{454EBA3A-CFA7-4557-80A3-8406924164EC}" dt="2025-09-23T19:06:18.876" v="6365" actId="14100"/>
-        <pc:sldMkLst>
-          <pc:docMk/>
-          <pc:sldMk cId="145336846" sldId="2147481218"/>
-        </pc:sldMkLst>
-      </pc:sldChg>
-      <pc:sldChg chg="addSp delSp modSp new mod">
-        <pc:chgData name="Ridhima Dhawan" userId="41b5bd7b-df07-43ed-9321-8df1cf164a12" providerId="ADAL" clId="{454EBA3A-CFA7-4557-80A3-8406924164EC}" dt="2025-09-25T15:21:33.063" v="8938" actId="20577"/>
-        <pc:sldMkLst>
-          <pc:docMk/>
-          <pc:sldMk cId="2449955966" sldId="2147481220"/>
-        </pc:sldMkLst>
-      </pc:sldChg>
-      <pc:sldChg chg="addSp delSp modSp add mod">
-        <pc:chgData name="Ridhima Dhawan" userId="41b5bd7b-df07-43ed-9321-8df1cf164a12" providerId="ADAL" clId="{454EBA3A-CFA7-4557-80A3-8406924164EC}" dt="2025-09-23T23:12:20.625" v="7960" actId="1076"/>
-        <pc:sldMkLst>
-          <pc:docMk/>
-          <pc:sldMk cId="3753532281" sldId="2147481221"/>
-        </pc:sldMkLst>
-      </pc:sldChg>
-      <pc:sldChg chg="addSp delSp modSp add mod ord">
-        <pc:chgData name="Ridhima Dhawan" userId="41b5bd7b-df07-43ed-9321-8df1cf164a12" providerId="ADAL" clId="{454EBA3A-CFA7-4557-80A3-8406924164EC}" dt="2025-09-26T16:50:09.182" v="9258" actId="20577"/>
-        <pc:sldMkLst>
-          <pc:docMk/>
-          <pc:sldMk cId="1157813500" sldId="2147481222"/>
-        </pc:sldMkLst>
-      </pc:sldChg>
-      <pc:sldChg chg="addSp delSp modSp add mod ord replId">
-        <pc:chgData name="Ridhima Dhawan" userId="41b5bd7b-df07-43ed-9321-8df1cf164a12" providerId="ADAL" clId="{454EBA3A-CFA7-4557-80A3-8406924164EC}" dt="2025-09-23T18:24:32.029" v="5732" actId="20577"/>
-        <pc:sldMkLst>
-          <pc:docMk/>
-          <pc:sldMk cId="4242413873" sldId="2147481223"/>
-        </pc:sldMkLst>
-      </pc:sldChg>
-      <pc:sldChg chg="addSp delSp modSp add mod">
-        <pc:chgData name="Ridhima Dhawan" userId="41b5bd7b-df07-43ed-9321-8df1cf164a12" providerId="ADAL" clId="{454EBA3A-CFA7-4557-80A3-8406924164EC}" dt="2025-09-26T06:40:51.484" v="9216" actId="404"/>
-        <pc:sldMkLst>
-          <pc:docMk/>
-          <pc:sldMk cId="3621352377" sldId="2147481224"/>
-        </pc:sldMkLst>
-      </pc:sldChg>
-      <pc:sldChg chg="addSp delSp modSp add mod">
-        <pc:chgData name="Ridhima Dhawan" userId="41b5bd7b-df07-43ed-9321-8df1cf164a12" providerId="ADAL" clId="{454EBA3A-CFA7-4557-80A3-8406924164EC}" dt="2025-09-25T15:39:35.496" v="8966" actId="20577"/>
-        <pc:sldMkLst>
-          <pc:docMk/>
-          <pc:sldMk cId="2178493738" sldId="2147481225"/>
-        </pc:sldMkLst>
-      </pc:sldChg>
-      <pc:sldChg chg="delSp modSp add mod">
-        <pc:chgData name="Ridhima Dhawan" userId="41b5bd7b-df07-43ed-9321-8df1cf164a12" providerId="ADAL" clId="{454EBA3A-CFA7-4557-80A3-8406924164EC}" dt="2025-09-25T18:48:13.249" v="9135" actId="20577"/>
-        <pc:sldMkLst>
-          <pc:docMk/>
-          <pc:sldMk cId="1394883244" sldId="2147481226"/>
-        </pc:sldMkLst>
-      </pc:sldChg>
-      <pc:sldChg chg="addSp delSp modSp add mod">
-        <pc:chgData name="Ridhima Dhawan" userId="41b5bd7b-df07-43ed-9321-8df1cf164a12" providerId="ADAL" clId="{454EBA3A-CFA7-4557-80A3-8406924164EC}" dt="2025-09-25T15:59:22.730" v="9080" actId="20577"/>
-        <pc:sldMkLst>
-          <pc:docMk/>
-          <pc:sldMk cId="2560992972" sldId="2147481227"/>
-        </pc:sldMkLst>
-      </pc:sldChg>
-      <pc:sldChg chg="modSp add mod">
-        <pc:chgData name="Ridhima Dhawan" userId="41b5bd7b-df07-43ed-9321-8df1cf164a12" providerId="ADAL" clId="{454EBA3A-CFA7-4557-80A3-8406924164EC}" dt="2025-09-25T15:59:30.763" v="9087" actId="20577"/>
-        <pc:sldMkLst>
-          <pc:docMk/>
-          <pc:sldMk cId="427855662" sldId="2147481228"/>
-        </pc:sldMkLst>
-      </pc:sldChg>
-      <pc:sldMasterChg chg="delSldLayout">
-        <pc:chgData name="Ridhima Dhawan" userId="41b5bd7b-df07-43ed-9321-8df1cf164a12" providerId="ADAL" clId="{454EBA3A-CFA7-4557-80A3-8406924164EC}" dt="2025-09-23T16:11:22.319" v="2067" actId="47"/>
-        <pc:sldMasterMkLst>
-          <pc:docMk/>
-          <pc:sldMasterMk cId="1804289383" sldId="2147483648"/>
-        </pc:sldMasterMkLst>
-      </pc:sldMasterChg>
-    </pc:docChg>
-  </pc:docChgLst>
-  <pc:docChgLst>
-    <pc:chgData name="Kate Tharp" userId="S::kate.tharp@vml.com::f673b90c-5ccd-4f11-b817-79e0f5d8c583" providerId="AD" clId="Web-{A1CFB926-845E-A4C8-E1FE-729016EF509A}"/>
-    <pc:docChg chg="mod">
-      <pc:chgData name="Kate Tharp" userId="S::kate.tharp@vml.com::f673b90c-5ccd-4f11-b817-79e0f5d8c583" providerId="AD" clId="Web-{A1CFB926-845E-A4C8-E1FE-729016EF509A}" dt="2025-09-30T17:14:33.967" v="0"/>
-      <pc:docMkLst>
-        <pc:docMk/>
-      </pc:docMkLst>
-    </pc:docChg>
-  </pc:docChgLst>
-  <pc:docChgLst>
     <pc:chgData name="Hernan Ramirez Diaz" userId="0b0763af-8f1b-4303-84e1-6429285cc810" providerId="ADAL" clId="{2822E497-8A7B-4458-B97C-66D815959D76}"/>
     <pc:docChg chg="undo redo custSel addSld delSld modSld sldOrd modSection">
       <pc:chgData name="Hernan Ramirez Diaz" userId="0b0763af-8f1b-4303-84e1-6429285cc810" providerId="ADAL" clId="{2822E497-8A7B-4458-B97C-66D815959D76}" dt="2025-09-02T20:40:05.164" v="28504" actId="20577"/>
       <pc:docMkLst>
         <pc:docMk/>
       </pc:docMkLst>
-    </pc:docChg>
-  </pc:docChgLst>
-  <pc:docChgLst>
-    <pc:chgData name="Casey Lee" userId="4bc459e0-655e-452e-96c2-b918c0999cdb" providerId="ADAL" clId="{FEDCCBD3-F3AF-4248-98FF-B03AEB6CAACA}"/>
-    <pc:docChg chg="undo redo custSel addSld delSld modSld sldOrd modSection">
-      <pc:chgData name="Casey Lee" userId="4bc459e0-655e-452e-96c2-b918c0999cdb" providerId="ADAL" clId="{FEDCCBD3-F3AF-4248-98FF-B03AEB6CAACA}" dt="2025-10-17T17:36:01.193" v="70061" actId="21"/>
-      <pc:docMkLst>
-        <pc:docMk/>
-      </pc:docMkLst>
-      <pc:sldChg chg="ord">
-        <pc:chgData name="Casey Lee" userId="4bc459e0-655e-452e-96c2-b918c0999cdb" providerId="ADAL" clId="{FEDCCBD3-F3AF-4248-98FF-B03AEB6CAACA}" dt="2025-10-02T20:28:16.132" v="37985"/>
-        <pc:sldMkLst>
-          <pc:docMk/>
-          <pc:sldMk cId="1802258249" sldId="280"/>
-        </pc:sldMkLst>
-      </pc:sldChg>
-      <pc:sldChg chg="modSp mod">
-        <pc:chgData name="Casey Lee" userId="4bc459e0-655e-452e-96c2-b918c0999cdb" providerId="ADAL" clId="{FEDCCBD3-F3AF-4248-98FF-B03AEB6CAACA}" dt="2025-09-30T16:47:04.428" v="21631" actId="20577"/>
-        <pc:sldMkLst>
-          <pc:docMk/>
-          <pc:sldMk cId="1694384516" sldId="285"/>
-        </pc:sldMkLst>
-      </pc:sldChg>
-      <pc:sldChg chg="add del mod ord modShow">
-        <pc:chgData name="Casey Lee" userId="4bc459e0-655e-452e-96c2-b918c0999cdb" providerId="ADAL" clId="{FEDCCBD3-F3AF-4248-98FF-B03AEB6CAACA}" dt="2025-09-26T16:35:44.883" v="4535"/>
-        <pc:sldMkLst>
-          <pc:docMk/>
-          <pc:sldMk cId="2227000735" sldId="307"/>
-        </pc:sldMkLst>
-      </pc:sldChg>
-      <pc:sldChg chg="addSp delSp modSp mod ord">
-        <pc:chgData name="Casey Lee" userId="4bc459e0-655e-452e-96c2-b918c0999cdb" providerId="ADAL" clId="{FEDCCBD3-F3AF-4248-98FF-B03AEB6CAACA}" dt="2025-10-10T15:24:34.837" v="70048" actId="20577"/>
-        <pc:sldMkLst>
-          <pc:docMk/>
-          <pc:sldMk cId="3180984745" sldId="333"/>
-        </pc:sldMkLst>
-      </pc:sldChg>
-      <pc:sldChg chg="modSp mod ord">
-        <pc:chgData name="Casey Lee" userId="4bc459e0-655e-452e-96c2-b918c0999cdb" providerId="ADAL" clId="{FEDCCBD3-F3AF-4248-98FF-B03AEB6CAACA}" dt="2025-10-02T20:28:16.132" v="37985"/>
-        <pc:sldMkLst>
-          <pc:docMk/>
-          <pc:sldMk cId="1946109353" sldId="355"/>
-        </pc:sldMkLst>
-      </pc:sldChg>
-      <pc:sldChg chg="addSp delSp modSp mod ord">
-        <pc:chgData name="Casey Lee" userId="4bc459e0-655e-452e-96c2-b918c0999cdb" providerId="ADAL" clId="{FEDCCBD3-F3AF-4248-98FF-B03AEB6CAACA}" dt="2025-09-29T13:57:09.558" v="11695"/>
-        <pc:sldMkLst>
-          <pc:docMk/>
-          <pc:sldMk cId="2675615646" sldId="419"/>
-        </pc:sldMkLst>
-      </pc:sldChg>
-      <pc:sldChg chg="addSp delSp modSp mod modCm">
-        <pc:chgData name="Casey Lee" userId="4bc459e0-655e-452e-96c2-b918c0999cdb" providerId="ADAL" clId="{FEDCCBD3-F3AF-4248-98FF-B03AEB6CAACA}" dt="2025-10-06T14:20:14.006" v="51184" actId="20577"/>
-        <pc:sldMkLst>
-          <pc:docMk/>
-          <pc:sldMk cId="1299622664" sldId="434"/>
-        </pc:sldMkLst>
-        <pc:extLst>
-          <p:ext xmlns:p="http://schemas.openxmlformats.org/presentationml/2006/main" uri="{D6D511B9-2390-475A-947B-AFAB55BFBCF1}">
-            <pc226:cmChg xmlns:pc226="http://schemas.microsoft.com/office/powerpoint/2022/06/main/command" chg="mod">
-              <pc226:chgData name="Casey Lee" userId="4bc459e0-655e-452e-96c2-b918c0999cdb" providerId="ADAL" clId="{FEDCCBD3-F3AF-4248-98FF-B03AEB6CAACA}" dt="2025-10-06T14:20:14.006" v="51184" actId="20577"/>
-              <pc2:cmMkLst xmlns:pc2="http://schemas.microsoft.com/office/powerpoint/2019/9/main/command">
-                <pc:docMk/>
-                <pc:sldMk cId="1299622664" sldId="434"/>
-                <pc2:cmMk id="{9C52BFDD-9F11-4C01-8EA9-393721749318}"/>
-              </pc2:cmMkLst>
-            </pc226:cmChg>
-          </p:ext>
-        </pc:extLst>
-      </pc:sldChg>
-      <pc:sldChg chg="add del ord">
-        <pc:chgData name="Casey Lee" userId="4bc459e0-655e-452e-96c2-b918c0999cdb" providerId="ADAL" clId="{FEDCCBD3-F3AF-4248-98FF-B03AEB6CAACA}" dt="2025-10-02T15:55:33.977" v="28746"/>
-        <pc:sldMkLst>
-          <pc:docMk/>
-          <pc:sldMk cId="3900277827" sldId="2147478250"/>
-        </pc:sldMkLst>
-      </pc:sldChg>
-      <pc:sldChg chg="add ord">
-        <pc:chgData name="Casey Lee" userId="4bc459e0-655e-452e-96c2-b918c0999cdb" providerId="ADAL" clId="{FEDCCBD3-F3AF-4248-98FF-B03AEB6CAACA}" dt="2025-10-02T15:55:33.977" v="28746"/>
-        <pc:sldMkLst>
-          <pc:docMk/>
-          <pc:sldMk cId="2066716811" sldId="2147478329"/>
-        </pc:sldMkLst>
-      </pc:sldChg>
-      <pc:sldChg chg="add del">
-        <pc:chgData name="Casey Lee" userId="4bc459e0-655e-452e-96c2-b918c0999cdb" providerId="ADAL" clId="{FEDCCBD3-F3AF-4248-98FF-B03AEB6CAACA}" dt="2025-09-19T19:13:18.647" v="2"/>
-        <pc:sldMkLst>
-          <pc:docMk/>
-          <pc:sldMk cId="679476797" sldId="2147480949"/>
-        </pc:sldMkLst>
-      </pc:sldChg>
-      <pc:sldChg chg="addSp delSp modSp add mod ord">
-        <pc:chgData name="Casey Lee" userId="4bc459e0-655e-452e-96c2-b918c0999cdb" providerId="ADAL" clId="{FEDCCBD3-F3AF-4248-98FF-B03AEB6CAACA}" dt="2025-10-07T13:38:34.824" v="59882"/>
-        <pc:sldMkLst>
-          <pc:docMk/>
-          <pc:sldMk cId="2761368814" sldId="2147481181"/>
-        </pc:sldMkLst>
-      </pc:sldChg>
-      <pc:sldChg chg="addSp delSp modSp add del mod">
-        <pc:chgData name="Casey Lee" userId="4bc459e0-655e-452e-96c2-b918c0999cdb" providerId="ADAL" clId="{FEDCCBD3-F3AF-4248-98FF-B03AEB6CAACA}" dt="2025-09-29T14:22:47.094" v="12758" actId="47"/>
-        <pc:sldMkLst>
-          <pc:docMk/>
-          <pc:sldMk cId="3069225704" sldId="2147481199"/>
-        </pc:sldMkLst>
-      </pc:sldChg>
-      <pc:sldChg chg="modSp add del mod">
-        <pc:chgData name="Casey Lee" userId="4bc459e0-655e-452e-96c2-b918c0999cdb" providerId="ADAL" clId="{FEDCCBD3-F3AF-4248-98FF-B03AEB6CAACA}" dt="2025-10-03T15:18:34.054" v="43364" actId="47"/>
-        <pc:sldMkLst>
-          <pc:docMk/>
-          <pc:sldMk cId="2500079299" sldId="2147481200"/>
-        </pc:sldMkLst>
-      </pc:sldChg>
-      <pc:sldChg chg="modSp add mod ord modCm">
-        <pc:chgData name="Casey Lee" userId="4bc459e0-655e-452e-96c2-b918c0999cdb" providerId="ADAL" clId="{FEDCCBD3-F3AF-4248-98FF-B03AEB6CAACA}" dt="2025-10-10T21:45:55.195" v="70049" actId="13926"/>
-        <pc:sldMkLst>
-          <pc:docMk/>
-          <pc:sldMk cId="829862625" sldId="2147481206"/>
-        </pc:sldMkLst>
-        <pc:extLst>
-          <p:ext xmlns:p="http://schemas.openxmlformats.org/presentationml/2006/main" uri="{D6D511B9-2390-475A-947B-AFAB55BFBCF1}">
-            <pc226:cmChg xmlns:pc226="http://schemas.microsoft.com/office/powerpoint/2022/06/main/command" chg="mod">
-              <pc226:chgData name="Casey Lee" userId="4bc459e0-655e-452e-96c2-b918c0999cdb" providerId="ADAL" clId="{FEDCCBD3-F3AF-4248-98FF-B03AEB6CAACA}" dt="2025-10-08T14:25:52.778" v="68521" actId="20577"/>
-              <pc2:cmMkLst xmlns:pc2="http://schemas.microsoft.com/office/powerpoint/2019/9/main/command">
-                <pc:docMk/>
-                <pc:sldMk cId="829862625" sldId="2147481206"/>
-                <pc2:cmMk id="{8C1768B5-F339-4F29-B263-E3C0B5FBF0A5}"/>
-              </pc2:cmMkLst>
-            </pc226:cmChg>
-          </p:ext>
-        </pc:extLst>
-      </pc:sldChg>
-      <pc:sldChg chg="addSp modSp mod ord">
-        <pc:chgData name="Casey Lee" userId="4bc459e0-655e-452e-96c2-b918c0999cdb" providerId="ADAL" clId="{FEDCCBD3-F3AF-4248-98FF-B03AEB6CAACA}" dt="2025-09-26T16:40:01.486" v="4856"/>
-        <pc:sldMkLst>
-          <pc:docMk/>
-          <pc:sldMk cId="2128657008" sldId="2147481209"/>
-        </pc:sldMkLst>
-      </pc:sldChg>
-      <pc:sldChg chg="addSp delSp modSp mod">
-        <pc:chgData name="Casey Lee" userId="4bc459e0-655e-452e-96c2-b918c0999cdb" providerId="ADAL" clId="{FEDCCBD3-F3AF-4248-98FF-B03AEB6CAACA}" dt="2025-09-19T20:25:41.897" v="1420" actId="20577"/>
-        <pc:sldMkLst>
-          <pc:docMk/>
-          <pc:sldMk cId="1105021549" sldId="2147481210"/>
-        </pc:sldMkLst>
-      </pc:sldChg>
-      <pc:sldChg chg="addSp delSp modSp mod modCm">
-        <pc:chgData name="Casey Lee" userId="4bc459e0-655e-452e-96c2-b918c0999cdb" providerId="ADAL" clId="{FEDCCBD3-F3AF-4248-98FF-B03AEB6CAACA}" dt="2025-10-02T17:39:03.548" v="33313" actId="20577"/>
-        <pc:sldMkLst>
-          <pc:docMk/>
-          <pc:sldMk cId="323746144" sldId="2147481211"/>
-        </pc:sldMkLst>
-        <pc:extLst>
-          <p:ext xmlns:p="http://schemas.openxmlformats.org/presentationml/2006/main" uri="{D6D511B9-2390-475A-947B-AFAB55BFBCF1}">
-            <pc226:cmChg xmlns:pc226="http://schemas.microsoft.com/office/powerpoint/2022/06/main/command" chg="mod">
-              <pc226:chgData name="Casey Lee" userId="4bc459e0-655e-452e-96c2-b918c0999cdb" providerId="ADAL" clId="{FEDCCBD3-F3AF-4248-98FF-B03AEB6CAACA}" dt="2025-10-02T17:39:03.548" v="33313" actId="20577"/>
-              <pc2:cmMkLst xmlns:pc2="http://schemas.microsoft.com/office/powerpoint/2019/9/main/command">
-                <pc:docMk/>
-                <pc:sldMk cId="323746144" sldId="2147481211"/>
-                <pc2:cmMk id="{39EB2F37-B8FD-49D1-A4FF-14B267B24A40}"/>
-              </pc2:cmMkLst>
-            </pc226:cmChg>
-          </p:ext>
-        </pc:extLst>
-      </pc:sldChg>
-      <pc:sldChg chg="addSp delSp modSp mod ord">
-        <pc:chgData name="Casey Lee" userId="4bc459e0-655e-452e-96c2-b918c0999cdb" providerId="ADAL" clId="{FEDCCBD3-F3AF-4248-98FF-B03AEB6CAACA}" dt="2025-10-07T16:36:18.841" v="65435" actId="1076"/>
-        <pc:sldMkLst>
-          <pc:docMk/>
-          <pc:sldMk cId="83366420" sldId="2147481212"/>
-        </pc:sldMkLst>
-      </pc:sldChg>
-      <pc:sldChg chg="addSp delSp modSp mod">
-        <pc:chgData name="Casey Lee" userId="4bc459e0-655e-452e-96c2-b918c0999cdb" providerId="ADAL" clId="{FEDCCBD3-F3AF-4248-98FF-B03AEB6CAACA}" dt="2025-10-06T14:44:31.164" v="51234" actId="20577"/>
-        <pc:sldMkLst>
-          <pc:docMk/>
-          <pc:sldMk cId="1270242671" sldId="2147481213"/>
-        </pc:sldMkLst>
-        <pc:spChg chg="mod">
-          <ac:chgData name="Casey Lee" userId="4bc459e0-655e-452e-96c2-b918c0999cdb" providerId="ADAL" clId="{FEDCCBD3-F3AF-4248-98FF-B03AEB6CAACA}" dt="2025-10-06T14:44:31.164" v="51234" actId="20577"/>
-          <ac:spMkLst>
-            <pc:docMk/>
-            <pc:sldMk cId="1270242671" sldId="2147481213"/>
-            <ac:spMk id="4" creationId="{F93D6D7D-FF3F-82F6-14A4-6285C0323998}"/>
-          </ac:spMkLst>
-        </pc:spChg>
-        <pc:graphicFrameChg chg="mod modGraphic">
-          <ac:chgData name="Casey Lee" userId="4bc459e0-655e-452e-96c2-b918c0999cdb" providerId="ADAL" clId="{FEDCCBD3-F3AF-4248-98FF-B03AEB6CAACA}" dt="2025-10-03T18:57:42.221" v="46337" actId="1076"/>
-          <ac:graphicFrameMkLst>
-            <pc:docMk/>
-            <pc:sldMk cId="1270242671" sldId="2147481213"/>
-            <ac:graphicFrameMk id="2" creationId="{38F22EE9-DEDC-E1DA-1E19-E1758E9C192D}"/>
-          </ac:graphicFrameMkLst>
-        </pc:graphicFrameChg>
-      </pc:sldChg>
-      <pc:sldChg chg="addSp delSp modSp mod">
-        <pc:chgData name="Casey Lee" userId="4bc459e0-655e-452e-96c2-b918c0999cdb" providerId="ADAL" clId="{FEDCCBD3-F3AF-4248-98FF-B03AEB6CAACA}" dt="2025-10-08T14:48:01.931" v="68667" actId="403"/>
-        <pc:sldMkLst>
-          <pc:docMk/>
-          <pc:sldMk cId="1389874235" sldId="2147481214"/>
-        </pc:sldMkLst>
-      </pc:sldChg>
-      <pc:sldChg chg="del">
-        <pc:chgData name="Casey Lee" userId="4bc459e0-655e-452e-96c2-b918c0999cdb" providerId="ADAL" clId="{FEDCCBD3-F3AF-4248-98FF-B03AEB6CAACA}" dt="2025-10-08T12:51:36.953" v="68169" actId="47"/>
-        <pc:sldMkLst>
-          <pc:docMk/>
-          <pc:sldMk cId="300876207" sldId="2147481215"/>
-        </pc:sldMkLst>
-      </pc:sldChg>
-      <pc:sldChg chg="addSp delSp modSp mod ord">
-        <pc:chgData name="Casey Lee" userId="4bc459e0-655e-452e-96c2-b918c0999cdb" providerId="ADAL" clId="{FEDCCBD3-F3AF-4248-98FF-B03AEB6CAACA}" dt="2025-09-26T16:40:01.486" v="4856"/>
-        <pc:sldMkLst>
-          <pc:docMk/>
-          <pc:sldMk cId="145336846" sldId="2147481218"/>
-        </pc:sldMkLst>
-      </pc:sldChg>
-      <pc:sldChg chg="addSp delSp modSp add mod">
-        <pc:chgData name="Casey Lee" userId="4bc459e0-655e-452e-96c2-b918c0999cdb" providerId="ADAL" clId="{FEDCCBD3-F3AF-4248-98FF-B03AEB6CAACA}" dt="2025-10-06T14:20:01.304" v="51183" actId="6549"/>
-        <pc:sldMkLst>
-          <pc:docMk/>
-          <pc:sldMk cId="3892756515" sldId="2147481219"/>
-        </pc:sldMkLst>
-      </pc:sldChg>
-      <pc:sldChg chg="modSp mod ord modShow">
-        <pc:chgData name="Casey Lee" userId="4bc459e0-655e-452e-96c2-b918c0999cdb" providerId="ADAL" clId="{FEDCCBD3-F3AF-4248-98FF-B03AEB6CAACA}" dt="2025-09-30T17:31:46.536" v="22108" actId="729"/>
-        <pc:sldMkLst>
-          <pc:docMk/>
-          <pc:sldMk cId="2449955966" sldId="2147481220"/>
-        </pc:sldMkLst>
-      </pc:sldChg>
-      <pc:sldChg chg="modSp mod ord modShow">
-        <pc:chgData name="Casey Lee" userId="4bc459e0-655e-452e-96c2-b918c0999cdb" providerId="ADAL" clId="{FEDCCBD3-F3AF-4248-98FF-B03AEB6CAACA}" dt="2025-09-30T17:31:46.536" v="22108" actId="729"/>
-        <pc:sldMkLst>
-          <pc:docMk/>
-          <pc:sldMk cId="3753532281" sldId="2147481221"/>
-        </pc:sldMkLst>
-      </pc:sldChg>
-      <pc:sldChg chg="addSp delSp modSp mod ord modCm">
-        <pc:chgData name="Casey Lee" userId="4bc459e0-655e-452e-96c2-b918c0999cdb" providerId="ADAL" clId="{FEDCCBD3-F3AF-4248-98FF-B03AEB6CAACA}" dt="2025-10-02T17:57:31.753" v="34405" actId="255"/>
-        <pc:sldMkLst>
-          <pc:docMk/>
-          <pc:sldMk cId="1157813500" sldId="2147481222"/>
-        </pc:sldMkLst>
-        <pc:extLst>
-          <p:ext xmlns:p="http://schemas.openxmlformats.org/presentationml/2006/main" uri="{D6D511B9-2390-475A-947B-AFAB55BFBCF1}">
-            <pc226:cmChg xmlns:pc226="http://schemas.microsoft.com/office/powerpoint/2022/06/main/command" chg="mod">
-              <pc226:chgData name="Casey Lee" userId="4bc459e0-655e-452e-96c2-b918c0999cdb" providerId="ADAL" clId="{FEDCCBD3-F3AF-4248-98FF-B03AEB6CAACA}" dt="2025-10-02T17:15:03.050" v="32088" actId="20577"/>
-              <pc2:cmMkLst xmlns:pc2="http://schemas.microsoft.com/office/powerpoint/2019/9/main/command">
-                <pc:docMk/>
-                <pc:sldMk cId="1157813500" sldId="2147481222"/>
-                <pc2:cmMk id="{0E9EAFC1-53E0-4A88-9A39-BCE44D7D16F2}"/>
-              </pc2:cmMkLst>
-            </pc226:cmChg>
-          </p:ext>
-        </pc:extLst>
-      </pc:sldChg>
-      <pc:sldChg chg="addSp delSp modSp mod ord">
-        <pc:chgData name="Casey Lee" userId="4bc459e0-655e-452e-96c2-b918c0999cdb" providerId="ADAL" clId="{FEDCCBD3-F3AF-4248-98FF-B03AEB6CAACA}" dt="2025-10-07T14:31:19.673" v="63115"/>
-        <pc:sldMkLst>
-          <pc:docMk/>
-          <pc:sldMk cId="4242413873" sldId="2147481223"/>
-        </pc:sldMkLst>
-      </pc:sldChg>
-      <pc:sldChg chg="ord">
-        <pc:chgData name="Casey Lee" userId="4bc459e0-655e-452e-96c2-b918c0999cdb" providerId="ADAL" clId="{FEDCCBD3-F3AF-4248-98FF-B03AEB6CAACA}" dt="2025-09-30T16:46:42.429" v="21626"/>
-        <pc:sldMkLst>
-          <pc:docMk/>
-          <pc:sldMk cId="3621352377" sldId="2147481224"/>
-        </pc:sldMkLst>
-      </pc:sldChg>
-      <pc:sldChg chg="modSp mod ord">
-        <pc:chgData name="Casey Lee" userId="4bc459e0-655e-452e-96c2-b918c0999cdb" providerId="ADAL" clId="{FEDCCBD3-F3AF-4248-98FF-B03AEB6CAACA}" dt="2025-09-30T16:46:16.686" v="21623"/>
-        <pc:sldMkLst>
-          <pc:docMk/>
-          <pc:sldMk cId="1394883244" sldId="2147481226"/>
-        </pc:sldMkLst>
-      </pc:sldChg>
-      <pc:sldChg chg="addSp delSp modSp mod modCm modNotesTx">
-        <pc:chgData name="Casey Lee" userId="4bc459e0-655e-452e-96c2-b918c0999cdb" providerId="ADAL" clId="{FEDCCBD3-F3AF-4248-98FF-B03AEB6CAACA}" dt="2025-10-01T20:42:30.379" v="26286" actId="14100"/>
-        <pc:sldMkLst>
-          <pc:docMk/>
-          <pc:sldMk cId="2560992972" sldId="2147481227"/>
-        </pc:sldMkLst>
-        <pc:extLst>
-          <p:ext xmlns:p="http://schemas.openxmlformats.org/presentationml/2006/main" uri="{D6D511B9-2390-475A-947B-AFAB55BFBCF1}">
-            <pc226:cmChg xmlns:pc226="http://schemas.microsoft.com/office/powerpoint/2022/06/main/command" chg="mod">
-              <pc226:chgData name="Casey Lee" userId="4bc459e0-655e-452e-96c2-b918c0999cdb" providerId="ADAL" clId="{FEDCCBD3-F3AF-4248-98FF-B03AEB6CAACA}" dt="2025-10-01T20:02:15.709" v="25719" actId="20577"/>
-              <pc2:cmMkLst xmlns:pc2="http://schemas.microsoft.com/office/powerpoint/2019/9/main/command">
-                <pc:docMk/>
-                <pc:sldMk cId="2560992972" sldId="2147481227"/>
-                <pc2:cmMk id="{72D62EF9-F7A0-4789-9637-4F84044DA606}"/>
-              </pc2:cmMkLst>
-            </pc226:cmChg>
-          </p:ext>
-        </pc:extLst>
-      </pc:sldChg>
-      <pc:sldChg chg="addSp delSp modSp mod modNotesTx">
-        <pc:chgData name="Casey Lee" userId="4bc459e0-655e-452e-96c2-b918c0999cdb" providerId="ADAL" clId="{FEDCCBD3-F3AF-4248-98FF-B03AEB6CAACA}" dt="2025-10-01T20:41:18.187" v="26285" actId="478"/>
-        <pc:sldMkLst>
-          <pc:docMk/>
-          <pc:sldMk cId="427855662" sldId="2147481228"/>
-        </pc:sldMkLst>
-      </pc:sldChg>
-      <pc:sldChg chg="addSp delSp modSp add mod ord">
-        <pc:chgData name="Casey Lee" userId="4bc459e0-655e-452e-96c2-b918c0999cdb" providerId="ADAL" clId="{FEDCCBD3-F3AF-4248-98FF-B03AEB6CAACA}" dt="2025-10-07T14:04:08.712" v="61012" actId="1076"/>
-        <pc:sldMkLst>
-          <pc:docMk/>
-          <pc:sldMk cId="1426298556" sldId="2147481229"/>
-        </pc:sldMkLst>
-      </pc:sldChg>
-      <pc:sldChg chg="addSp delSp modSp add mod modNotesTx">
-        <pc:chgData name="Casey Lee" userId="4bc459e0-655e-452e-96c2-b918c0999cdb" providerId="ADAL" clId="{FEDCCBD3-F3AF-4248-98FF-B03AEB6CAACA}" dt="2025-10-02T20:01:31.975" v="37715" actId="255"/>
-        <pc:sldMkLst>
-          <pc:docMk/>
-          <pc:sldMk cId="3134119948" sldId="2147481230"/>
-        </pc:sldMkLst>
-      </pc:sldChg>
-      <pc:sldChg chg="addSp delSp modSp add mod">
-        <pc:chgData name="Casey Lee" userId="4bc459e0-655e-452e-96c2-b918c0999cdb" providerId="ADAL" clId="{FEDCCBD3-F3AF-4248-98FF-B03AEB6CAACA}" dt="2025-10-01T18:56:40.945" v="24342" actId="20577"/>
-        <pc:sldMkLst>
-          <pc:docMk/>
-          <pc:sldMk cId="1129204174" sldId="2147481231"/>
-        </pc:sldMkLst>
-      </pc:sldChg>
-      <pc:sldChg chg="modSp add mod ord">
-        <pc:chgData name="Casey Lee" userId="4bc459e0-655e-452e-96c2-b918c0999cdb" providerId="ADAL" clId="{FEDCCBD3-F3AF-4248-98FF-B03AEB6CAACA}" dt="2025-10-03T20:38:46.309" v="48204" actId="1076"/>
-        <pc:sldMkLst>
-          <pc:docMk/>
-          <pc:sldMk cId="1893241687" sldId="2147481232"/>
-        </pc:sldMkLst>
-      </pc:sldChg>
-      <pc:sldChg chg="add del">
-        <pc:chgData name="Casey Lee" userId="4bc459e0-655e-452e-96c2-b918c0999cdb" providerId="ADAL" clId="{FEDCCBD3-F3AF-4248-98FF-B03AEB6CAACA}" dt="2025-09-29T14:08:50.206" v="12280"/>
-        <pc:sldMkLst>
-          <pc:docMk/>
-          <pc:sldMk cId="1370004904" sldId="2147481234"/>
-        </pc:sldMkLst>
-      </pc:sldChg>
-      <pc:sldChg chg="addSp delSp modSp add del mod">
-        <pc:chgData name="Casey Lee" userId="4bc459e0-655e-452e-96c2-b918c0999cdb" providerId="ADAL" clId="{FEDCCBD3-F3AF-4248-98FF-B03AEB6CAACA}" dt="2025-10-03T14:53:21.106" v="42144" actId="47"/>
-        <pc:sldMkLst>
-          <pc:docMk/>
-          <pc:sldMk cId="3872972120" sldId="2147481234"/>
-        </pc:sldMkLst>
-      </pc:sldChg>
-      <pc:sldChg chg="addSp delSp modSp add del mod">
-        <pc:chgData name="Casey Lee" userId="4bc459e0-655e-452e-96c2-b918c0999cdb" providerId="ADAL" clId="{FEDCCBD3-F3AF-4248-98FF-B03AEB6CAACA}" dt="2025-10-03T13:59:31.111" v="41556" actId="47"/>
-        <pc:sldMkLst>
-          <pc:docMk/>
-          <pc:sldMk cId="2664751740" sldId="2147481235"/>
-        </pc:sldMkLst>
-      </pc:sldChg>
-      <pc:sldChg chg="addSp delSp modSp add mod modShow">
-        <pc:chgData name="Casey Lee" userId="4bc459e0-655e-452e-96c2-b918c0999cdb" providerId="ADAL" clId="{FEDCCBD3-F3AF-4248-98FF-B03AEB6CAACA}" dt="2025-10-03T15:58:41.245" v="44921" actId="14100"/>
-        <pc:sldMkLst>
-          <pc:docMk/>
-          <pc:sldMk cId="1567322584" sldId="2147481236"/>
-        </pc:sldMkLst>
-      </pc:sldChg>
-      <pc:sldChg chg="addSp delSp modSp add mod ord">
-        <pc:chgData name="Casey Lee" userId="4bc459e0-655e-452e-96c2-b918c0999cdb" providerId="ADAL" clId="{FEDCCBD3-F3AF-4248-98FF-B03AEB6CAACA}" dt="2025-10-02T05:31:02.461" v="27783" actId="27918"/>
-        <pc:sldMkLst>
-          <pc:docMk/>
-          <pc:sldMk cId="229596941" sldId="2147481237"/>
-        </pc:sldMkLst>
-      </pc:sldChg>
-      <pc:sldChg chg="addSp delSp modSp add del mod ord">
-        <pc:chgData name="Casey Lee" userId="4bc459e0-655e-452e-96c2-b918c0999cdb" providerId="ADAL" clId="{FEDCCBD3-F3AF-4248-98FF-B03AEB6CAACA}" dt="2025-10-02T05:31:02.417" v="27779" actId="27918"/>
-        <pc:sldMkLst>
-          <pc:docMk/>
-          <pc:sldMk cId="821359188" sldId="2147481238"/>
-        </pc:sldMkLst>
-      </pc:sldChg>
-      <pc:sldChg chg="addSp delSp modSp add mod ord">
-        <pc:chgData name="Casey Lee" userId="4bc459e0-655e-452e-96c2-b918c0999cdb" providerId="ADAL" clId="{FEDCCBD3-F3AF-4248-98FF-B03AEB6CAACA}" dt="2025-10-02T05:31:02.436" v="27781" actId="27918"/>
-        <pc:sldMkLst>
-          <pc:docMk/>
-          <pc:sldMk cId="1694054532" sldId="2147481239"/>
-        </pc:sldMkLst>
-      </pc:sldChg>
-      <pc:sldChg chg="addSp delSp modSp add mod ord">
-        <pc:chgData name="Casey Lee" userId="4bc459e0-655e-452e-96c2-b918c0999cdb" providerId="ADAL" clId="{FEDCCBD3-F3AF-4248-98FF-B03AEB6CAACA}" dt="2025-10-02T05:31:02.449" v="27782" actId="27918"/>
-        <pc:sldMkLst>
-          <pc:docMk/>
-          <pc:sldMk cId="3378682446" sldId="2147481240"/>
-        </pc:sldMkLst>
-      </pc:sldChg>
-      <pc:sldChg chg="addSp delSp modSp add mod">
-        <pc:chgData name="Casey Lee" userId="4bc459e0-655e-452e-96c2-b918c0999cdb" providerId="ADAL" clId="{FEDCCBD3-F3AF-4248-98FF-B03AEB6CAACA}" dt="2025-09-30T20:55:46.946" v="23942" actId="20577"/>
-        <pc:sldMkLst>
-          <pc:docMk/>
-          <pc:sldMk cId="3130016136" sldId="2147481241"/>
-        </pc:sldMkLst>
-      </pc:sldChg>
-      <pc:sldChg chg="add ord">
-        <pc:chgData name="Casey Lee" userId="4bc459e0-655e-452e-96c2-b918c0999cdb" providerId="ADAL" clId="{FEDCCBD3-F3AF-4248-98FF-B03AEB6CAACA}" dt="2025-09-30T14:41:11.888" v="19035"/>
-        <pc:sldMkLst>
-          <pc:docMk/>
-          <pc:sldMk cId="3652664627" sldId="2147481242"/>
-        </pc:sldMkLst>
-      </pc:sldChg>
-      <pc:sldChg chg="addSp delSp modSp add mod ord">
-        <pc:chgData name="Casey Lee" userId="4bc459e0-655e-452e-96c2-b918c0999cdb" providerId="ADAL" clId="{FEDCCBD3-F3AF-4248-98FF-B03AEB6CAACA}" dt="2025-10-06T14:26:54.755" v="51186" actId="20577"/>
-        <pc:sldMkLst>
-          <pc:docMk/>
-          <pc:sldMk cId="3576209394" sldId="2147481243"/>
-        </pc:sldMkLst>
-      </pc:sldChg>
-      <pc:sldChg chg="addSp delSp modSp add mod ord">
-        <pc:chgData name="Casey Lee" userId="4bc459e0-655e-452e-96c2-b918c0999cdb" providerId="ADAL" clId="{FEDCCBD3-F3AF-4248-98FF-B03AEB6CAACA}" dt="2025-10-09T14:30:09.411" v="70035" actId="20577"/>
-        <pc:sldMkLst>
-          <pc:docMk/>
-          <pc:sldMk cId="2460346233" sldId="2147481244"/>
-        </pc:sldMkLst>
-      </pc:sldChg>
-      <pc:sldChg chg="delSp add del mod">
-        <pc:chgData name="Casey Lee" userId="4bc459e0-655e-452e-96c2-b918c0999cdb" providerId="ADAL" clId="{FEDCCBD3-F3AF-4248-98FF-B03AEB6CAACA}" dt="2025-09-30T16:46:21.643" v="21624" actId="47"/>
-        <pc:sldMkLst>
-          <pc:docMk/>
-          <pc:sldMk cId="3652261605" sldId="2147481244"/>
-        </pc:sldMkLst>
-      </pc:sldChg>
-      <pc:sldChg chg="addSp delSp modSp del mod">
-        <pc:chgData name="Casey Lee" userId="4bc459e0-655e-452e-96c2-b918c0999cdb" providerId="ADAL" clId="{FEDCCBD3-F3AF-4248-98FF-B03AEB6CAACA}" dt="2025-10-03T19:07:17.692" v="46513" actId="47"/>
-        <pc:sldMkLst>
-          <pc:docMk/>
-          <pc:sldMk cId="3253257184" sldId="2147481245"/>
-        </pc:sldMkLst>
-      </pc:sldChg>
-      <pc:sldChg chg="addSp delSp modSp del mod ord">
-        <pc:chgData name="Casey Lee" userId="4bc459e0-655e-452e-96c2-b918c0999cdb" providerId="ADAL" clId="{FEDCCBD3-F3AF-4248-98FF-B03AEB6CAACA}" dt="2025-10-02T20:57:45.174" v="38909" actId="47"/>
-        <pc:sldMkLst>
-          <pc:docMk/>
-          <pc:sldMk cId="3132776874" sldId="2147481246"/>
-        </pc:sldMkLst>
-      </pc:sldChg>
-      <pc:sldChg chg="modSp mod">
-        <pc:chgData name="Casey Lee" userId="4bc459e0-655e-452e-96c2-b918c0999cdb" providerId="ADAL" clId="{FEDCCBD3-F3AF-4248-98FF-B03AEB6CAACA}" dt="2025-10-09T14:29:41.840" v="70033" actId="20577"/>
-        <pc:sldMkLst>
-          <pc:docMk/>
-          <pc:sldMk cId="2852939510" sldId="2147481248"/>
-        </pc:sldMkLst>
-      </pc:sldChg>
-      <pc:sldChg chg="add ord">
-        <pc:chgData name="Casey Lee" userId="4bc459e0-655e-452e-96c2-b918c0999cdb" providerId="ADAL" clId="{FEDCCBD3-F3AF-4248-98FF-B03AEB6CAACA}" dt="2025-10-01T19:21:14.031" v="24345"/>
-        <pc:sldMkLst>
-          <pc:docMk/>
-          <pc:sldMk cId="2363090598" sldId="2147481251"/>
-        </pc:sldMkLst>
-      </pc:sldChg>
-      <pc:sldChg chg="add ord">
-        <pc:chgData name="Casey Lee" userId="4bc459e0-655e-452e-96c2-b918c0999cdb" providerId="ADAL" clId="{FEDCCBD3-F3AF-4248-98FF-B03AEB6CAACA}" dt="2025-10-01T19:25:21.977" v="24350"/>
-        <pc:sldMkLst>
-          <pc:docMk/>
-          <pc:sldMk cId="2326761967" sldId="2147481252"/>
-        </pc:sldMkLst>
-      </pc:sldChg>
-      <pc:sldChg chg="addSp delSp modSp add mod ord">
-        <pc:chgData name="Casey Lee" userId="4bc459e0-655e-452e-96c2-b918c0999cdb" providerId="ADAL" clId="{FEDCCBD3-F3AF-4248-98FF-B03AEB6CAACA}" dt="2025-10-02T05:31:02.401" v="27778" actId="27918"/>
-        <pc:sldMkLst>
-          <pc:docMk/>
-          <pc:sldMk cId="3718838375" sldId="2147481253"/>
-        </pc:sldMkLst>
-      </pc:sldChg>
-      <pc:sldChg chg="add del">
-        <pc:chgData name="Casey Lee" userId="4bc459e0-655e-452e-96c2-b918c0999cdb" providerId="ADAL" clId="{FEDCCBD3-F3AF-4248-98FF-B03AEB6CAACA}" dt="2025-10-01T20:10:26.540" v="26275" actId="47"/>
-        <pc:sldMkLst>
-          <pc:docMk/>
-          <pc:sldMk cId="3798332572" sldId="2147481253"/>
-        </pc:sldMkLst>
-      </pc:sldChg>
-      <pc:sldChg chg="add mod ord modShow">
-        <pc:chgData name="Casey Lee" userId="4bc459e0-655e-452e-96c2-b918c0999cdb" providerId="ADAL" clId="{FEDCCBD3-F3AF-4248-98FF-B03AEB6CAACA}" dt="2025-10-02T20:28:16.132" v="37985"/>
-        <pc:sldMkLst>
-          <pc:docMk/>
-          <pc:sldMk cId="2060710732" sldId="2147481254"/>
-        </pc:sldMkLst>
-      </pc:sldChg>
-      <pc:sldChg chg="addSp delSp modSp mod modShow">
-        <pc:chgData name="Casey Lee" userId="4bc459e0-655e-452e-96c2-b918c0999cdb" providerId="ADAL" clId="{FEDCCBD3-F3AF-4248-98FF-B03AEB6CAACA}" dt="2025-10-08T20:39:16.692" v="70028" actId="122"/>
-        <pc:sldMkLst>
-          <pc:docMk/>
-          <pc:sldMk cId="988488" sldId="2147481255"/>
-        </pc:sldMkLst>
-      </pc:sldChg>
-      <pc:sldChg chg="addSp delSp modSp add del mod">
-        <pc:chgData name="Casey Lee" userId="4bc459e0-655e-452e-96c2-b918c0999cdb" providerId="ADAL" clId="{FEDCCBD3-F3AF-4248-98FF-B03AEB6CAACA}" dt="2025-10-02T18:03:09.206" v="34600" actId="47"/>
-        <pc:sldMkLst>
-          <pc:docMk/>
-          <pc:sldMk cId="527820914" sldId="2147481255"/>
-        </pc:sldMkLst>
-      </pc:sldChg>
-      <pc:sldChg chg="addSp delSp modSp add del mod">
-        <pc:chgData name="Casey Lee" userId="4bc459e0-655e-452e-96c2-b918c0999cdb" providerId="ADAL" clId="{FEDCCBD3-F3AF-4248-98FF-B03AEB6CAACA}" dt="2025-10-02T16:43:43.045" v="30085" actId="47"/>
-        <pc:sldMkLst>
-          <pc:docMk/>
-          <pc:sldMk cId="2989387375" sldId="2147481255"/>
-        </pc:sldMkLst>
-      </pc:sldChg>
-      <pc:sldChg chg="new del">
-        <pc:chgData name="Casey Lee" userId="4bc459e0-655e-452e-96c2-b918c0999cdb" providerId="ADAL" clId="{FEDCCBD3-F3AF-4248-98FF-B03AEB6CAACA}" dt="2025-10-02T17:30:01.770" v="32414" actId="47"/>
-        <pc:sldMkLst>
-          <pc:docMk/>
-          <pc:sldMk cId="3199761401" sldId="2147481255"/>
-        </pc:sldMkLst>
-      </pc:sldChg>
-      <pc:sldChg chg="delSp modSp add del mod">
-        <pc:chgData name="Casey Lee" userId="4bc459e0-655e-452e-96c2-b918c0999cdb" providerId="ADAL" clId="{FEDCCBD3-F3AF-4248-98FF-B03AEB6CAACA}" dt="2025-10-03T19:53:41.930" v="47704" actId="47"/>
-        <pc:sldMkLst>
-          <pc:docMk/>
-          <pc:sldMk cId="2390622337" sldId="2147481256"/>
-        </pc:sldMkLst>
-      </pc:sldChg>
-      <pc:sldChg chg="modSp mod">
-        <pc:chgData name="Casey Lee" userId="4bc459e0-655e-452e-96c2-b918c0999cdb" providerId="ADAL" clId="{FEDCCBD3-F3AF-4248-98FF-B03AEB6CAACA}" dt="2025-10-03T20:39:14.325" v="48212" actId="20577"/>
-        <pc:sldMkLst>
-          <pc:docMk/>
-          <pc:sldMk cId="2682905776" sldId="2147481257"/>
-        </pc:sldMkLst>
-      </pc:sldChg>
-      <pc:sldChg chg="modSp mod">
-        <pc:chgData name="Casey Lee" userId="4bc459e0-655e-452e-96c2-b918c0999cdb" providerId="ADAL" clId="{FEDCCBD3-F3AF-4248-98FF-B03AEB6CAACA}" dt="2025-10-03T20:39:56.594" v="48220" actId="20577"/>
-        <pc:sldMkLst>
-          <pc:docMk/>
-          <pc:sldMk cId="2763871" sldId="2147481258"/>
-        </pc:sldMkLst>
-      </pc:sldChg>
-      <pc:sldChg chg="addSp delSp modSp add mod">
-        <pc:chgData name="Casey Lee" userId="4bc459e0-655e-452e-96c2-b918c0999cdb" providerId="ADAL" clId="{FEDCCBD3-F3AF-4248-98FF-B03AEB6CAACA}" dt="2025-10-03T15:31:53.386" v="43638" actId="1076"/>
-        <pc:sldMkLst>
-          <pc:docMk/>
-          <pc:sldMk cId="2295337202" sldId="2147481259"/>
-        </pc:sldMkLst>
-      </pc:sldChg>
-      <pc:sldChg chg="addSp delSp modSp add mod">
-        <pc:chgData name="Casey Lee" userId="4bc459e0-655e-452e-96c2-b918c0999cdb" providerId="ADAL" clId="{FEDCCBD3-F3AF-4248-98FF-B03AEB6CAACA}" dt="2025-10-06T14:42:44.314" v="51204" actId="20577"/>
-        <pc:sldMkLst>
-          <pc:docMk/>
-          <pc:sldMk cId="2022463905" sldId="2147481260"/>
-        </pc:sldMkLst>
-      </pc:sldChg>
-      <pc:sldChg chg="addSp delSp modSp add mod">
-        <pc:chgData name="Casey Lee" userId="4bc459e0-655e-452e-96c2-b918c0999cdb" providerId="ADAL" clId="{FEDCCBD3-F3AF-4248-98FF-B03AEB6CAACA}" dt="2025-10-17T17:36:01.193" v="70061" actId="21"/>
-        <pc:sldMkLst>
-          <pc:docMk/>
-          <pc:sldMk cId="648698299" sldId="2147481261"/>
-        </pc:sldMkLst>
-      </pc:sldChg>
-      <pc:sldChg chg="modSp mod">
-        <pc:chgData name="Casey Lee" userId="4bc459e0-655e-452e-96c2-b918c0999cdb" providerId="ADAL" clId="{FEDCCBD3-F3AF-4248-98FF-B03AEB6CAACA}" dt="2025-10-03T19:00:55.817" v="46428" actId="207"/>
-        <pc:sldMkLst>
-          <pc:docMk/>
-          <pc:sldMk cId="4145473322" sldId="2147481262"/>
-        </pc:sldMkLst>
-      </pc:sldChg>
-      <pc:sldChg chg="addSp delSp modSp add mod ord">
-        <pc:chgData name="Casey Lee" userId="4bc459e0-655e-452e-96c2-b918c0999cdb" providerId="ADAL" clId="{FEDCCBD3-F3AF-4248-98FF-B03AEB6CAACA}" dt="2025-10-07T20:07:50.220" v="65922"/>
-        <pc:sldMkLst>
-          <pc:docMk/>
-          <pc:sldMk cId="756745785" sldId="2147481263"/>
-        </pc:sldMkLst>
-      </pc:sldChg>
-      <pc:sldChg chg="modSp mod">
-        <pc:chgData name="Casey Lee" userId="4bc459e0-655e-452e-96c2-b918c0999cdb" providerId="ADAL" clId="{FEDCCBD3-F3AF-4248-98FF-B03AEB6CAACA}" dt="2025-10-06T14:43:21.408" v="51208" actId="20577"/>
-        <pc:sldMkLst>
-          <pc:docMk/>
-          <pc:sldMk cId="345488764" sldId="2147481264"/>
-        </pc:sldMkLst>
-      </pc:sldChg>
-      <pc:sldChg chg="add del">
-        <pc:chgData name="Casey Lee" userId="4bc459e0-655e-452e-96c2-b918c0999cdb" providerId="ADAL" clId="{FEDCCBD3-F3AF-4248-98FF-B03AEB6CAACA}" dt="2025-10-03T18:56:44.257" v="46243" actId="47"/>
-        <pc:sldMkLst>
-          <pc:docMk/>
-          <pc:sldMk cId="1533153485" sldId="2147481265"/>
-        </pc:sldMkLst>
-      </pc:sldChg>
-      <pc:sldChg chg="modSp add mod">
-        <pc:chgData name="Casey Lee" userId="4bc459e0-655e-452e-96c2-b918c0999cdb" providerId="ADAL" clId="{FEDCCBD3-F3AF-4248-98FF-B03AEB6CAACA}" dt="2025-10-03T19:29:54.444" v="46737" actId="20577"/>
-        <pc:sldMkLst>
-          <pc:docMk/>
-          <pc:sldMk cId="2503961039" sldId="2147481265"/>
-        </pc:sldMkLst>
-      </pc:sldChg>
-      <pc:sldChg chg="mod ord modShow">
-        <pc:chgData name="Casey Lee" userId="4bc459e0-655e-452e-96c2-b918c0999cdb" providerId="ADAL" clId="{FEDCCBD3-F3AF-4248-98FF-B03AEB6CAACA}" dt="2025-10-07T21:02:19.784" v="67905" actId="729"/>
-        <pc:sldMkLst>
-          <pc:docMk/>
-          <pc:sldMk cId="863687252" sldId="2147481266"/>
-        </pc:sldMkLst>
-      </pc:sldChg>
-      <pc:sldChg chg="modSp mod">
-        <pc:chgData name="Casey Lee" userId="4bc459e0-655e-452e-96c2-b918c0999cdb" providerId="ADAL" clId="{FEDCCBD3-F3AF-4248-98FF-B03AEB6CAACA}" dt="2025-10-06T14:38:20.855" v="51196" actId="20577"/>
-        <pc:sldMkLst>
-          <pc:docMk/>
-          <pc:sldMk cId="645413853" sldId="2147481268"/>
-        </pc:sldMkLst>
-      </pc:sldChg>
-      <pc:sldChg chg="modSp mod ord modCm">
-        <pc:chgData name="Casey Lee" userId="4bc459e0-655e-452e-96c2-b918c0999cdb" providerId="ADAL" clId="{FEDCCBD3-F3AF-4248-98FF-B03AEB6CAACA}" dt="2025-10-07T20:03:15.429" v="65920"/>
-        <pc:sldMkLst>
-          <pc:docMk/>
-          <pc:sldMk cId="3907743225" sldId="2147481269"/>
-        </pc:sldMkLst>
-        <pc:extLst>
-          <p:ext xmlns:p="http://schemas.openxmlformats.org/presentationml/2006/main" uri="{D6D511B9-2390-475A-947B-AFAB55BFBCF1}">
-            <pc226:cmChg xmlns:pc226="http://schemas.microsoft.com/office/powerpoint/2022/06/main/command" chg="mod">
-              <pc226:chgData name="Casey Lee" userId="4bc459e0-655e-452e-96c2-b918c0999cdb" providerId="ADAL" clId="{FEDCCBD3-F3AF-4248-98FF-B03AEB6CAACA}" dt="2025-10-07T20:03:01.832" v="65912" actId="20577"/>
-              <pc2:cmMkLst xmlns:pc2="http://schemas.microsoft.com/office/powerpoint/2019/9/main/command">
-                <pc:docMk/>
-                <pc:sldMk cId="3907743225" sldId="2147481269"/>
-                <pc2:cmMk id="{1C84629E-6323-F44F-AD17-0816FD20B7E6}"/>
-              </pc2:cmMkLst>
-            </pc226:cmChg>
-          </p:ext>
-        </pc:extLst>
-      </pc:sldChg>
-      <pc:sldChg chg="del">
-        <pc:chgData name="Casey Lee" userId="4bc459e0-655e-452e-96c2-b918c0999cdb" providerId="ADAL" clId="{FEDCCBD3-F3AF-4248-98FF-B03AEB6CAACA}" dt="2025-10-07T21:02:02.298" v="67901" actId="47"/>
-        <pc:sldMkLst>
-          <pc:docMk/>
-          <pc:sldMk cId="2080702279" sldId="2147481270"/>
-        </pc:sldMkLst>
-      </pc:sldChg>
-      <pc:sldChg chg="addSp delSp modSp add mod">
-        <pc:chgData name="Casey Lee" userId="4bc459e0-655e-452e-96c2-b918c0999cdb" providerId="ADAL" clId="{FEDCCBD3-F3AF-4248-98FF-B03AEB6CAACA}" dt="2025-10-07T20:24:35.150" v="66597" actId="14100"/>
-        <pc:sldMkLst>
-          <pc:docMk/>
-          <pc:sldMk cId="869299062" sldId="2147481271"/>
-        </pc:sldMkLst>
-      </pc:sldChg>
-      <pc:sldChg chg="del">
-        <pc:chgData name="Casey Lee" userId="4bc459e0-655e-452e-96c2-b918c0999cdb" providerId="ADAL" clId="{FEDCCBD3-F3AF-4248-98FF-B03AEB6CAACA}" dt="2025-10-07T14:47:04.313" v="64602" actId="47"/>
-        <pc:sldMkLst>
-          <pc:docMk/>
-          <pc:sldMk cId="1252616050" sldId="2147481273"/>
-        </pc:sldMkLst>
-      </pc:sldChg>
-      <pc:sldChg chg="addSp delSp modSp mod ord">
-        <pc:chgData name="Casey Lee" userId="4bc459e0-655e-452e-96c2-b918c0999cdb" providerId="ADAL" clId="{FEDCCBD3-F3AF-4248-98FF-B03AEB6CAACA}" dt="2025-10-06T22:26:50.546" v="59691"/>
-        <pc:sldMkLst>
-          <pc:docMk/>
-          <pc:sldMk cId="1976876559" sldId="2147481274"/>
-        </pc:sldMkLst>
-      </pc:sldChg>
-      <pc:sldChg chg="addSp modSp mod">
-        <pc:chgData name="Casey Lee" userId="4bc459e0-655e-452e-96c2-b918c0999cdb" providerId="ADAL" clId="{FEDCCBD3-F3AF-4248-98FF-B03AEB6CAACA}" dt="2025-10-07T20:45:56.729" v="66823" actId="20577"/>
-        <pc:sldMkLst>
-          <pc:docMk/>
-          <pc:sldMk cId="926817997" sldId="2147481276"/>
-        </pc:sldMkLst>
-      </pc:sldChg>
-      <pc:sldChg chg="modSp mod">
-        <pc:chgData name="Casey Lee" userId="4bc459e0-655e-452e-96c2-b918c0999cdb" providerId="ADAL" clId="{FEDCCBD3-F3AF-4248-98FF-B03AEB6CAACA}" dt="2025-10-06T14:28:47.223" v="51187" actId="20577"/>
-        <pc:sldMkLst>
-          <pc:docMk/>
-          <pc:sldMk cId="2350308366" sldId="2147481278"/>
-        </pc:sldMkLst>
-      </pc:sldChg>
-      <pc:sldChg chg="modSp add del mod">
-        <pc:chgData name="Casey Lee" userId="4bc459e0-655e-452e-96c2-b918c0999cdb" providerId="ADAL" clId="{FEDCCBD3-F3AF-4248-98FF-B03AEB6CAACA}" dt="2025-10-06T17:59:59.603" v="51304" actId="47"/>
-        <pc:sldMkLst>
-          <pc:docMk/>
-          <pc:sldMk cId="2073971854" sldId="2147481279"/>
-        </pc:sldMkLst>
-      </pc:sldChg>
-      <pc:sldChg chg="add del">
-        <pc:chgData name="Casey Lee" userId="4bc459e0-655e-452e-96c2-b918c0999cdb" providerId="ADAL" clId="{FEDCCBD3-F3AF-4248-98FF-B03AEB6CAACA}" dt="2025-10-06T18:00:11.534" v="51306"/>
-        <pc:sldMkLst>
-          <pc:docMk/>
-          <pc:sldMk cId="2464430635" sldId="2147481279"/>
-        </pc:sldMkLst>
-      </pc:sldChg>
-      <pc:sldChg chg="delSp modSp add del mod">
-        <pc:chgData name="Casey Lee" userId="4bc459e0-655e-452e-96c2-b918c0999cdb" providerId="ADAL" clId="{FEDCCBD3-F3AF-4248-98FF-B03AEB6CAACA}" dt="2025-10-06T18:00:29.729" v="51310" actId="47"/>
-        <pc:sldMkLst>
-          <pc:docMk/>
-          <pc:sldMk cId="2680122059" sldId="2147481279"/>
-        </pc:sldMkLst>
-      </pc:sldChg>
-      <pc:sldChg chg="addSp delSp modSp add del mod">
-        <pc:chgData name="Casey Lee" userId="4bc459e0-655e-452e-96c2-b918c0999cdb" providerId="ADAL" clId="{FEDCCBD3-F3AF-4248-98FF-B03AEB6CAACA}" dt="2025-10-06T20:03:10.927" v="53757" actId="47"/>
-        <pc:sldMkLst>
-          <pc:docMk/>
-          <pc:sldMk cId="3991912433" sldId="2147481279"/>
-        </pc:sldMkLst>
-      </pc:sldChg>
-      <pc:sldChg chg="add del">
-        <pc:chgData name="Casey Lee" userId="4bc459e0-655e-452e-96c2-b918c0999cdb" providerId="ADAL" clId="{FEDCCBD3-F3AF-4248-98FF-B03AEB6CAACA}" dt="2025-10-06T20:11:57.506" v="54064" actId="47"/>
-        <pc:sldMkLst>
-          <pc:docMk/>
-          <pc:sldMk cId="2121545136" sldId="2147481281"/>
-        </pc:sldMkLst>
-      </pc:sldChg>
-      <pc:sldChg chg="addSp delSp modSp add del mod">
-        <pc:chgData name="Casey Lee" userId="4bc459e0-655e-452e-96c2-b918c0999cdb" providerId="ADAL" clId="{FEDCCBD3-F3AF-4248-98FF-B03AEB6CAACA}" dt="2025-10-06T20:04:56.588" v="53773" actId="47"/>
-        <pc:sldMkLst>
-          <pc:docMk/>
-          <pc:sldMk cId="1440506278" sldId="2147481282"/>
-        </pc:sldMkLst>
-      </pc:sldChg>
-      <pc:sldChg chg="addSp delSp modSp add del mod">
-        <pc:chgData name="Casey Lee" userId="4bc459e0-655e-452e-96c2-b918c0999cdb" providerId="ADAL" clId="{FEDCCBD3-F3AF-4248-98FF-B03AEB6CAACA}" dt="2025-10-06T20:08:45.813" v="53874" actId="47"/>
-        <pc:sldMkLst>
-          <pc:docMk/>
-          <pc:sldMk cId="3422270090" sldId="2147481283"/>
-        </pc:sldMkLst>
-      </pc:sldChg>
-      <pc:sldChg chg="addSp delSp modSp add mod ord">
-        <pc:chgData name="Casey Lee" userId="4bc459e0-655e-452e-96c2-b918c0999cdb" providerId="ADAL" clId="{FEDCCBD3-F3AF-4248-98FF-B03AEB6CAACA}" dt="2025-10-07T19:05:05.388" v="65578"/>
-        <pc:sldMkLst>
-          <pc:docMk/>
-          <pc:sldMk cId="1246806865" sldId="2147481284"/>
-        </pc:sldMkLst>
-      </pc:sldChg>
-      <pc:sldChg chg="addSp delSp modSp add del mod ord modShow">
-        <pc:chgData name="Casey Lee" userId="4bc459e0-655e-452e-96c2-b918c0999cdb" providerId="ADAL" clId="{FEDCCBD3-F3AF-4248-98FF-B03AEB6CAACA}" dt="2025-10-06T21:41:42.945" v="57193" actId="47"/>
-        <pc:sldMkLst>
-          <pc:docMk/>
-          <pc:sldMk cId="3679891914" sldId="2147481285"/>
-        </pc:sldMkLst>
-      </pc:sldChg>
-      <pc:sldChg chg="addSp delSp modSp add mod">
-        <pc:chgData name="Casey Lee" userId="4bc459e0-655e-452e-96c2-b918c0999cdb" providerId="ADAL" clId="{FEDCCBD3-F3AF-4248-98FF-B03AEB6CAACA}" dt="2025-10-07T21:11:25.626" v="68168"/>
-        <pc:sldMkLst>
-          <pc:docMk/>
-          <pc:sldMk cId="2379161747" sldId="2147481286"/>
-        </pc:sldMkLst>
-      </pc:sldChg>
-      <pc:sldChg chg="modSp add del mod">
-        <pc:chgData name="Casey Lee" userId="4bc459e0-655e-452e-96c2-b918c0999cdb" providerId="ADAL" clId="{FEDCCBD3-F3AF-4248-98FF-B03AEB6CAACA}" dt="2025-10-06T21:14:50.008" v="55647" actId="47"/>
-        <pc:sldMkLst>
-          <pc:docMk/>
-          <pc:sldMk cId="1754210451" sldId="2147481287"/>
-        </pc:sldMkLst>
-      </pc:sldChg>
-      <pc:sldChg chg="addSp delSp modSp add mod ord modNotesTx">
-        <pc:chgData name="Casey Lee" userId="4bc459e0-655e-452e-96c2-b918c0999cdb" providerId="ADAL" clId="{FEDCCBD3-F3AF-4248-98FF-B03AEB6CAACA}" dt="2025-10-08T13:51:35.424" v="68204" actId="20577"/>
-        <pc:sldMkLst>
-          <pc:docMk/>
-          <pc:sldMk cId="2042423855" sldId="2147481287"/>
-        </pc:sldMkLst>
-      </pc:sldChg>
-      <pc:sldChg chg="add del">
-        <pc:chgData name="Casey Lee" userId="4bc459e0-655e-452e-96c2-b918c0999cdb" providerId="ADAL" clId="{FEDCCBD3-F3AF-4248-98FF-B03AEB6CAACA}" dt="2025-10-06T21:52:12.046" v="57717" actId="47"/>
-        <pc:sldMkLst>
-          <pc:docMk/>
-          <pc:sldMk cId="1027152683" sldId="2147481288"/>
-        </pc:sldMkLst>
-      </pc:sldChg>
-      <pc:sldChg chg="delSp modSp add mod ord">
-        <pc:chgData name="Casey Lee" userId="4bc459e0-655e-452e-96c2-b918c0999cdb" providerId="ADAL" clId="{FEDCCBD3-F3AF-4248-98FF-B03AEB6CAACA}" dt="2025-10-07T19:05:05.388" v="65578"/>
-        <pc:sldMkLst>
-          <pc:docMk/>
-          <pc:sldMk cId="1092428753" sldId="2147481288"/>
-        </pc:sldMkLst>
-      </pc:sldChg>
-      <pc:sldChg chg="add del">
-        <pc:chgData name="Casey Lee" userId="4bc459e0-655e-452e-96c2-b918c0999cdb" providerId="ADAL" clId="{FEDCCBD3-F3AF-4248-98FF-B03AEB6CAACA}" dt="2025-10-06T21:46:01.387" v="57264"/>
-        <pc:sldMkLst>
-          <pc:docMk/>
-          <pc:sldMk cId="4225137205" sldId="2147481288"/>
-        </pc:sldMkLst>
-      </pc:sldChg>
-      <pc:sldChg chg="modSp add mod">
-        <pc:chgData name="Casey Lee" userId="4bc459e0-655e-452e-96c2-b918c0999cdb" providerId="ADAL" clId="{FEDCCBD3-F3AF-4248-98FF-B03AEB6CAACA}" dt="2025-10-07T19:52:51.587" v="65705" actId="948"/>
-        <pc:sldMkLst>
-          <pc:docMk/>
-          <pc:sldMk cId="2213353267" sldId="2147481289"/>
-        </pc:sldMkLst>
-      </pc:sldChg>
-      <pc:sldChg chg="add ord">
-        <pc:chgData name="Casey Lee" userId="4bc459e0-655e-452e-96c2-b918c0999cdb" providerId="ADAL" clId="{FEDCCBD3-F3AF-4248-98FF-B03AEB6CAACA}" dt="2025-10-07T21:00:42.858" v="67899"/>
-        <pc:sldMkLst>
-          <pc:docMk/>
-          <pc:sldMk cId="1751227399" sldId="2147481290"/>
-        </pc:sldMkLst>
-      </pc:sldChg>
-      <pc:sldChg chg="modSp add mod">
-        <pc:chgData name="Casey Lee" userId="4bc459e0-655e-452e-96c2-b918c0999cdb" providerId="ADAL" clId="{FEDCCBD3-F3AF-4248-98FF-B03AEB6CAACA}" dt="2025-10-07T19:53:56.299" v="65827" actId="1076"/>
-        <pc:sldMkLst>
-          <pc:docMk/>
-          <pc:sldMk cId="1156650361" sldId="2147481291"/>
-        </pc:sldMkLst>
-      </pc:sldChg>
-      <pc:sldChg chg="add del">
-        <pc:chgData name="Casey Lee" userId="4bc459e0-655e-452e-96c2-b918c0999cdb" providerId="ADAL" clId="{FEDCCBD3-F3AF-4248-98FF-B03AEB6CAACA}" dt="2025-10-07T21:02:06.578" v="67902" actId="47"/>
-        <pc:sldMkLst>
-          <pc:docMk/>
-          <pc:sldMk cId="361016522" sldId="2147481292"/>
-        </pc:sldMkLst>
-      </pc:sldChg>
-      <pc:sldChg chg="addSp delSp modSp add del mod ord">
-        <pc:chgData name="Casey Lee" userId="4bc459e0-655e-452e-96c2-b918c0999cdb" providerId="ADAL" clId="{FEDCCBD3-F3AF-4248-98FF-B03AEB6CAACA}" dt="2025-10-08T17:27:26.723" v="69666" actId="47"/>
-        <pc:sldMkLst>
-          <pc:docMk/>
-          <pc:sldMk cId="3867349040" sldId="2147481294"/>
-        </pc:sldMkLst>
-      </pc:sldChg>
-      <pc:sldChg chg="addSp delSp modSp add mod ord">
-        <pc:chgData name="Casey Lee" userId="4bc459e0-655e-452e-96c2-b918c0999cdb" providerId="ADAL" clId="{FEDCCBD3-F3AF-4248-98FF-B03AEB6CAACA}" dt="2025-10-08T18:13:18.131" v="69766"/>
-        <pc:sldMkLst>
-          <pc:docMk/>
-          <pc:sldMk cId="277216321" sldId="2147481295"/>
-        </pc:sldMkLst>
-      </pc:sldChg>
-      <pc:sldChg chg="delSp modSp add del mod">
-        <pc:chgData name="Casey Lee" userId="4bc459e0-655e-452e-96c2-b918c0999cdb" providerId="ADAL" clId="{FEDCCBD3-F3AF-4248-98FF-B03AEB6CAACA}" dt="2025-10-08T17:25:27.263" v="69638" actId="47"/>
-        <pc:sldMkLst>
-          <pc:docMk/>
-          <pc:sldMk cId="525573459" sldId="2147481295"/>
-        </pc:sldMkLst>
-      </pc:sldChg>
-      <pc:sldChg chg="addSp delSp modSp add del mod">
-        <pc:chgData name="Casey Lee" userId="4bc459e0-655e-452e-96c2-b918c0999cdb" providerId="ADAL" clId="{FEDCCBD3-F3AF-4248-98FF-B03AEB6CAACA}" dt="2025-10-08T20:34:36.066" v="69822" actId="47"/>
-        <pc:sldMkLst>
-          <pc:docMk/>
-          <pc:sldMk cId="1403578223" sldId="2147481296"/>
-        </pc:sldMkLst>
-      </pc:sldChg>
-      <pc:sldChg chg="add">
-        <pc:chgData name="Casey Lee" userId="4bc459e0-655e-452e-96c2-b918c0999cdb" providerId="ADAL" clId="{FEDCCBD3-F3AF-4248-98FF-B03AEB6CAACA}" dt="2025-10-08T20:34:09.412" v="69814"/>
-        <pc:sldMkLst>
-          <pc:docMk/>
-          <pc:sldMk cId="3933677755" sldId="2147481297"/>
-        </pc:sldMkLst>
-      </pc:sldChg>
-      <pc:sldChg chg="modSp add del mod">
-        <pc:chgData name="Casey Lee" userId="4bc459e0-655e-452e-96c2-b918c0999cdb" providerId="ADAL" clId="{FEDCCBD3-F3AF-4248-98FF-B03AEB6CAACA}" dt="2025-10-10T22:07:45.214" v="70059" actId="47"/>
-        <pc:sldMkLst>
-          <pc:docMk/>
-          <pc:sldMk cId="634037322" sldId="2147481298"/>
-        </pc:sldMkLst>
-      </pc:sldChg>
     </pc:docChg>
   </pc:docChgLst>
   <pc:docChgLst>
@@ -2890,6 +1210,1448 @@
     </pc:docChg>
   </pc:docChgLst>
   <pc:docChgLst>
+    <pc:chgData name="Kate Tharp" userId="S::kate.tharp@vml.com::f673b90c-5ccd-4f11-b817-79e0f5d8c583" providerId="AD" clId="Web-{A1CFB926-845E-A4C8-E1FE-729016EF509A}"/>
+    <pc:docChg chg="mod">
+      <pc:chgData name="Kate Tharp" userId="S::kate.tharp@vml.com::f673b90c-5ccd-4f11-b817-79e0f5d8c583" providerId="AD" clId="Web-{A1CFB926-845E-A4C8-E1FE-729016EF509A}" dt="2025-09-30T17:14:33.967" v="0"/>
+      <pc:docMkLst>
+        <pc:docMk/>
+      </pc:docMkLst>
+    </pc:docChg>
+  </pc:docChgLst>
+  <pc:docChgLst>
+    <pc:chgData name="Casey Lee" userId="4bc459e0-655e-452e-96c2-b918c0999cdb" providerId="ADAL" clId="{FEDCCBD3-F3AF-4248-98FF-B03AEB6CAACA}"/>
+    <pc:docChg chg="undo redo custSel addSld delSld modSld sldOrd modSection">
+      <pc:chgData name="Casey Lee" userId="4bc459e0-655e-452e-96c2-b918c0999cdb" providerId="ADAL" clId="{FEDCCBD3-F3AF-4248-98FF-B03AEB6CAACA}" dt="2025-10-17T17:36:01.193" v="70061" actId="21"/>
+      <pc:docMkLst>
+        <pc:docMk/>
+      </pc:docMkLst>
+      <pc:sldChg chg="ord">
+        <pc:chgData name="Casey Lee" userId="4bc459e0-655e-452e-96c2-b918c0999cdb" providerId="ADAL" clId="{FEDCCBD3-F3AF-4248-98FF-B03AEB6CAACA}" dt="2025-10-02T20:28:16.132" v="37985"/>
+        <pc:sldMkLst>
+          <pc:docMk/>
+          <pc:sldMk cId="1802258249" sldId="280"/>
+        </pc:sldMkLst>
+      </pc:sldChg>
+      <pc:sldChg chg="modSp mod">
+        <pc:chgData name="Casey Lee" userId="4bc459e0-655e-452e-96c2-b918c0999cdb" providerId="ADAL" clId="{FEDCCBD3-F3AF-4248-98FF-B03AEB6CAACA}" dt="2025-09-30T16:47:04.428" v="21631" actId="20577"/>
+        <pc:sldMkLst>
+          <pc:docMk/>
+          <pc:sldMk cId="1694384516" sldId="285"/>
+        </pc:sldMkLst>
+      </pc:sldChg>
+      <pc:sldChg chg="add del mod ord modShow">
+        <pc:chgData name="Casey Lee" userId="4bc459e0-655e-452e-96c2-b918c0999cdb" providerId="ADAL" clId="{FEDCCBD3-F3AF-4248-98FF-B03AEB6CAACA}" dt="2025-09-26T16:35:44.883" v="4535"/>
+        <pc:sldMkLst>
+          <pc:docMk/>
+          <pc:sldMk cId="2227000735" sldId="307"/>
+        </pc:sldMkLst>
+      </pc:sldChg>
+      <pc:sldChg chg="addSp delSp modSp mod ord">
+        <pc:chgData name="Casey Lee" userId="4bc459e0-655e-452e-96c2-b918c0999cdb" providerId="ADAL" clId="{FEDCCBD3-F3AF-4248-98FF-B03AEB6CAACA}" dt="2025-10-10T15:24:34.837" v="70048" actId="20577"/>
+        <pc:sldMkLst>
+          <pc:docMk/>
+          <pc:sldMk cId="3180984745" sldId="333"/>
+        </pc:sldMkLst>
+      </pc:sldChg>
+      <pc:sldChg chg="modSp mod ord">
+        <pc:chgData name="Casey Lee" userId="4bc459e0-655e-452e-96c2-b918c0999cdb" providerId="ADAL" clId="{FEDCCBD3-F3AF-4248-98FF-B03AEB6CAACA}" dt="2025-10-02T20:28:16.132" v="37985"/>
+        <pc:sldMkLst>
+          <pc:docMk/>
+          <pc:sldMk cId="1946109353" sldId="355"/>
+        </pc:sldMkLst>
+      </pc:sldChg>
+      <pc:sldChg chg="addSp delSp modSp mod ord">
+        <pc:chgData name="Casey Lee" userId="4bc459e0-655e-452e-96c2-b918c0999cdb" providerId="ADAL" clId="{FEDCCBD3-F3AF-4248-98FF-B03AEB6CAACA}" dt="2025-09-29T13:57:09.558" v="11695"/>
+        <pc:sldMkLst>
+          <pc:docMk/>
+          <pc:sldMk cId="2675615646" sldId="419"/>
+        </pc:sldMkLst>
+      </pc:sldChg>
+      <pc:sldChg chg="addSp delSp modSp mod modCm">
+        <pc:chgData name="Casey Lee" userId="4bc459e0-655e-452e-96c2-b918c0999cdb" providerId="ADAL" clId="{FEDCCBD3-F3AF-4248-98FF-B03AEB6CAACA}" dt="2025-10-06T14:20:14.006" v="51184" actId="20577"/>
+        <pc:sldMkLst>
+          <pc:docMk/>
+          <pc:sldMk cId="1299622664" sldId="434"/>
+        </pc:sldMkLst>
+        <pc:extLst>
+          <p:ext xmlns:p="http://schemas.openxmlformats.org/presentationml/2006/main" uri="{D6D511B9-2390-475A-947B-AFAB55BFBCF1}">
+            <pc226:cmChg xmlns:pc226="http://schemas.microsoft.com/office/powerpoint/2022/06/main/command" xmlns="" chg="mod">
+              <pc226:chgData name="Casey Lee" userId="4bc459e0-655e-452e-96c2-b918c0999cdb" providerId="ADAL" clId="{FEDCCBD3-F3AF-4248-98FF-B03AEB6CAACA}" dt="2025-10-06T14:20:14.006" v="51184" actId="20577"/>
+              <pc2:cmMkLst xmlns:pc2="http://schemas.microsoft.com/office/powerpoint/2019/9/main/command">
+                <pc:docMk/>
+                <pc:sldMk cId="1299622664" sldId="434"/>
+                <pc2:cmMk id="{9C52BFDD-9F11-4C01-8EA9-393721749318}"/>
+              </pc2:cmMkLst>
+            </pc226:cmChg>
+          </p:ext>
+        </pc:extLst>
+      </pc:sldChg>
+      <pc:sldChg chg="add del ord">
+        <pc:chgData name="Casey Lee" userId="4bc459e0-655e-452e-96c2-b918c0999cdb" providerId="ADAL" clId="{FEDCCBD3-F3AF-4248-98FF-B03AEB6CAACA}" dt="2025-10-02T15:55:33.977" v="28746"/>
+        <pc:sldMkLst>
+          <pc:docMk/>
+          <pc:sldMk cId="3900277827" sldId="2147478250"/>
+        </pc:sldMkLst>
+      </pc:sldChg>
+      <pc:sldChg chg="add ord">
+        <pc:chgData name="Casey Lee" userId="4bc459e0-655e-452e-96c2-b918c0999cdb" providerId="ADAL" clId="{FEDCCBD3-F3AF-4248-98FF-B03AEB6CAACA}" dt="2025-10-02T15:55:33.977" v="28746"/>
+        <pc:sldMkLst>
+          <pc:docMk/>
+          <pc:sldMk cId="2066716811" sldId="2147478329"/>
+        </pc:sldMkLst>
+      </pc:sldChg>
+      <pc:sldChg chg="add del">
+        <pc:chgData name="Casey Lee" userId="4bc459e0-655e-452e-96c2-b918c0999cdb" providerId="ADAL" clId="{FEDCCBD3-F3AF-4248-98FF-B03AEB6CAACA}" dt="2025-09-19T19:13:18.647" v="2"/>
+        <pc:sldMkLst>
+          <pc:docMk/>
+          <pc:sldMk cId="679476797" sldId="2147480949"/>
+        </pc:sldMkLst>
+      </pc:sldChg>
+      <pc:sldChg chg="addSp delSp modSp add mod ord">
+        <pc:chgData name="Casey Lee" userId="4bc459e0-655e-452e-96c2-b918c0999cdb" providerId="ADAL" clId="{FEDCCBD3-F3AF-4248-98FF-B03AEB6CAACA}" dt="2025-10-07T13:38:34.824" v="59882"/>
+        <pc:sldMkLst>
+          <pc:docMk/>
+          <pc:sldMk cId="2761368814" sldId="2147481181"/>
+        </pc:sldMkLst>
+      </pc:sldChg>
+      <pc:sldChg chg="addSp delSp modSp add del mod">
+        <pc:chgData name="Casey Lee" userId="4bc459e0-655e-452e-96c2-b918c0999cdb" providerId="ADAL" clId="{FEDCCBD3-F3AF-4248-98FF-B03AEB6CAACA}" dt="2025-09-29T14:22:47.094" v="12758" actId="47"/>
+        <pc:sldMkLst>
+          <pc:docMk/>
+          <pc:sldMk cId="3069225704" sldId="2147481199"/>
+        </pc:sldMkLst>
+      </pc:sldChg>
+      <pc:sldChg chg="modSp add del mod">
+        <pc:chgData name="Casey Lee" userId="4bc459e0-655e-452e-96c2-b918c0999cdb" providerId="ADAL" clId="{FEDCCBD3-F3AF-4248-98FF-B03AEB6CAACA}" dt="2025-10-03T15:18:34.054" v="43364" actId="47"/>
+        <pc:sldMkLst>
+          <pc:docMk/>
+          <pc:sldMk cId="2500079299" sldId="2147481200"/>
+        </pc:sldMkLst>
+      </pc:sldChg>
+      <pc:sldChg chg="modSp add mod ord modCm">
+        <pc:chgData name="Casey Lee" userId="4bc459e0-655e-452e-96c2-b918c0999cdb" providerId="ADAL" clId="{FEDCCBD3-F3AF-4248-98FF-B03AEB6CAACA}" dt="2025-10-10T21:45:55.195" v="70049" actId="13926"/>
+        <pc:sldMkLst>
+          <pc:docMk/>
+          <pc:sldMk cId="829862625" sldId="2147481206"/>
+        </pc:sldMkLst>
+        <pc:extLst>
+          <p:ext xmlns:p="http://schemas.openxmlformats.org/presentationml/2006/main" uri="{D6D511B9-2390-475A-947B-AFAB55BFBCF1}">
+            <pc226:cmChg xmlns:pc226="http://schemas.microsoft.com/office/powerpoint/2022/06/main/command" xmlns="" chg="mod">
+              <pc226:chgData name="Casey Lee" userId="4bc459e0-655e-452e-96c2-b918c0999cdb" providerId="ADAL" clId="{FEDCCBD3-F3AF-4248-98FF-B03AEB6CAACA}" dt="2025-10-08T14:25:52.778" v="68521" actId="20577"/>
+              <pc2:cmMkLst xmlns:pc2="http://schemas.microsoft.com/office/powerpoint/2019/9/main/command">
+                <pc:docMk/>
+                <pc:sldMk cId="829862625" sldId="2147481206"/>
+                <pc2:cmMk id="{8C1768B5-F339-4F29-B263-E3C0B5FBF0A5}"/>
+              </pc2:cmMkLst>
+            </pc226:cmChg>
+          </p:ext>
+        </pc:extLst>
+      </pc:sldChg>
+      <pc:sldChg chg="addSp modSp mod ord">
+        <pc:chgData name="Casey Lee" userId="4bc459e0-655e-452e-96c2-b918c0999cdb" providerId="ADAL" clId="{FEDCCBD3-F3AF-4248-98FF-B03AEB6CAACA}" dt="2025-09-26T16:40:01.486" v="4856"/>
+        <pc:sldMkLst>
+          <pc:docMk/>
+          <pc:sldMk cId="2128657008" sldId="2147481209"/>
+        </pc:sldMkLst>
+      </pc:sldChg>
+      <pc:sldChg chg="addSp delSp modSp mod">
+        <pc:chgData name="Casey Lee" userId="4bc459e0-655e-452e-96c2-b918c0999cdb" providerId="ADAL" clId="{FEDCCBD3-F3AF-4248-98FF-B03AEB6CAACA}" dt="2025-09-19T20:25:41.897" v="1420" actId="20577"/>
+        <pc:sldMkLst>
+          <pc:docMk/>
+          <pc:sldMk cId="1105021549" sldId="2147481210"/>
+        </pc:sldMkLst>
+      </pc:sldChg>
+      <pc:sldChg chg="addSp delSp modSp mod modCm">
+        <pc:chgData name="Casey Lee" userId="4bc459e0-655e-452e-96c2-b918c0999cdb" providerId="ADAL" clId="{FEDCCBD3-F3AF-4248-98FF-B03AEB6CAACA}" dt="2025-10-02T17:39:03.548" v="33313" actId="20577"/>
+        <pc:sldMkLst>
+          <pc:docMk/>
+          <pc:sldMk cId="323746144" sldId="2147481211"/>
+        </pc:sldMkLst>
+        <pc:extLst>
+          <p:ext xmlns:p="http://schemas.openxmlformats.org/presentationml/2006/main" uri="{D6D511B9-2390-475A-947B-AFAB55BFBCF1}">
+            <pc226:cmChg xmlns:pc226="http://schemas.microsoft.com/office/powerpoint/2022/06/main/command" xmlns="" chg="mod">
+              <pc226:chgData name="Casey Lee" userId="4bc459e0-655e-452e-96c2-b918c0999cdb" providerId="ADAL" clId="{FEDCCBD3-F3AF-4248-98FF-B03AEB6CAACA}" dt="2025-10-02T17:39:03.548" v="33313" actId="20577"/>
+              <pc2:cmMkLst xmlns:pc2="http://schemas.microsoft.com/office/powerpoint/2019/9/main/command">
+                <pc:docMk/>
+                <pc:sldMk cId="323746144" sldId="2147481211"/>
+                <pc2:cmMk id="{39EB2F37-B8FD-49D1-A4FF-14B267B24A40}"/>
+              </pc2:cmMkLst>
+            </pc226:cmChg>
+          </p:ext>
+        </pc:extLst>
+      </pc:sldChg>
+      <pc:sldChg chg="addSp delSp modSp mod ord">
+        <pc:chgData name="Casey Lee" userId="4bc459e0-655e-452e-96c2-b918c0999cdb" providerId="ADAL" clId="{FEDCCBD3-F3AF-4248-98FF-B03AEB6CAACA}" dt="2025-10-07T16:36:18.841" v="65435" actId="1076"/>
+        <pc:sldMkLst>
+          <pc:docMk/>
+          <pc:sldMk cId="83366420" sldId="2147481212"/>
+        </pc:sldMkLst>
+      </pc:sldChg>
+      <pc:sldChg chg="addSp delSp modSp mod">
+        <pc:chgData name="Casey Lee" userId="4bc459e0-655e-452e-96c2-b918c0999cdb" providerId="ADAL" clId="{FEDCCBD3-F3AF-4248-98FF-B03AEB6CAACA}" dt="2025-10-06T14:44:31.164" v="51234" actId="20577"/>
+        <pc:sldMkLst>
+          <pc:docMk/>
+          <pc:sldMk cId="1270242671" sldId="2147481213"/>
+        </pc:sldMkLst>
+        <pc:spChg chg="mod">
+          <ac:chgData name="Casey Lee" userId="4bc459e0-655e-452e-96c2-b918c0999cdb" providerId="ADAL" clId="{FEDCCBD3-F3AF-4248-98FF-B03AEB6CAACA}" dt="2025-10-06T14:44:31.164" v="51234" actId="20577"/>
+          <ac:spMkLst>
+            <pc:docMk/>
+            <pc:sldMk cId="1270242671" sldId="2147481213"/>
+            <ac:spMk id="4" creationId="{F93D6D7D-FF3F-82F6-14A4-6285C0323998}"/>
+          </ac:spMkLst>
+        </pc:spChg>
+        <pc:graphicFrameChg chg="mod modGraphic">
+          <ac:chgData name="Casey Lee" userId="4bc459e0-655e-452e-96c2-b918c0999cdb" providerId="ADAL" clId="{FEDCCBD3-F3AF-4248-98FF-B03AEB6CAACA}" dt="2025-10-03T18:57:42.221" v="46337" actId="1076"/>
+          <ac:graphicFrameMkLst>
+            <pc:docMk/>
+            <pc:sldMk cId="1270242671" sldId="2147481213"/>
+            <ac:graphicFrameMk id="2" creationId="{38F22EE9-DEDC-E1DA-1E19-E1758E9C192D}"/>
+          </ac:graphicFrameMkLst>
+        </pc:graphicFrameChg>
+      </pc:sldChg>
+      <pc:sldChg chg="addSp delSp modSp mod">
+        <pc:chgData name="Casey Lee" userId="4bc459e0-655e-452e-96c2-b918c0999cdb" providerId="ADAL" clId="{FEDCCBD3-F3AF-4248-98FF-B03AEB6CAACA}" dt="2025-10-08T14:48:01.931" v="68667" actId="403"/>
+        <pc:sldMkLst>
+          <pc:docMk/>
+          <pc:sldMk cId="1389874235" sldId="2147481214"/>
+        </pc:sldMkLst>
+      </pc:sldChg>
+      <pc:sldChg chg="del">
+        <pc:chgData name="Casey Lee" userId="4bc459e0-655e-452e-96c2-b918c0999cdb" providerId="ADAL" clId="{FEDCCBD3-F3AF-4248-98FF-B03AEB6CAACA}" dt="2025-10-08T12:51:36.953" v="68169" actId="47"/>
+        <pc:sldMkLst>
+          <pc:docMk/>
+          <pc:sldMk cId="300876207" sldId="2147481215"/>
+        </pc:sldMkLst>
+      </pc:sldChg>
+      <pc:sldChg chg="addSp delSp modSp mod ord">
+        <pc:chgData name="Casey Lee" userId="4bc459e0-655e-452e-96c2-b918c0999cdb" providerId="ADAL" clId="{FEDCCBD3-F3AF-4248-98FF-B03AEB6CAACA}" dt="2025-09-26T16:40:01.486" v="4856"/>
+        <pc:sldMkLst>
+          <pc:docMk/>
+          <pc:sldMk cId="145336846" sldId="2147481218"/>
+        </pc:sldMkLst>
+      </pc:sldChg>
+      <pc:sldChg chg="addSp delSp modSp add mod">
+        <pc:chgData name="Casey Lee" userId="4bc459e0-655e-452e-96c2-b918c0999cdb" providerId="ADAL" clId="{FEDCCBD3-F3AF-4248-98FF-B03AEB6CAACA}" dt="2025-10-06T14:20:01.304" v="51183" actId="6549"/>
+        <pc:sldMkLst>
+          <pc:docMk/>
+          <pc:sldMk cId="3892756515" sldId="2147481219"/>
+        </pc:sldMkLst>
+      </pc:sldChg>
+      <pc:sldChg chg="modSp mod ord modShow">
+        <pc:chgData name="Casey Lee" userId="4bc459e0-655e-452e-96c2-b918c0999cdb" providerId="ADAL" clId="{FEDCCBD3-F3AF-4248-98FF-B03AEB6CAACA}" dt="2025-09-30T17:31:46.536" v="22108" actId="729"/>
+        <pc:sldMkLst>
+          <pc:docMk/>
+          <pc:sldMk cId="2449955966" sldId="2147481220"/>
+        </pc:sldMkLst>
+      </pc:sldChg>
+      <pc:sldChg chg="modSp mod ord modShow">
+        <pc:chgData name="Casey Lee" userId="4bc459e0-655e-452e-96c2-b918c0999cdb" providerId="ADAL" clId="{FEDCCBD3-F3AF-4248-98FF-B03AEB6CAACA}" dt="2025-09-30T17:31:46.536" v="22108" actId="729"/>
+        <pc:sldMkLst>
+          <pc:docMk/>
+          <pc:sldMk cId="3753532281" sldId="2147481221"/>
+        </pc:sldMkLst>
+      </pc:sldChg>
+      <pc:sldChg chg="addSp delSp modSp mod ord modCm">
+        <pc:chgData name="Casey Lee" userId="4bc459e0-655e-452e-96c2-b918c0999cdb" providerId="ADAL" clId="{FEDCCBD3-F3AF-4248-98FF-B03AEB6CAACA}" dt="2025-10-02T17:57:31.753" v="34405" actId="255"/>
+        <pc:sldMkLst>
+          <pc:docMk/>
+          <pc:sldMk cId="1157813500" sldId="2147481222"/>
+        </pc:sldMkLst>
+        <pc:extLst>
+          <p:ext xmlns:p="http://schemas.openxmlformats.org/presentationml/2006/main" uri="{D6D511B9-2390-475A-947B-AFAB55BFBCF1}">
+            <pc226:cmChg xmlns:pc226="http://schemas.microsoft.com/office/powerpoint/2022/06/main/command" xmlns="" chg="mod">
+              <pc226:chgData name="Casey Lee" userId="4bc459e0-655e-452e-96c2-b918c0999cdb" providerId="ADAL" clId="{FEDCCBD3-F3AF-4248-98FF-B03AEB6CAACA}" dt="2025-10-02T17:15:03.050" v="32088" actId="20577"/>
+              <pc2:cmMkLst xmlns:pc2="http://schemas.microsoft.com/office/powerpoint/2019/9/main/command">
+                <pc:docMk/>
+                <pc:sldMk cId="1157813500" sldId="2147481222"/>
+                <pc2:cmMk id="{0E9EAFC1-53E0-4A88-9A39-BCE44D7D16F2}"/>
+              </pc2:cmMkLst>
+            </pc226:cmChg>
+          </p:ext>
+        </pc:extLst>
+      </pc:sldChg>
+      <pc:sldChg chg="addSp delSp modSp mod ord">
+        <pc:chgData name="Casey Lee" userId="4bc459e0-655e-452e-96c2-b918c0999cdb" providerId="ADAL" clId="{FEDCCBD3-F3AF-4248-98FF-B03AEB6CAACA}" dt="2025-10-07T14:31:19.673" v="63115"/>
+        <pc:sldMkLst>
+          <pc:docMk/>
+          <pc:sldMk cId="4242413873" sldId="2147481223"/>
+        </pc:sldMkLst>
+      </pc:sldChg>
+      <pc:sldChg chg="ord">
+        <pc:chgData name="Casey Lee" userId="4bc459e0-655e-452e-96c2-b918c0999cdb" providerId="ADAL" clId="{FEDCCBD3-F3AF-4248-98FF-B03AEB6CAACA}" dt="2025-09-30T16:46:42.429" v="21626"/>
+        <pc:sldMkLst>
+          <pc:docMk/>
+          <pc:sldMk cId="3621352377" sldId="2147481224"/>
+        </pc:sldMkLst>
+      </pc:sldChg>
+      <pc:sldChg chg="modSp mod ord">
+        <pc:chgData name="Casey Lee" userId="4bc459e0-655e-452e-96c2-b918c0999cdb" providerId="ADAL" clId="{FEDCCBD3-F3AF-4248-98FF-B03AEB6CAACA}" dt="2025-09-30T16:46:16.686" v="21623"/>
+        <pc:sldMkLst>
+          <pc:docMk/>
+          <pc:sldMk cId="1394883244" sldId="2147481226"/>
+        </pc:sldMkLst>
+      </pc:sldChg>
+      <pc:sldChg chg="addSp delSp modSp mod modCm modNotesTx">
+        <pc:chgData name="Casey Lee" userId="4bc459e0-655e-452e-96c2-b918c0999cdb" providerId="ADAL" clId="{FEDCCBD3-F3AF-4248-98FF-B03AEB6CAACA}" dt="2025-10-01T20:42:30.379" v="26286" actId="14100"/>
+        <pc:sldMkLst>
+          <pc:docMk/>
+          <pc:sldMk cId="2560992972" sldId="2147481227"/>
+        </pc:sldMkLst>
+        <pc:extLst>
+          <p:ext xmlns:p="http://schemas.openxmlformats.org/presentationml/2006/main" uri="{D6D511B9-2390-475A-947B-AFAB55BFBCF1}">
+            <pc226:cmChg xmlns:pc226="http://schemas.microsoft.com/office/powerpoint/2022/06/main/command" xmlns="" chg="mod">
+              <pc226:chgData name="Casey Lee" userId="4bc459e0-655e-452e-96c2-b918c0999cdb" providerId="ADAL" clId="{FEDCCBD3-F3AF-4248-98FF-B03AEB6CAACA}" dt="2025-10-01T20:02:15.709" v="25719" actId="20577"/>
+              <pc2:cmMkLst xmlns:pc2="http://schemas.microsoft.com/office/powerpoint/2019/9/main/command">
+                <pc:docMk/>
+                <pc:sldMk cId="2560992972" sldId="2147481227"/>
+                <pc2:cmMk id="{72D62EF9-F7A0-4789-9637-4F84044DA606}"/>
+              </pc2:cmMkLst>
+            </pc226:cmChg>
+          </p:ext>
+        </pc:extLst>
+      </pc:sldChg>
+      <pc:sldChg chg="addSp delSp modSp mod modNotesTx">
+        <pc:chgData name="Casey Lee" userId="4bc459e0-655e-452e-96c2-b918c0999cdb" providerId="ADAL" clId="{FEDCCBD3-F3AF-4248-98FF-B03AEB6CAACA}" dt="2025-10-01T20:41:18.187" v="26285" actId="478"/>
+        <pc:sldMkLst>
+          <pc:docMk/>
+          <pc:sldMk cId="427855662" sldId="2147481228"/>
+        </pc:sldMkLst>
+      </pc:sldChg>
+      <pc:sldChg chg="addSp delSp modSp add mod ord">
+        <pc:chgData name="Casey Lee" userId="4bc459e0-655e-452e-96c2-b918c0999cdb" providerId="ADAL" clId="{FEDCCBD3-F3AF-4248-98FF-B03AEB6CAACA}" dt="2025-10-07T14:04:08.712" v="61012" actId="1076"/>
+        <pc:sldMkLst>
+          <pc:docMk/>
+          <pc:sldMk cId="1426298556" sldId="2147481229"/>
+        </pc:sldMkLst>
+      </pc:sldChg>
+      <pc:sldChg chg="addSp delSp modSp add mod modNotesTx">
+        <pc:chgData name="Casey Lee" userId="4bc459e0-655e-452e-96c2-b918c0999cdb" providerId="ADAL" clId="{FEDCCBD3-F3AF-4248-98FF-B03AEB6CAACA}" dt="2025-10-02T20:01:31.975" v="37715" actId="255"/>
+        <pc:sldMkLst>
+          <pc:docMk/>
+          <pc:sldMk cId="3134119948" sldId="2147481230"/>
+        </pc:sldMkLst>
+      </pc:sldChg>
+      <pc:sldChg chg="addSp delSp modSp add mod">
+        <pc:chgData name="Casey Lee" userId="4bc459e0-655e-452e-96c2-b918c0999cdb" providerId="ADAL" clId="{FEDCCBD3-F3AF-4248-98FF-B03AEB6CAACA}" dt="2025-10-01T18:56:40.945" v="24342" actId="20577"/>
+        <pc:sldMkLst>
+          <pc:docMk/>
+          <pc:sldMk cId="1129204174" sldId="2147481231"/>
+        </pc:sldMkLst>
+      </pc:sldChg>
+      <pc:sldChg chg="modSp add mod ord">
+        <pc:chgData name="Casey Lee" userId="4bc459e0-655e-452e-96c2-b918c0999cdb" providerId="ADAL" clId="{FEDCCBD3-F3AF-4248-98FF-B03AEB6CAACA}" dt="2025-10-03T20:38:46.309" v="48204" actId="1076"/>
+        <pc:sldMkLst>
+          <pc:docMk/>
+          <pc:sldMk cId="1893241687" sldId="2147481232"/>
+        </pc:sldMkLst>
+      </pc:sldChg>
+      <pc:sldChg chg="add del">
+        <pc:chgData name="Casey Lee" userId="4bc459e0-655e-452e-96c2-b918c0999cdb" providerId="ADAL" clId="{FEDCCBD3-F3AF-4248-98FF-B03AEB6CAACA}" dt="2025-09-29T14:08:50.206" v="12280"/>
+        <pc:sldMkLst>
+          <pc:docMk/>
+          <pc:sldMk cId="1370004904" sldId="2147481234"/>
+        </pc:sldMkLst>
+      </pc:sldChg>
+      <pc:sldChg chg="addSp delSp modSp add del mod">
+        <pc:chgData name="Casey Lee" userId="4bc459e0-655e-452e-96c2-b918c0999cdb" providerId="ADAL" clId="{FEDCCBD3-F3AF-4248-98FF-B03AEB6CAACA}" dt="2025-10-03T14:53:21.106" v="42144" actId="47"/>
+        <pc:sldMkLst>
+          <pc:docMk/>
+          <pc:sldMk cId="3872972120" sldId="2147481234"/>
+        </pc:sldMkLst>
+      </pc:sldChg>
+      <pc:sldChg chg="addSp delSp modSp add del mod">
+        <pc:chgData name="Casey Lee" userId="4bc459e0-655e-452e-96c2-b918c0999cdb" providerId="ADAL" clId="{FEDCCBD3-F3AF-4248-98FF-B03AEB6CAACA}" dt="2025-10-03T13:59:31.111" v="41556" actId="47"/>
+        <pc:sldMkLst>
+          <pc:docMk/>
+          <pc:sldMk cId="2664751740" sldId="2147481235"/>
+        </pc:sldMkLst>
+      </pc:sldChg>
+      <pc:sldChg chg="addSp delSp modSp add mod modShow">
+        <pc:chgData name="Casey Lee" userId="4bc459e0-655e-452e-96c2-b918c0999cdb" providerId="ADAL" clId="{FEDCCBD3-F3AF-4248-98FF-B03AEB6CAACA}" dt="2025-10-03T15:58:41.245" v="44921" actId="14100"/>
+        <pc:sldMkLst>
+          <pc:docMk/>
+          <pc:sldMk cId="1567322584" sldId="2147481236"/>
+        </pc:sldMkLst>
+      </pc:sldChg>
+      <pc:sldChg chg="addSp delSp modSp add mod ord">
+        <pc:chgData name="Casey Lee" userId="4bc459e0-655e-452e-96c2-b918c0999cdb" providerId="ADAL" clId="{FEDCCBD3-F3AF-4248-98FF-B03AEB6CAACA}" dt="2025-10-02T05:31:02.461" v="27783" actId="27918"/>
+        <pc:sldMkLst>
+          <pc:docMk/>
+          <pc:sldMk cId="229596941" sldId="2147481237"/>
+        </pc:sldMkLst>
+      </pc:sldChg>
+      <pc:sldChg chg="addSp delSp modSp add del mod ord">
+        <pc:chgData name="Casey Lee" userId="4bc459e0-655e-452e-96c2-b918c0999cdb" providerId="ADAL" clId="{FEDCCBD3-F3AF-4248-98FF-B03AEB6CAACA}" dt="2025-10-02T05:31:02.417" v="27779" actId="27918"/>
+        <pc:sldMkLst>
+          <pc:docMk/>
+          <pc:sldMk cId="821359188" sldId="2147481238"/>
+        </pc:sldMkLst>
+      </pc:sldChg>
+      <pc:sldChg chg="addSp delSp modSp add mod ord">
+        <pc:chgData name="Casey Lee" userId="4bc459e0-655e-452e-96c2-b918c0999cdb" providerId="ADAL" clId="{FEDCCBD3-F3AF-4248-98FF-B03AEB6CAACA}" dt="2025-10-02T05:31:02.436" v="27781" actId="27918"/>
+        <pc:sldMkLst>
+          <pc:docMk/>
+          <pc:sldMk cId="1694054532" sldId="2147481239"/>
+        </pc:sldMkLst>
+      </pc:sldChg>
+      <pc:sldChg chg="addSp delSp modSp add mod ord">
+        <pc:chgData name="Casey Lee" userId="4bc459e0-655e-452e-96c2-b918c0999cdb" providerId="ADAL" clId="{FEDCCBD3-F3AF-4248-98FF-B03AEB6CAACA}" dt="2025-10-02T05:31:02.449" v="27782" actId="27918"/>
+        <pc:sldMkLst>
+          <pc:docMk/>
+          <pc:sldMk cId="3378682446" sldId="2147481240"/>
+        </pc:sldMkLst>
+      </pc:sldChg>
+      <pc:sldChg chg="addSp delSp modSp add mod">
+        <pc:chgData name="Casey Lee" userId="4bc459e0-655e-452e-96c2-b918c0999cdb" providerId="ADAL" clId="{FEDCCBD3-F3AF-4248-98FF-B03AEB6CAACA}" dt="2025-09-30T20:55:46.946" v="23942" actId="20577"/>
+        <pc:sldMkLst>
+          <pc:docMk/>
+          <pc:sldMk cId="3130016136" sldId="2147481241"/>
+        </pc:sldMkLst>
+      </pc:sldChg>
+      <pc:sldChg chg="add ord">
+        <pc:chgData name="Casey Lee" userId="4bc459e0-655e-452e-96c2-b918c0999cdb" providerId="ADAL" clId="{FEDCCBD3-F3AF-4248-98FF-B03AEB6CAACA}" dt="2025-09-30T14:41:11.888" v="19035"/>
+        <pc:sldMkLst>
+          <pc:docMk/>
+          <pc:sldMk cId="3652664627" sldId="2147481242"/>
+        </pc:sldMkLst>
+      </pc:sldChg>
+      <pc:sldChg chg="addSp delSp modSp add mod ord">
+        <pc:chgData name="Casey Lee" userId="4bc459e0-655e-452e-96c2-b918c0999cdb" providerId="ADAL" clId="{FEDCCBD3-F3AF-4248-98FF-B03AEB6CAACA}" dt="2025-10-06T14:26:54.755" v="51186" actId="20577"/>
+        <pc:sldMkLst>
+          <pc:docMk/>
+          <pc:sldMk cId="3576209394" sldId="2147481243"/>
+        </pc:sldMkLst>
+      </pc:sldChg>
+      <pc:sldChg chg="addSp delSp modSp add mod ord">
+        <pc:chgData name="Casey Lee" userId="4bc459e0-655e-452e-96c2-b918c0999cdb" providerId="ADAL" clId="{FEDCCBD3-F3AF-4248-98FF-B03AEB6CAACA}" dt="2025-10-09T14:30:09.411" v="70035" actId="20577"/>
+        <pc:sldMkLst>
+          <pc:docMk/>
+          <pc:sldMk cId="2460346233" sldId="2147481244"/>
+        </pc:sldMkLst>
+      </pc:sldChg>
+      <pc:sldChg chg="delSp add del mod">
+        <pc:chgData name="Casey Lee" userId="4bc459e0-655e-452e-96c2-b918c0999cdb" providerId="ADAL" clId="{FEDCCBD3-F3AF-4248-98FF-B03AEB6CAACA}" dt="2025-09-30T16:46:21.643" v="21624" actId="47"/>
+        <pc:sldMkLst>
+          <pc:docMk/>
+          <pc:sldMk cId="3652261605" sldId="2147481244"/>
+        </pc:sldMkLst>
+      </pc:sldChg>
+      <pc:sldChg chg="addSp delSp modSp del mod">
+        <pc:chgData name="Casey Lee" userId="4bc459e0-655e-452e-96c2-b918c0999cdb" providerId="ADAL" clId="{FEDCCBD3-F3AF-4248-98FF-B03AEB6CAACA}" dt="2025-10-03T19:07:17.692" v="46513" actId="47"/>
+        <pc:sldMkLst>
+          <pc:docMk/>
+          <pc:sldMk cId="3253257184" sldId="2147481245"/>
+        </pc:sldMkLst>
+      </pc:sldChg>
+      <pc:sldChg chg="addSp delSp modSp del mod ord">
+        <pc:chgData name="Casey Lee" userId="4bc459e0-655e-452e-96c2-b918c0999cdb" providerId="ADAL" clId="{FEDCCBD3-F3AF-4248-98FF-B03AEB6CAACA}" dt="2025-10-02T20:57:45.174" v="38909" actId="47"/>
+        <pc:sldMkLst>
+          <pc:docMk/>
+          <pc:sldMk cId="3132776874" sldId="2147481246"/>
+        </pc:sldMkLst>
+      </pc:sldChg>
+      <pc:sldChg chg="modSp mod">
+        <pc:chgData name="Casey Lee" userId="4bc459e0-655e-452e-96c2-b918c0999cdb" providerId="ADAL" clId="{FEDCCBD3-F3AF-4248-98FF-B03AEB6CAACA}" dt="2025-10-09T14:29:41.840" v="70033" actId="20577"/>
+        <pc:sldMkLst>
+          <pc:docMk/>
+          <pc:sldMk cId="2852939510" sldId="2147481248"/>
+        </pc:sldMkLst>
+      </pc:sldChg>
+      <pc:sldChg chg="add ord">
+        <pc:chgData name="Casey Lee" userId="4bc459e0-655e-452e-96c2-b918c0999cdb" providerId="ADAL" clId="{FEDCCBD3-F3AF-4248-98FF-B03AEB6CAACA}" dt="2025-10-01T19:21:14.031" v="24345"/>
+        <pc:sldMkLst>
+          <pc:docMk/>
+          <pc:sldMk cId="2363090598" sldId="2147481251"/>
+        </pc:sldMkLst>
+      </pc:sldChg>
+      <pc:sldChg chg="add ord">
+        <pc:chgData name="Casey Lee" userId="4bc459e0-655e-452e-96c2-b918c0999cdb" providerId="ADAL" clId="{FEDCCBD3-F3AF-4248-98FF-B03AEB6CAACA}" dt="2025-10-01T19:25:21.977" v="24350"/>
+        <pc:sldMkLst>
+          <pc:docMk/>
+          <pc:sldMk cId="2326761967" sldId="2147481252"/>
+        </pc:sldMkLst>
+      </pc:sldChg>
+      <pc:sldChg chg="addSp delSp modSp add mod ord">
+        <pc:chgData name="Casey Lee" userId="4bc459e0-655e-452e-96c2-b918c0999cdb" providerId="ADAL" clId="{FEDCCBD3-F3AF-4248-98FF-B03AEB6CAACA}" dt="2025-10-02T05:31:02.401" v="27778" actId="27918"/>
+        <pc:sldMkLst>
+          <pc:docMk/>
+          <pc:sldMk cId="3718838375" sldId="2147481253"/>
+        </pc:sldMkLst>
+      </pc:sldChg>
+      <pc:sldChg chg="add del">
+        <pc:chgData name="Casey Lee" userId="4bc459e0-655e-452e-96c2-b918c0999cdb" providerId="ADAL" clId="{FEDCCBD3-F3AF-4248-98FF-B03AEB6CAACA}" dt="2025-10-01T20:10:26.540" v="26275" actId="47"/>
+        <pc:sldMkLst>
+          <pc:docMk/>
+          <pc:sldMk cId="3798332572" sldId="2147481253"/>
+        </pc:sldMkLst>
+      </pc:sldChg>
+      <pc:sldChg chg="add mod ord modShow">
+        <pc:chgData name="Casey Lee" userId="4bc459e0-655e-452e-96c2-b918c0999cdb" providerId="ADAL" clId="{FEDCCBD3-F3AF-4248-98FF-B03AEB6CAACA}" dt="2025-10-02T20:28:16.132" v="37985"/>
+        <pc:sldMkLst>
+          <pc:docMk/>
+          <pc:sldMk cId="2060710732" sldId="2147481254"/>
+        </pc:sldMkLst>
+      </pc:sldChg>
+      <pc:sldChg chg="addSp delSp modSp mod modShow">
+        <pc:chgData name="Casey Lee" userId="4bc459e0-655e-452e-96c2-b918c0999cdb" providerId="ADAL" clId="{FEDCCBD3-F3AF-4248-98FF-B03AEB6CAACA}" dt="2025-10-08T20:39:16.692" v="70028" actId="122"/>
+        <pc:sldMkLst>
+          <pc:docMk/>
+          <pc:sldMk cId="988488" sldId="2147481255"/>
+        </pc:sldMkLst>
+      </pc:sldChg>
+      <pc:sldChg chg="addSp delSp modSp add del mod">
+        <pc:chgData name="Casey Lee" userId="4bc459e0-655e-452e-96c2-b918c0999cdb" providerId="ADAL" clId="{FEDCCBD3-F3AF-4248-98FF-B03AEB6CAACA}" dt="2025-10-02T18:03:09.206" v="34600" actId="47"/>
+        <pc:sldMkLst>
+          <pc:docMk/>
+          <pc:sldMk cId="527820914" sldId="2147481255"/>
+        </pc:sldMkLst>
+      </pc:sldChg>
+      <pc:sldChg chg="addSp delSp modSp add del mod">
+        <pc:chgData name="Casey Lee" userId="4bc459e0-655e-452e-96c2-b918c0999cdb" providerId="ADAL" clId="{FEDCCBD3-F3AF-4248-98FF-B03AEB6CAACA}" dt="2025-10-02T16:43:43.045" v="30085" actId="47"/>
+        <pc:sldMkLst>
+          <pc:docMk/>
+          <pc:sldMk cId="2989387375" sldId="2147481255"/>
+        </pc:sldMkLst>
+      </pc:sldChg>
+      <pc:sldChg chg="new del">
+        <pc:chgData name="Casey Lee" userId="4bc459e0-655e-452e-96c2-b918c0999cdb" providerId="ADAL" clId="{FEDCCBD3-F3AF-4248-98FF-B03AEB6CAACA}" dt="2025-10-02T17:30:01.770" v="32414" actId="47"/>
+        <pc:sldMkLst>
+          <pc:docMk/>
+          <pc:sldMk cId="3199761401" sldId="2147481255"/>
+        </pc:sldMkLst>
+      </pc:sldChg>
+      <pc:sldChg chg="delSp modSp add del mod">
+        <pc:chgData name="Casey Lee" userId="4bc459e0-655e-452e-96c2-b918c0999cdb" providerId="ADAL" clId="{FEDCCBD3-F3AF-4248-98FF-B03AEB6CAACA}" dt="2025-10-03T19:53:41.930" v="47704" actId="47"/>
+        <pc:sldMkLst>
+          <pc:docMk/>
+          <pc:sldMk cId="2390622337" sldId="2147481256"/>
+        </pc:sldMkLst>
+      </pc:sldChg>
+      <pc:sldChg chg="modSp mod">
+        <pc:chgData name="Casey Lee" userId="4bc459e0-655e-452e-96c2-b918c0999cdb" providerId="ADAL" clId="{FEDCCBD3-F3AF-4248-98FF-B03AEB6CAACA}" dt="2025-10-03T20:39:14.325" v="48212" actId="20577"/>
+        <pc:sldMkLst>
+          <pc:docMk/>
+          <pc:sldMk cId="2682905776" sldId="2147481257"/>
+        </pc:sldMkLst>
+      </pc:sldChg>
+      <pc:sldChg chg="modSp mod">
+        <pc:chgData name="Casey Lee" userId="4bc459e0-655e-452e-96c2-b918c0999cdb" providerId="ADAL" clId="{FEDCCBD3-F3AF-4248-98FF-B03AEB6CAACA}" dt="2025-10-03T20:39:56.594" v="48220" actId="20577"/>
+        <pc:sldMkLst>
+          <pc:docMk/>
+          <pc:sldMk cId="2763871" sldId="2147481258"/>
+        </pc:sldMkLst>
+      </pc:sldChg>
+      <pc:sldChg chg="addSp delSp modSp add mod">
+        <pc:chgData name="Casey Lee" userId="4bc459e0-655e-452e-96c2-b918c0999cdb" providerId="ADAL" clId="{FEDCCBD3-F3AF-4248-98FF-B03AEB6CAACA}" dt="2025-10-03T15:31:53.386" v="43638" actId="1076"/>
+        <pc:sldMkLst>
+          <pc:docMk/>
+          <pc:sldMk cId="2295337202" sldId="2147481259"/>
+        </pc:sldMkLst>
+      </pc:sldChg>
+      <pc:sldChg chg="addSp delSp modSp add mod">
+        <pc:chgData name="Casey Lee" userId="4bc459e0-655e-452e-96c2-b918c0999cdb" providerId="ADAL" clId="{FEDCCBD3-F3AF-4248-98FF-B03AEB6CAACA}" dt="2025-10-06T14:42:44.314" v="51204" actId="20577"/>
+        <pc:sldMkLst>
+          <pc:docMk/>
+          <pc:sldMk cId="2022463905" sldId="2147481260"/>
+        </pc:sldMkLst>
+      </pc:sldChg>
+      <pc:sldChg chg="addSp delSp modSp add mod">
+        <pc:chgData name="Casey Lee" userId="4bc459e0-655e-452e-96c2-b918c0999cdb" providerId="ADAL" clId="{FEDCCBD3-F3AF-4248-98FF-B03AEB6CAACA}" dt="2025-10-17T17:36:01.193" v="70061" actId="21"/>
+        <pc:sldMkLst>
+          <pc:docMk/>
+          <pc:sldMk cId="648698299" sldId="2147481261"/>
+        </pc:sldMkLst>
+      </pc:sldChg>
+      <pc:sldChg chg="modSp mod">
+        <pc:chgData name="Casey Lee" userId="4bc459e0-655e-452e-96c2-b918c0999cdb" providerId="ADAL" clId="{FEDCCBD3-F3AF-4248-98FF-B03AEB6CAACA}" dt="2025-10-03T19:00:55.817" v="46428" actId="207"/>
+        <pc:sldMkLst>
+          <pc:docMk/>
+          <pc:sldMk cId="4145473322" sldId="2147481262"/>
+        </pc:sldMkLst>
+      </pc:sldChg>
+      <pc:sldChg chg="addSp delSp modSp add mod ord">
+        <pc:chgData name="Casey Lee" userId="4bc459e0-655e-452e-96c2-b918c0999cdb" providerId="ADAL" clId="{FEDCCBD3-F3AF-4248-98FF-B03AEB6CAACA}" dt="2025-10-07T20:07:50.220" v="65922"/>
+        <pc:sldMkLst>
+          <pc:docMk/>
+          <pc:sldMk cId="756745785" sldId="2147481263"/>
+        </pc:sldMkLst>
+      </pc:sldChg>
+      <pc:sldChg chg="modSp mod">
+        <pc:chgData name="Casey Lee" userId="4bc459e0-655e-452e-96c2-b918c0999cdb" providerId="ADAL" clId="{FEDCCBD3-F3AF-4248-98FF-B03AEB6CAACA}" dt="2025-10-06T14:43:21.408" v="51208" actId="20577"/>
+        <pc:sldMkLst>
+          <pc:docMk/>
+          <pc:sldMk cId="345488764" sldId="2147481264"/>
+        </pc:sldMkLst>
+      </pc:sldChg>
+      <pc:sldChg chg="add del">
+        <pc:chgData name="Casey Lee" userId="4bc459e0-655e-452e-96c2-b918c0999cdb" providerId="ADAL" clId="{FEDCCBD3-F3AF-4248-98FF-B03AEB6CAACA}" dt="2025-10-03T18:56:44.257" v="46243" actId="47"/>
+        <pc:sldMkLst>
+          <pc:docMk/>
+          <pc:sldMk cId="1533153485" sldId="2147481265"/>
+        </pc:sldMkLst>
+      </pc:sldChg>
+      <pc:sldChg chg="modSp add mod">
+        <pc:chgData name="Casey Lee" userId="4bc459e0-655e-452e-96c2-b918c0999cdb" providerId="ADAL" clId="{FEDCCBD3-F3AF-4248-98FF-B03AEB6CAACA}" dt="2025-10-03T19:29:54.444" v="46737" actId="20577"/>
+        <pc:sldMkLst>
+          <pc:docMk/>
+          <pc:sldMk cId="2503961039" sldId="2147481265"/>
+        </pc:sldMkLst>
+      </pc:sldChg>
+      <pc:sldChg chg="mod ord modShow">
+        <pc:chgData name="Casey Lee" userId="4bc459e0-655e-452e-96c2-b918c0999cdb" providerId="ADAL" clId="{FEDCCBD3-F3AF-4248-98FF-B03AEB6CAACA}" dt="2025-10-07T21:02:19.784" v="67905" actId="729"/>
+        <pc:sldMkLst>
+          <pc:docMk/>
+          <pc:sldMk cId="863687252" sldId="2147481266"/>
+        </pc:sldMkLst>
+      </pc:sldChg>
+      <pc:sldChg chg="modSp mod">
+        <pc:chgData name="Casey Lee" userId="4bc459e0-655e-452e-96c2-b918c0999cdb" providerId="ADAL" clId="{FEDCCBD3-F3AF-4248-98FF-B03AEB6CAACA}" dt="2025-10-06T14:38:20.855" v="51196" actId="20577"/>
+        <pc:sldMkLst>
+          <pc:docMk/>
+          <pc:sldMk cId="645413853" sldId="2147481268"/>
+        </pc:sldMkLst>
+      </pc:sldChg>
+      <pc:sldChg chg="modSp mod ord modCm">
+        <pc:chgData name="Casey Lee" userId="4bc459e0-655e-452e-96c2-b918c0999cdb" providerId="ADAL" clId="{FEDCCBD3-F3AF-4248-98FF-B03AEB6CAACA}" dt="2025-10-07T20:03:15.429" v="65920"/>
+        <pc:sldMkLst>
+          <pc:docMk/>
+          <pc:sldMk cId="3907743225" sldId="2147481269"/>
+        </pc:sldMkLst>
+        <pc:extLst>
+          <p:ext xmlns:p="http://schemas.openxmlformats.org/presentationml/2006/main" uri="{D6D511B9-2390-475A-947B-AFAB55BFBCF1}">
+            <pc226:cmChg xmlns:pc226="http://schemas.microsoft.com/office/powerpoint/2022/06/main/command" xmlns="" chg="mod">
+              <pc226:chgData name="Casey Lee" userId="4bc459e0-655e-452e-96c2-b918c0999cdb" providerId="ADAL" clId="{FEDCCBD3-F3AF-4248-98FF-B03AEB6CAACA}" dt="2025-10-07T20:03:01.832" v="65912" actId="20577"/>
+              <pc2:cmMkLst xmlns:pc2="http://schemas.microsoft.com/office/powerpoint/2019/9/main/command">
+                <pc:docMk/>
+                <pc:sldMk cId="3907743225" sldId="2147481269"/>
+                <pc2:cmMk id="{1C84629E-6323-F44F-AD17-0816FD20B7E6}"/>
+              </pc2:cmMkLst>
+            </pc226:cmChg>
+          </p:ext>
+        </pc:extLst>
+      </pc:sldChg>
+      <pc:sldChg chg="del">
+        <pc:chgData name="Casey Lee" userId="4bc459e0-655e-452e-96c2-b918c0999cdb" providerId="ADAL" clId="{FEDCCBD3-F3AF-4248-98FF-B03AEB6CAACA}" dt="2025-10-07T21:02:02.298" v="67901" actId="47"/>
+        <pc:sldMkLst>
+          <pc:docMk/>
+          <pc:sldMk cId="2080702279" sldId="2147481270"/>
+        </pc:sldMkLst>
+      </pc:sldChg>
+      <pc:sldChg chg="addSp delSp modSp add mod">
+        <pc:chgData name="Casey Lee" userId="4bc459e0-655e-452e-96c2-b918c0999cdb" providerId="ADAL" clId="{FEDCCBD3-F3AF-4248-98FF-B03AEB6CAACA}" dt="2025-10-07T20:24:35.150" v="66597" actId="14100"/>
+        <pc:sldMkLst>
+          <pc:docMk/>
+          <pc:sldMk cId="869299062" sldId="2147481271"/>
+        </pc:sldMkLst>
+      </pc:sldChg>
+      <pc:sldChg chg="del">
+        <pc:chgData name="Casey Lee" userId="4bc459e0-655e-452e-96c2-b918c0999cdb" providerId="ADAL" clId="{FEDCCBD3-F3AF-4248-98FF-B03AEB6CAACA}" dt="2025-10-07T14:47:04.313" v="64602" actId="47"/>
+        <pc:sldMkLst>
+          <pc:docMk/>
+          <pc:sldMk cId="1252616050" sldId="2147481273"/>
+        </pc:sldMkLst>
+      </pc:sldChg>
+      <pc:sldChg chg="addSp delSp modSp mod ord">
+        <pc:chgData name="Casey Lee" userId="4bc459e0-655e-452e-96c2-b918c0999cdb" providerId="ADAL" clId="{FEDCCBD3-F3AF-4248-98FF-B03AEB6CAACA}" dt="2025-10-06T22:26:50.546" v="59691"/>
+        <pc:sldMkLst>
+          <pc:docMk/>
+          <pc:sldMk cId="1976876559" sldId="2147481274"/>
+        </pc:sldMkLst>
+      </pc:sldChg>
+      <pc:sldChg chg="addSp modSp mod">
+        <pc:chgData name="Casey Lee" userId="4bc459e0-655e-452e-96c2-b918c0999cdb" providerId="ADAL" clId="{FEDCCBD3-F3AF-4248-98FF-B03AEB6CAACA}" dt="2025-10-07T20:45:56.729" v="66823" actId="20577"/>
+        <pc:sldMkLst>
+          <pc:docMk/>
+          <pc:sldMk cId="926817997" sldId="2147481276"/>
+        </pc:sldMkLst>
+      </pc:sldChg>
+      <pc:sldChg chg="modSp mod">
+        <pc:chgData name="Casey Lee" userId="4bc459e0-655e-452e-96c2-b918c0999cdb" providerId="ADAL" clId="{FEDCCBD3-F3AF-4248-98FF-B03AEB6CAACA}" dt="2025-10-06T14:28:47.223" v="51187" actId="20577"/>
+        <pc:sldMkLst>
+          <pc:docMk/>
+          <pc:sldMk cId="2350308366" sldId="2147481278"/>
+        </pc:sldMkLst>
+      </pc:sldChg>
+      <pc:sldChg chg="modSp add del mod">
+        <pc:chgData name="Casey Lee" userId="4bc459e0-655e-452e-96c2-b918c0999cdb" providerId="ADAL" clId="{FEDCCBD3-F3AF-4248-98FF-B03AEB6CAACA}" dt="2025-10-06T17:59:59.603" v="51304" actId="47"/>
+        <pc:sldMkLst>
+          <pc:docMk/>
+          <pc:sldMk cId="2073971854" sldId="2147481279"/>
+        </pc:sldMkLst>
+      </pc:sldChg>
+      <pc:sldChg chg="add del">
+        <pc:chgData name="Casey Lee" userId="4bc459e0-655e-452e-96c2-b918c0999cdb" providerId="ADAL" clId="{FEDCCBD3-F3AF-4248-98FF-B03AEB6CAACA}" dt="2025-10-06T18:00:11.534" v="51306"/>
+        <pc:sldMkLst>
+          <pc:docMk/>
+          <pc:sldMk cId="2464430635" sldId="2147481279"/>
+        </pc:sldMkLst>
+      </pc:sldChg>
+      <pc:sldChg chg="delSp modSp add del mod">
+        <pc:chgData name="Casey Lee" userId="4bc459e0-655e-452e-96c2-b918c0999cdb" providerId="ADAL" clId="{FEDCCBD3-F3AF-4248-98FF-B03AEB6CAACA}" dt="2025-10-06T18:00:29.729" v="51310" actId="47"/>
+        <pc:sldMkLst>
+          <pc:docMk/>
+          <pc:sldMk cId="2680122059" sldId="2147481279"/>
+        </pc:sldMkLst>
+      </pc:sldChg>
+      <pc:sldChg chg="addSp delSp modSp add del mod">
+        <pc:chgData name="Casey Lee" userId="4bc459e0-655e-452e-96c2-b918c0999cdb" providerId="ADAL" clId="{FEDCCBD3-F3AF-4248-98FF-B03AEB6CAACA}" dt="2025-10-06T20:03:10.927" v="53757" actId="47"/>
+        <pc:sldMkLst>
+          <pc:docMk/>
+          <pc:sldMk cId="3991912433" sldId="2147481279"/>
+        </pc:sldMkLst>
+      </pc:sldChg>
+      <pc:sldChg chg="add del">
+        <pc:chgData name="Casey Lee" userId="4bc459e0-655e-452e-96c2-b918c0999cdb" providerId="ADAL" clId="{FEDCCBD3-F3AF-4248-98FF-B03AEB6CAACA}" dt="2025-10-06T20:11:57.506" v="54064" actId="47"/>
+        <pc:sldMkLst>
+          <pc:docMk/>
+          <pc:sldMk cId="2121545136" sldId="2147481281"/>
+        </pc:sldMkLst>
+      </pc:sldChg>
+      <pc:sldChg chg="addSp delSp modSp add del mod">
+        <pc:chgData name="Casey Lee" userId="4bc459e0-655e-452e-96c2-b918c0999cdb" providerId="ADAL" clId="{FEDCCBD3-F3AF-4248-98FF-B03AEB6CAACA}" dt="2025-10-06T20:04:56.588" v="53773" actId="47"/>
+        <pc:sldMkLst>
+          <pc:docMk/>
+          <pc:sldMk cId="1440506278" sldId="2147481282"/>
+        </pc:sldMkLst>
+      </pc:sldChg>
+      <pc:sldChg chg="addSp delSp modSp add del mod">
+        <pc:chgData name="Casey Lee" userId="4bc459e0-655e-452e-96c2-b918c0999cdb" providerId="ADAL" clId="{FEDCCBD3-F3AF-4248-98FF-B03AEB6CAACA}" dt="2025-10-06T20:08:45.813" v="53874" actId="47"/>
+        <pc:sldMkLst>
+          <pc:docMk/>
+          <pc:sldMk cId="3422270090" sldId="2147481283"/>
+        </pc:sldMkLst>
+      </pc:sldChg>
+      <pc:sldChg chg="addSp delSp modSp add mod ord">
+        <pc:chgData name="Casey Lee" userId="4bc459e0-655e-452e-96c2-b918c0999cdb" providerId="ADAL" clId="{FEDCCBD3-F3AF-4248-98FF-B03AEB6CAACA}" dt="2025-10-07T19:05:05.388" v="65578"/>
+        <pc:sldMkLst>
+          <pc:docMk/>
+          <pc:sldMk cId="1246806865" sldId="2147481284"/>
+        </pc:sldMkLst>
+      </pc:sldChg>
+      <pc:sldChg chg="addSp delSp modSp add del mod ord modShow">
+        <pc:chgData name="Casey Lee" userId="4bc459e0-655e-452e-96c2-b918c0999cdb" providerId="ADAL" clId="{FEDCCBD3-F3AF-4248-98FF-B03AEB6CAACA}" dt="2025-10-06T21:41:42.945" v="57193" actId="47"/>
+        <pc:sldMkLst>
+          <pc:docMk/>
+          <pc:sldMk cId="3679891914" sldId="2147481285"/>
+        </pc:sldMkLst>
+      </pc:sldChg>
+      <pc:sldChg chg="addSp delSp modSp add mod">
+        <pc:chgData name="Casey Lee" userId="4bc459e0-655e-452e-96c2-b918c0999cdb" providerId="ADAL" clId="{FEDCCBD3-F3AF-4248-98FF-B03AEB6CAACA}" dt="2025-10-07T21:11:25.626" v="68168"/>
+        <pc:sldMkLst>
+          <pc:docMk/>
+          <pc:sldMk cId="2379161747" sldId="2147481286"/>
+        </pc:sldMkLst>
+      </pc:sldChg>
+      <pc:sldChg chg="modSp add del mod">
+        <pc:chgData name="Casey Lee" userId="4bc459e0-655e-452e-96c2-b918c0999cdb" providerId="ADAL" clId="{FEDCCBD3-F3AF-4248-98FF-B03AEB6CAACA}" dt="2025-10-06T21:14:50.008" v="55647" actId="47"/>
+        <pc:sldMkLst>
+          <pc:docMk/>
+          <pc:sldMk cId="1754210451" sldId="2147481287"/>
+        </pc:sldMkLst>
+      </pc:sldChg>
+      <pc:sldChg chg="addSp delSp modSp add mod ord modNotesTx">
+        <pc:chgData name="Casey Lee" userId="4bc459e0-655e-452e-96c2-b918c0999cdb" providerId="ADAL" clId="{FEDCCBD3-F3AF-4248-98FF-B03AEB6CAACA}" dt="2025-10-08T13:51:35.424" v="68204" actId="20577"/>
+        <pc:sldMkLst>
+          <pc:docMk/>
+          <pc:sldMk cId="2042423855" sldId="2147481287"/>
+        </pc:sldMkLst>
+      </pc:sldChg>
+      <pc:sldChg chg="add del">
+        <pc:chgData name="Casey Lee" userId="4bc459e0-655e-452e-96c2-b918c0999cdb" providerId="ADAL" clId="{FEDCCBD3-F3AF-4248-98FF-B03AEB6CAACA}" dt="2025-10-06T21:52:12.046" v="57717" actId="47"/>
+        <pc:sldMkLst>
+          <pc:docMk/>
+          <pc:sldMk cId="1027152683" sldId="2147481288"/>
+        </pc:sldMkLst>
+      </pc:sldChg>
+      <pc:sldChg chg="delSp modSp add mod ord">
+        <pc:chgData name="Casey Lee" userId="4bc459e0-655e-452e-96c2-b918c0999cdb" providerId="ADAL" clId="{FEDCCBD3-F3AF-4248-98FF-B03AEB6CAACA}" dt="2025-10-07T19:05:05.388" v="65578"/>
+        <pc:sldMkLst>
+          <pc:docMk/>
+          <pc:sldMk cId="1092428753" sldId="2147481288"/>
+        </pc:sldMkLst>
+      </pc:sldChg>
+      <pc:sldChg chg="add del">
+        <pc:chgData name="Casey Lee" userId="4bc459e0-655e-452e-96c2-b918c0999cdb" providerId="ADAL" clId="{FEDCCBD3-F3AF-4248-98FF-B03AEB6CAACA}" dt="2025-10-06T21:46:01.387" v="57264"/>
+        <pc:sldMkLst>
+          <pc:docMk/>
+          <pc:sldMk cId="4225137205" sldId="2147481288"/>
+        </pc:sldMkLst>
+      </pc:sldChg>
+      <pc:sldChg chg="modSp add mod">
+        <pc:chgData name="Casey Lee" userId="4bc459e0-655e-452e-96c2-b918c0999cdb" providerId="ADAL" clId="{FEDCCBD3-F3AF-4248-98FF-B03AEB6CAACA}" dt="2025-10-07T19:52:51.587" v="65705" actId="948"/>
+        <pc:sldMkLst>
+          <pc:docMk/>
+          <pc:sldMk cId="2213353267" sldId="2147481289"/>
+        </pc:sldMkLst>
+      </pc:sldChg>
+      <pc:sldChg chg="add ord">
+        <pc:chgData name="Casey Lee" userId="4bc459e0-655e-452e-96c2-b918c0999cdb" providerId="ADAL" clId="{FEDCCBD3-F3AF-4248-98FF-B03AEB6CAACA}" dt="2025-10-07T21:00:42.858" v="67899"/>
+        <pc:sldMkLst>
+          <pc:docMk/>
+          <pc:sldMk cId="1751227399" sldId="2147481290"/>
+        </pc:sldMkLst>
+      </pc:sldChg>
+      <pc:sldChg chg="modSp add mod">
+        <pc:chgData name="Casey Lee" userId="4bc459e0-655e-452e-96c2-b918c0999cdb" providerId="ADAL" clId="{FEDCCBD3-F3AF-4248-98FF-B03AEB6CAACA}" dt="2025-10-07T19:53:56.299" v="65827" actId="1076"/>
+        <pc:sldMkLst>
+          <pc:docMk/>
+          <pc:sldMk cId="1156650361" sldId="2147481291"/>
+        </pc:sldMkLst>
+      </pc:sldChg>
+      <pc:sldChg chg="add del">
+        <pc:chgData name="Casey Lee" userId="4bc459e0-655e-452e-96c2-b918c0999cdb" providerId="ADAL" clId="{FEDCCBD3-F3AF-4248-98FF-B03AEB6CAACA}" dt="2025-10-07T21:02:06.578" v="67902" actId="47"/>
+        <pc:sldMkLst>
+          <pc:docMk/>
+          <pc:sldMk cId="361016522" sldId="2147481292"/>
+        </pc:sldMkLst>
+      </pc:sldChg>
+      <pc:sldChg chg="addSp delSp modSp add del mod ord">
+        <pc:chgData name="Casey Lee" userId="4bc459e0-655e-452e-96c2-b918c0999cdb" providerId="ADAL" clId="{FEDCCBD3-F3AF-4248-98FF-B03AEB6CAACA}" dt="2025-10-08T17:27:26.723" v="69666" actId="47"/>
+        <pc:sldMkLst>
+          <pc:docMk/>
+          <pc:sldMk cId="3867349040" sldId="2147481294"/>
+        </pc:sldMkLst>
+      </pc:sldChg>
+      <pc:sldChg chg="addSp delSp modSp add mod ord">
+        <pc:chgData name="Casey Lee" userId="4bc459e0-655e-452e-96c2-b918c0999cdb" providerId="ADAL" clId="{FEDCCBD3-F3AF-4248-98FF-B03AEB6CAACA}" dt="2025-10-08T18:13:18.131" v="69766"/>
+        <pc:sldMkLst>
+          <pc:docMk/>
+          <pc:sldMk cId="277216321" sldId="2147481295"/>
+        </pc:sldMkLst>
+      </pc:sldChg>
+      <pc:sldChg chg="delSp modSp add del mod">
+        <pc:chgData name="Casey Lee" userId="4bc459e0-655e-452e-96c2-b918c0999cdb" providerId="ADAL" clId="{FEDCCBD3-F3AF-4248-98FF-B03AEB6CAACA}" dt="2025-10-08T17:25:27.263" v="69638" actId="47"/>
+        <pc:sldMkLst>
+          <pc:docMk/>
+          <pc:sldMk cId="525573459" sldId="2147481295"/>
+        </pc:sldMkLst>
+      </pc:sldChg>
+      <pc:sldChg chg="addSp delSp modSp add del mod">
+        <pc:chgData name="Casey Lee" userId="4bc459e0-655e-452e-96c2-b918c0999cdb" providerId="ADAL" clId="{FEDCCBD3-F3AF-4248-98FF-B03AEB6CAACA}" dt="2025-10-08T20:34:36.066" v="69822" actId="47"/>
+        <pc:sldMkLst>
+          <pc:docMk/>
+          <pc:sldMk cId="1403578223" sldId="2147481296"/>
+        </pc:sldMkLst>
+      </pc:sldChg>
+      <pc:sldChg chg="add">
+        <pc:chgData name="Casey Lee" userId="4bc459e0-655e-452e-96c2-b918c0999cdb" providerId="ADAL" clId="{FEDCCBD3-F3AF-4248-98FF-B03AEB6CAACA}" dt="2025-10-08T20:34:09.412" v="69814"/>
+        <pc:sldMkLst>
+          <pc:docMk/>
+          <pc:sldMk cId="3933677755" sldId="2147481297"/>
+        </pc:sldMkLst>
+      </pc:sldChg>
+      <pc:sldChg chg="modSp add del mod">
+        <pc:chgData name="Casey Lee" userId="4bc459e0-655e-452e-96c2-b918c0999cdb" providerId="ADAL" clId="{FEDCCBD3-F3AF-4248-98FF-B03AEB6CAACA}" dt="2025-10-10T22:07:45.214" v="70059" actId="47"/>
+        <pc:sldMkLst>
+          <pc:docMk/>
+          <pc:sldMk cId="634037322" sldId="2147481298"/>
+        </pc:sldMkLst>
+      </pc:sldChg>
+    </pc:docChg>
+  </pc:docChgLst>
+  <pc:docChgLst>
+    <pc:chgData name="Hernan Ramirez Diaz" userId="0b0763af-8f1b-4303-84e1-6429285cc810" providerId="ADAL" clId="{42163F52-BB8D-4D37-ACEA-9F3481FEDAF8}"/>
+    <pc:docChg chg="undo redo custSel addSld delSld modSld sldOrd modSection">
+      <pc:chgData name="Hernan Ramirez Diaz" userId="0b0763af-8f1b-4303-84e1-6429285cc810" providerId="ADAL" clId="{42163F52-BB8D-4D37-ACEA-9F3481FEDAF8}" dt="2025-10-09T23:46:55.071" v="23066" actId="47"/>
+      <pc:docMkLst>
+        <pc:docMk/>
+      </pc:docMkLst>
+      <pc:sldChg chg="ord">
+        <pc:chgData name="Hernan Ramirez Diaz" userId="0b0763af-8f1b-4303-84e1-6429285cc810" providerId="ADAL" clId="{42163F52-BB8D-4D37-ACEA-9F3481FEDAF8}" dt="2025-10-03T21:28:29.889" v="12946"/>
+        <pc:sldMkLst>
+          <pc:docMk/>
+          <pc:sldMk cId="0" sldId="274"/>
+        </pc:sldMkLst>
+      </pc:sldChg>
+      <pc:sldChg chg="modSp mod">
+        <pc:chgData name="Hernan Ramirez Diaz" userId="0b0763af-8f1b-4303-84e1-6429285cc810" providerId="ADAL" clId="{42163F52-BB8D-4D37-ACEA-9F3481FEDAF8}" dt="2025-10-09T17:08:26.822" v="22799" actId="20577"/>
+        <pc:sldMkLst>
+          <pc:docMk/>
+          <pc:sldMk cId="0" sldId="275"/>
+        </pc:sldMkLst>
+      </pc:sldChg>
+      <pc:sldChg chg="add">
+        <pc:chgData name="Hernan Ramirez Diaz" userId="0b0763af-8f1b-4303-84e1-6429285cc810" providerId="ADAL" clId="{42163F52-BB8D-4D37-ACEA-9F3481FEDAF8}" dt="2025-09-30T22:48:51.036" v="3291"/>
+        <pc:sldMkLst>
+          <pc:docMk/>
+          <pc:sldMk cId="1802258249" sldId="280"/>
+        </pc:sldMkLst>
+      </pc:sldChg>
+      <pc:sldChg chg="modSp mod">
+        <pc:chgData name="Hernan Ramirez Diaz" userId="0b0763af-8f1b-4303-84e1-6429285cc810" providerId="ADAL" clId="{42163F52-BB8D-4D37-ACEA-9F3481FEDAF8}" dt="2025-10-09T18:04:53.412" v="22846" actId="20577"/>
+        <pc:sldMkLst>
+          <pc:docMk/>
+          <pc:sldMk cId="1694384516" sldId="285"/>
+        </pc:sldMkLst>
+      </pc:sldChg>
+      <pc:sldChg chg="add">
+        <pc:chgData name="Hernan Ramirez Diaz" userId="0b0763af-8f1b-4303-84e1-6429285cc810" providerId="ADAL" clId="{42163F52-BB8D-4D37-ACEA-9F3481FEDAF8}" dt="2025-09-30T22:48:51.036" v="3291"/>
+        <pc:sldMkLst>
+          <pc:docMk/>
+          <pc:sldMk cId="1946109353" sldId="355"/>
+        </pc:sldMkLst>
+      </pc:sldChg>
+      <pc:sldChg chg="addSp delSp modSp mod">
+        <pc:chgData name="Hernan Ramirez Diaz" userId="0b0763af-8f1b-4303-84e1-6429285cc810" providerId="ADAL" clId="{42163F52-BB8D-4D37-ACEA-9F3481FEDAF8}" dt="2025-09-26T19:17:47.895" v="1246" actId="478"/>
+        <pc:sldMkLst>
+          <pc:docMk/>
+          <pc:sldMk cId="2675615646" sldId="419"/>
+        </pc:sldMkLst>
+      </pc:sldChg>
+      <pc:sldChg chg="addSp delSp modSp add mod modCm modNotesTx">
+        <pc:chgData name="Hernan Ramirez Diaz" userId="0b0763af-8f1b-4303-84e1-6429285cc810" providerId="ADAL" clId="{42163F52-BB8D-4D37-ACEA-9F3481FEDAF8}" dt="2025-10-09T18:32:21.559" v="22854" actId="255"/>
+        <pc:sldMkLst>
+          <pc:docMk/>
+          <pc:sldMk cId="1299622664" sldId="434"/>
+        </pc:sldMkLst>
+        <pc:extLst>
+          <p:ext xmlns:p="http://schemas.openxmlformats.org/presentationml/2006/main" uri="{D6D511B9-2390-475A-947B-AFAB55BFBCF1}">
+            <pc226:cmChg xmlns:pc226="http://schemas.microsoft.com/office/powerpoint/2022/06/main/command" xmlns="" chg="mod">
+              <pc226:chgData name="Hernan Ramirez Diaz" userId="0b0763af-8f1b-4303-84e1-6429285cc810" providerId="ADAL" clId="{42163F52-BB8D-4D37-ACEA-9F3481FEDAF8}" dt="2025-10-09T18:32:19.001" v="22853" actId="20577"/>
+              <pc2:cmMkLst xmlns:pc2="http://schemas.microsoft.com/office/powerpoint/2019/9/main/command">
+                <pc:docMk/>
+                <pc:sldMk cId="1299622664" sldId="434"/>
+                <pc2:cmMk id="{9C52BFDD-9F11-4C01-8EA9-393721749318}"/>
+              </pc2:cmMkLst>
+            </pc226:cmChg>
+          </p:ext>
+        </pc:extLst>
+      </pc:sldChg>
+      <pc:sldChg chg="addSp delSp modSp mod">
+        <pc:chgData name="Hernan Ramirez Diaz" userId="0b0763af-8f1b-4303-84e1-6429285cc810" providerId="ADAL" clId="{42163F52-BB8D-4D37-ACEA-9F3481FEDAF8}" dt="2025-10-04T05:39:23.308" v="18433" actId="20577"/>
+        <pc:sldMkLst>
+          <pc:docMk/>
+          <pc:sldMk cId="2761368814" sldId="2147481181"/>
+        </pc:sldMkLst>
+      </pc:sldChg>
+      <pc:sldChg chg="ord">
+        <pc:chgData name="Hernan Ramirez Diaz" userId="0b0763af-8f1b-4303-84e1-6429285cc810" providerId="ADAL" clId="{42163F52-BB8D-4D37-ACEA-9F3481FEDAF8}" dt="2025-09-26T17:01:54.525" v="385"/>
+        <pc:sldMkLst>
+          <pc:docMk/>
+          <pc:sldMk cId="1105021549" sldId="2147481210"/>
+        </pc:sldMkLst>
+      </pc:sldChg>
+      <pc:sldChg chg="modSp mod modCm">
+        <pc:chgData name="Hernan Ramirez Diaz" userId="0b0763af-8f1b-4303-84e1-6429285cc810" providerId="ADAL" clId="{42163F52-BB8D-4D37-ACEA-9F3481FEDAF8}" dt="2025-10-03T16:10:51.912" v="10625" actId="14100"/>
+        <pc:sldMkLst>
+          <pc:docMk/>
+          <pc:sldMk cId="323746144" sldId="2147481211"/>
+        </pc:sldMkLst>
+        <pc:extLst>
+          <p:ext xmlns:p="http://schemas.openxmlformats.org/presentationml/2006/main" uri="{D6D511B9-2390-475A-947B-AFAB55BFBCF1}">
+            <pc226:cmChg xmlns:pc226="http://schemas.microsoft.com/office/powerpoint/2022/06/main/command" xmlns="" chg="mod">
+              <pc226:chgData name="Hernan Ramirez Diaz" userId="0b0763af-8f1b-4303-84e1-6429285cc810" providerId="ADAL" clId="{42163F52-BB8D-4D37-ACEA-9F3481FEDAF8}" dt="2025-10-02T22:39:01.158" v="9248" actId="20577"/>
+              <pc2:cmMkLst xmlns:pc2="http://schemas.microsoft.com/office/powerpoint/2019/9/main/command">
+                <pc:docMk/>
+                <pc:sldMk cId="323746144" sldId="2147481211"/>
+                <pc2:cmMk id="{39EB2F37-B8FD-49D1-A4FF-14B267B24A40}"/>
+              </pc2:cmMkLst>
+            </pc226:cmChg>
+          </p:ext>
+        </pc:extLst>
+      </pc:sldChg>
+      <pc:sldChg chg="modSp mod">
+        <pc:chgData name="Hernan Ramirez Diaz" userId="0b0763af-8f1b-4303-84e1-6429285cc810" providerId="ADAL" clId="{42163F52-BB8D-4D37-ACEA-9F3481FEDAF8}" dt="2025-10-09T04:58:22.879" v="22528" actId="1035"/>
+        <pc:sldMkLst>
+          <pc:docMk/>
+          <pc:sldMk cId="83366420" sldId="2147481212"/>
+        </pc:sldMkLst>
+      </pc:sldChg>
+      <pc:sldChg chg="delSp modSp mod">
+        <pc:chgData name="Hernan Ramirez Diaz" userId="0b0763af-8f1b-4303-84e1-6429285cc810" providerId="ADAL" clId="{42163F52-BB8D-4D37-ACEA-9F3481FEDAF8}" dt="2025-10-09T17:03:58.170" v="22792" actId="20577"/>
+        <pc:sldMkLst>
+          <pc:docMk/>
+          <pc:sldMk cId="1270242671" sldId="2147481213"/>
+        </pc:sldMkLst>
+        <pc:spChg chg="mod">
+          <ac:chgData name="Hernan Ramirez Diaz" userId="0b0763af-8f1b-4303-84e1-6429285cc810" providerId="ADAL" clId="{42163F52-BB8D-4D37-ACEA-9F3481FEDAF8}" dt="2025-10-09T17:03:58.170" v="22792" actId="20577"/>
+          <ac:spMkLst>
+            <pc:docMk/>
+            <pc:sldMk cId="1270242671" sldId="2147481213"/>
+            <ac:spMk id="4" creationId="{F93D6D7D-FF3F-82F6-14A4-6285C0323998}"/>
+          </ac:spMkLst>
+        </pc:spChg>
+        <pc:graphicFrameChg chg="mod modGraphic">
+          <ac:chgData name="Hernan Ramirez Diaz" userId="0b0763af-8f1b-4303-84e1-6429285cc810" providerId="ADAL" clId="{42163F52-BB8D-4D37-ACEA-9F3481FEDAF8}" dt="2025-10-03T22:43:17.109" v="14321" actId="207"/>
+          <ac:graphicFrameMkLst>
+            <pc:docMk/>
+            <pc:sldMk cId="1270242671" sldId="2147481213"/>
+            <ac:graphicFrameMk id="2" creationId="{38F22EE9-DEDC-E1DA-1E19-E1758E9C192D}"/>
+          </ac:graphicFrameMkLst>
+        </pc:graphicFrameChg>
+      </pc:sldChg>
+      <pc:sldChg chg="delSp modSp mod">
+        <pc:chgData name="Hernan Ramirez Diaz" userId="0b0763af-8f1b-4303-84e1-6429285cc810" providerId="ADAL" clId="{42163F52-BB8D-4D37-ACEA-9F3481FEDAF8}" dt="2025-10-09T05:00:32.384" v="22644" actId="1035"/>
+        <pc:sldMkLst>
+          <pc:docMk/>
+          <pc:sldMk cId="1389874235" sldId="2147481214"/>
+        </pc:sldMkLst>
+      </pc:sldChg>
+      <pc:sldChg chg="modSp add mod">
+        <pc:chgData name="Hernan Ramirez Diaz" userId="0b0763af-8f1b-4303-84e1-6429285cc810" providerId="ADAL" clId="{42163F52-BB8D-4D37-ACEA-9F3481FEDAF8}" dt="2025-10-03T19:58:25.863" v="12889" actId="14100"/>
+        <pc:sldMkLst>
+          <pc:docMk/>
+          <pc:sldMk cId="300876207" sldId="2147481215"/>
+        </pc:sldMkLst>
+      </pc:sldChg>
+      <pc:sldChg chg="add del ord">
+        <pc:chgData name="Hernan Ramirez Diaz" userId="0b0763af-8f1b-4303-84e1-6429285cc810" providerId="ADAL" clId="{42163F52-BB8D-4D37-ACEA-9F3481FEDAF8}" dt="2025-10-03T19:19:44.098" v="12538" actId="2696"/>
+        <pc:sldMkLst>
+          <pc:docMk/>
+          <pc:sldMk cId="3040778351" sldId="2147481215"/>
+        </pc:sldMkLst>
+      </pc:sldChg>
+      <pc:sldChg chg="del">
+        <pc:chgData name="Hernan Ramirez Diaz" userId="0b0763af-8f1b-4303-84e1-6429285cc810" providerId="ADAL" clId="{42163F52-BB8D-4D37-ACEA-9F3481FEDAF8}" dt="2025-10-01T19:52:59.448" v="3710" actId="47"/>
+        <pc:sldMkLst>
+          <pc:docMk/>
+          <pc:sldMk cId="1707149320" sldId="2147481216"/>
+        </pc:sldMkLst>
+      </pc:sldChg>
+      <pc:sldChg chg="addSp delSp modSp mod ord modCm">
+        <pc:chgData name="Hernan Ramirez Diaz" userId="0b0763af-8f1b-4303-84e1-6429285cc810" providerId="ADAL" clId="{42163F52-BB8D-4D37-ACEA-9F3481FEDAF8}" dt="2025-10-09T17:24:41.542" v="22829" actId="20577"/>
+        <pc:sldMkLst>
+          <pc:docMk/>
+          <pc:sldMk cId="3892756515" sldId="2147481219"/>
+        </pc:sldMkLst>
+        <pc:extLst>
+          <p:ext xmlns:p="http://schemas.openxmlformats.org/presentationml/2006/main" uri="{D6D511B9-2390-475A-947B-AFAB55BFBCF1}">
+            <pc226:cmChg xmlns:pc226="http://schemas.microsoft.com/office/powerpoint/2022/06/main/command" xmlns="" chg="mod">
+              <pc226:chgData name="Hernan Ramirez Diaz" userId="0b0763af-8f1b-4303-84e1-6429285cc810" providerId="ADAL" clId="{42163F52-BB8D-4D37-ACEA-9F3481FEDAF8}" dt="2025-10-09T17:24:41.542" v="22829" actId="20577"/>
+              <pc2:cmMkLst xmlns:pc2="http://schemas.microsoft.com/office/powerpoint/2019/9/main/command">
+                <pc:docMk/>
+                <pc:sldMk cId="3892756515" sldId="2147481219"/>
+                <pc2:cmMk id="{E4D7CC20-49CD-274F-A77F-C5E4F47D747E}"/>
+              </pc2:cmMkLst>
+            </pc226:cmChg>
+          </p:ext>
+        </pc:extLst>
+      </pc:sldChg>
+      <pc:sldChg chg="modSp mod modCm">
+        <pc:chgData name="Hernan Ramirez Diaz" userId="0b0763af-8f1b-4303-84e1-6429285cc810" providerId="ADAL" clId="{42163F52-BB8D-4D37-ACEA-9F3481FEDAF8}" dt="2025-10-09T04:59:47.752" v="22596" actId="1035"/>
+        <pc:sldMkLst>
+          <pc:docMk/>
+          <pc:sldMk cId="1157813500" sldId="2147481222"/>
+        </pc:sldMkLst>
+        <pc:extLst>
+          <p:ext xmlns:p="http://schemas.openxmlformats.org/presentationml/2006/main" uri="{D6D511B9-2390-475A-947B-AFAB55BFBCF1}">
+            <pc226:cmChg xmlns:pc226="http://schemas.microsoft.com/office/powerpoint/2022/06/main/command" xmlns="" chg="mod">
+              <pc226:chgData name="Hernan Ramirez Diaz" userId="0b0763af-8f1b-4303-84e1-6429285cc810" providerId="ADAL" clId="{42163F52-BB8D-4D37-ACEA-9F3481FEDAF8}" dt="2025-10-07T18:20:22.027" v="21107" actId="20577"/>
+              <pc2:cmMkLst xmlns:pc2="http://schemas.microsoft.com/office/powerpoint/2019/9/main/command">
+                <pc:docMk/>
+                <pc:sldMk cId="1157813500" sldId="2147481222"/>
+                <pc2:cmMk id="{0E9EAFC1-53E0-4A88-9A39-BCE44D7D16F2}"/>
+              </pc2:cmMkLst>
+            </pc226:cmChg>
+          </p:ext>
+        </pc:extLst>
+      </pc:sldChg>
+      <pc:sldChg chg="modSp mod">
+        <pc:chgData name="Hernan Ramirez Diaz" userId="0b0763af-8f1b-4303-84e1-6429285cc810" providerId="ADAL" clId="{42163F52-BB8D-4D37-ACEA-9F3481FEDAF8}" dt="2025-10-09T04:59:40.805" v="22590" actId="1035"/>
+        <pc:sldMkLst>
+          <pc:docMk/>
+          <pc:sldMk cId="4242413873" sldId="2147481223"/>
+        </pc:sldMkLst>
+      </pc:sldChg>
+      <pc:sldChg chg="ord">
+        <pc:chgData name="Hernan Ramirez Diaz" userId="0b0763af-8f1b-4303-84e1-6429285cc810" providerId="ADAL" clId="{42163F52-BB8D-4D37-ACEA-9F3481FEDAF8}" dt="2025-09-26T17:20:04.965" v="447"/>
+        <pc:sldMkLst>
+          <pc:docMk/>
+          <pc:sldMk cId="3621352377" sldId="2147481224"/>
+        </pc:sldMkLst>
+      </pc:sldChg>
+      <pc:sldChg chg="ord">
+        <pc:chgData name="Hernan Ramirez Diaz" userId="0b0763af-8f1b-4303-84e1-6429285cc810" providerId="ADAL" clId="{42163F52-BB8D-4D37-ACEA-9F3481FEDAF8}" dt="2025-09-26T17:01:54.525" v="385"/>
+        <pc:sldMkLst>
+          <pc:docMk/>
+          <pc:sldMk cId="2178493738" sldId="2147481225"/>
+        </pc:sldMkLst>
+      </pc:sldChg>
+      <pc:sldChg chg="addSp delSp modSp mod ord modCm">
+        <pc:chgData name="Hernan Ramirez Diaz" userId="0b0763af-8f1b-4303-84e1-6429285cc810" providerId="ADAL" clId="{42163F52-BB8D-4D37-ACEA-9F3481FEDAF8}" dt="2025-10-09T17:15:40.602" v="22819" actId="20577"/>
+        <pc:sldMkLst>
+          <pc:docMk/>
+          <pc:sldMk cId="2560992972" sldId="2147481227"/>
+        </pc:sldMkLst>
+        <pc:extLst>
+          <p:ext xmlns:p="http://schemas.openxmlformats.org/presentationml/2006/main" uri="{D6D511B9-2390-475A-947B-AFAB55BFBCF1}">
+            <pc226:cmChg xmlns:pc226="http://schemas.microsoft.com/office/powerpoint/2022/06/main/command" xmlns="" chg="mod">
+              <pc226:chgData name="Hernan Ramirez Diaz" userId="0b0763af-8f1b-4303-84e1-6429285cc810" providerId="ADAL" clId="{42163F52-BB8D-4D37-ACEA-9F3481FEDAF8}" dt="2025-10-09T17:15:40.602" v="22819" actId="20577"/>
+              <pc2:cmMkLst xmlns:pc2="http://schemas.microsoft.com/office/powerpoint/2019/9/main/command">
+                <pc:docMk/>
+                <pc:sldMk cId="2560992972" sldId="2147481227"/>
+                <pc2:cmMk id="{72D62EF9-F7A0-4789-9637-4F84044DA606}"/>
+              </pc2:cmMkLst>
+            </pc226:cmChg>
+          </p:ext>
+        </pc:extLst>
+      </pc:sldChg>
+      <pc:sldChg chg="addSp delSp modSp mod ord">
+        <pc:chgData name="Hernan Ramirez Diaz" userId="0b0763af-8f1b-4303-84e1-6429285cc810" providerId="ADAL" clId="{42163F52-BB8D-4D37-ACEA-9F3481FEDAF8}" dt="2025-10-09T19:32:50.791" v="23064" actId="1037"/>
+        <pc:sldMkLst>
+          <pc:docMk/>
+          <pc:sldMk cId="427855662" sldId="2147481228"/>
+        </pc:sldMkLst>
+      </pc:sldChg>
+      <pc:sldChg chg="modSp mod ord modNotesTx">
+        <pc:chgData name="Hernan Ramirez Diaz" userId="0b0763af-8f1b-4303-84e1-6429285cc810" providerId="ADAL" clId="{42163F52-BB8D-4D37-ACEA-9F3481FEDAF8}" dt="2025-10-09T04:57:52.012" v="22487" actId="1035"/>
+        <pc:sldMkLst>
+          <pc:docMk/>
+          <pc:sldMk cId="1426298556" sldId="2147481229"/>
+        </pc:sldMkLst>
+      </pc:sldChg>
+      <pc:sldChg chg="addSp delSp modSp mod">
+        <pc:chgData name="Hernan Ramirez Diaz" userId="0b0763af-8f1b-4303-84e1-6429285cc810" providerId="ADAL" clId="{42163F52-BB8D-4D37-ACEA-9F3481FEDAF8}" dt="2025-10-09T04:57:58.079" v="22501" actId="1035"/>
+        <pc:sldMkLst>
+          <pc:docMk/>
+          <pc:sldMk cId="3134119948" sldId="2147481230"/>
+        </pc:sldMkLst>
+      </pc:sldChg>
+      <pc:sldChg chg="delSp modSp del mod">
+        <pc:chgData name="Hernan Ramirez Diaz" userId="0b0763af-8f1b-4303-84e1-6429285cc810" providerId="ADAL" clId="{42163F52-BB8D-4D37-ACEA-9F3481FEDAF8}" dt="2025-10-02T20:26:03.335" v="8228" actId="47"/>
+        <pc:sldMkLst>
+          <pc:docMk/>
+          <pc:sldMk cId="1129204174" sldId="2147481231"/>
+        </pc:sldMkLst>
+      </pc:sldChg>
+      <pc:sldChg chg="addSp delSp modSp mod modCm">
+        <pc:chgData name="Hernan Ramirez Diaz" userId="0b0763af-8f1b-4303-84e1-6429285cc810" providerId="ADAL" clId="{42163F52-BB8D-4D37-ACEA-9F3481FEDAF8}" dt="2025-10-09T18:59:36.975" v="22935" actId="20577"/>
+        <pc:sldMkLst>
+          <pc:docMk/>
+          <pc:sldMk cId="1893241687" sldId="2147481232"/>
+        </pc:sldMkLst>
+        <pc:extLst>
+          <p:ext xmlns:p="http://schemas.openxmlformats.org/presentationml/2006/main" uri="{D6D511B9-2390-475A-947B-AFAB55BFBCF1}">
+            <pc226:cmChg xmlns:pc226="http://schemas.microsoft.com/office/powerpoint/2022/06/main/command" xmlns="" chg="mod">
+              <pc226:chgData name="Hernan Ramirez Diaz" userId="0b0763af-8f1b-4303-84e1-6429285cc810" providerId="ADAL" clId="{42163F52-BB8D-4D37-ACEA-9F3481FEDAF8}" dt="2025-10-07T18:08:32.590" v="21033" actId="20577"/>
+              <pc2:cmMkLst xmlns:pc2="http://schemas.microsoft.com/office/powerpoint/2019/9/main/command">
+                <pc:docMk/>
+                <pc:sldMk cId="1893241687" sldId="2147481232"/>
+                <pc2:cmMk id="{29037932-B4DA-4A44-A2AC-7D730AFE600D}"/>
+              </pc2:cmMkLst>
+            </pc226:cmChg>
+          </p:ext>
+        </pc:extLst>
+      </pc:sldChg>
+      <pc:sldChg chg="addSp delSp modSp new mod ord">
+        <pc:chgData name="Hernan Ramirez Diaz" userId="0b0763af-8f1b-4303-84e1-6429285cc810" providerId="ADAL" clId="{42163F52-BB8D-4D37-ACEA-9F3481FEDAF8}" dt="2025-10-01T19:15:27.007" v="3709"/>
+        <pc:sldMkLst>
+          <pc:docMk/>
+          <pc:sldMk cId="4253379048" sldId="2147481233"/>
+        </pc:sldMkLst>
+      </pc:sldChg>
+      <pc:sldChg chg="modSp mod">
+        <pc:chgData name="Hernan Ramirez Diaz" userId="0b0763af-8f1b-4303-84e1-6429285cc810" providerId="ADAL" clId="{42163F52-BB8D-4D37-ACEA-9F3481FEDAF8}" dt="2025-10-02T18:50:50.363" v="7266" actId="1036"/>
+        <pc:sldMkLst>
+          <pc:docMk/>
+          <pc:sldMk cId="3872972120" sldId="2147481234"/>
+        </pc:sldMkLst>
+      </pc:sldChg>
+      <pc:sldChg chg="modSp mod">
+        <pc:chgData name="Hernan Ramirez Diaz" userId="0b0763af-8f1b-4303-84e1-6429285cc810" providerId="ADAL" clId="{42163F52-BB8D-4D37-ACEA-9F3481FEDAF8}" dt="2025-09-30T18:22:12.515" v="2442" actId="20577"/>
+        <pc:sldMkLst>
+          <pc:docMk/>
+          <pc:sldMk cId="2664751740" sldId="2147481235"/>
+        </pc:sldMkLst>
+      </pc:sldChg>
+      <pc:sldChg chg="addSp delSp mod ord">
+        <pc:chgData name="Hernan Ramirez Diaz" userId="0b0763af-8f1b-4303-84e1-6429285cc810" providerId="ADAL" clId="{42163F52-BB8D-4D37-ACEA-9F3481FEDAF8}" dt="2025-10-03T17:59:31.126" v="12393"/>
+        <pc:sldMkLst>
+          <pc:docMk/>
+          <pc:sldMk cId="1567322584" sldId="2147481236"/>
+        </pc:sldMkLst>
+      </pc:sldChg>
+      <pc:sldChg chg="mod ord modShow">
+        <pc:chgData name="Hernan Ramirez Diaz" userId="0b0763af-8f1b-4303-84e1-6429285cc810" providerId="ADAL" clId="{42163F52-BB8D-4D37-ACEA-9F3481FEDAF8}" dt="2025-10-02T00:31:30.415" v="4706"/>
+        <pc:sldMkLst>
+          <pc:docMk/>
+          <pc:sldMk cId="229596941" sldId="2147481237"/>
+        </pc:sldMkLst>
+      </pc:sldChg>
+      <pc:sldChg chg="mod ord modShow">
+        <pc:chgData name="Hernan Ramirez Diaz" userId="0b0763af-8f1b-4303-84e1-6429285cc810" providerId="ADAL" clId="{42163F52-BB8D-4D37-ACEA-9F3481FEDAF8}" dt="2025-10-02T00:11:50.455" v="4246"/>
+        <pc:sldMkLst>
+          <pc:docMk/>
+          <pc:sldMk cId="3130016136" sldId="2147481241"/>
+        </pc:sldMkLst>
+      </pc:sldChg>
+      <pc:sldChg chg="addSp delSp modSp mod ord modNotesTx">
+        <pc:chgData name="Hernan Ramirez Diaz" userId="0b0763af-8f1b-4303-84e1-6429285cc810" providerId="ADAL" clId="{42163F52-BB8D-4D37-ACEA-9F3481FEDAF8}" dt="2025-10-09T04:50:09.294" v="22073" actId="1035"/>
+        <pc:sldMkLst>
+          <pc:docMk/>
+          <pc:sldMk cId="3576209394" sldId="2147481243"/>
+        </pc:sldMkLst>
+      </pc:sldChg>
+      <pc:sldChg chg="addSp delSp modSp mod ord modShow">
+        <pc:chgData name="Hernan Ramirez Diaz" userId="0b0763af-8f1b-4303-84e1-6429285cc810" providerId="ADAL" clId="{42163F52-BB8D-4D37-ACEA-9F3481FEDAF8}" dt="2025-10-09T04:55:44.808" v="22353" actId="1035"/>
+        <pc:sldMkLst>
+          <pc:docMk/>
+          <pc:sldMk cId="2460346233" sldId="2147481244"/>
+        </pc:sldMkLst>
+      </pc:sldChg>
+      <pc:sldChg chg="delSp modSp add mod">
+        <pc:chgData name="Hernan Ramirez Diaz" userId="0b0763af-8f1b-4303-84e1-6429285cc810" providerId="ADAL" clId="{42163F52-BB8D-4D37-ACEA-9F3481FEDAF8}" dt="2025-10-02T22:44:15.905" v="9401" actId="207"/>
+        <pc:sldMkLst>
+          <pc:docMk/>
+          <pc:sldMk cId="3253257184" sldId="2147481245"/>
+        </pc:sldMkLst>
+      </pc:sldChg>
+      <pc:sldChg chg="delSp modSp add mod">
+        <pc:chgData name="Hernan Ramirez Diaz" userId="0b0763af-8f1b-4303-84e1-6429285cc810" providerId="ADAL" clId="{42163F52-BB8D-4D37-ACEA-9F3481FEDAF8}" dt="2025-09-30T22:49:21.331" v="3295" actId="478"/>
+        <pc:sldMkLst>
+          <pc:docMk/>
+          <pc:sldMk cId="3132776874" sldId="2147481246"/>
+        </pc:sldMkLst>
+      </pc:sldChg>
+      <pc:sldChg chg="modSp mod">
+        <pc:chgData name="Hernan Ramirez Diaz" userId="0b0763af-8f1b-4303-84e1-6429285cc810" providerId="ADAL" clId="{42163F52-BB8D-4D37-ACEA-9F3481FEDAF8}" dt="2025-10-02T21:02:50.516" v="8870" actId="1036"/>
+        <pc:sldMkLst>
+          <pc:docMk/>
+          <pc:sldMk cId="1484297181" sldId="2147481247"/>
+        </pc:sldMkLst>
+      </pc:sldChg>
+      <pc:sldChg chg="addSp delSp modSp add mod">
+        <pc:chgData name="Hernan Ramirez Diaz" userId="0b0763af-8f1b-4303-84e1-6429285cc810" providerId="ADAL" clId="{42163F52-BB8D-4D37-ACEA-9F3481FEDAF8}" dt="2025-10-09T04:25:13.090" v="21978" actId="1035"/>
+        <pc:sldMkLst>
+          <pc:docMk/>
+          <pc:sldMk cId="2852939510" sldId="2147481248"/>
+        </pc:sldMkLst>
+      </pc:sldChg>
+      <pc:sldChg chg="modSp mod ord">
+        <pc:chgData name="Hernan Ramirez Diaz" userId="0b0763af-8f1b-4303-84e1-6429285cc810" providerId="ADAL" clId="{42163F52-BB8D-4D37-ACEA-9F3481FEDAF8}" dt="2025-10-09T04:58:28.772" v="22530" actId="1035"/>
+        <pc:sldMkLst>
+          <pc:docMk/>
+          <pc:sldMk cId="25791284" sldId="2147481249"/>
+        </pc:sldMkLst>
+      </pc:sldChg>
+      <pc:sldChg chg="addSp delSp modSp add mod ord modNotesTx">
+        <pc:chgData name="Hernan Ramirez Diaz" userId="0b0763af-8f1b-4303-84e1-6429285cc810" providerId="ADAL" clId="{42163F52-BB8D-4D37-ACEA-9F3481FEDAF8}" dt="2025-10-02T19:20:52.887" v="7370"/>
+        <pc:sldMkLst>
+          <pc:docMk/>
+          <pc:sldMk cId="2176796729" sldId="2147481250"/>
+        </pc:sldMkLst>
+      </pc:sldChg>
+      <pc:sldChg chg="addSp delSp modSp add del mod ord">
+        <pc:chgData name="Hernan Ramirez Diaz" userId="0b0763af-8f1b-4303-84e1-6429285cc810" providerId="ADAL" clId="{42163F52-BB8D-4D37-ACEA-9F3481FEDAF8}" dt="2025-10-01T01:45:35.806" v="3698" actId="47"/>
+        <pc:sldMkLst>
+          <pc:docMk/>
+          <pc:sldMk cId="1939539720" sldId="2147481251"/>
+        </pc:sldMkLst>
+      </pc:sldChg>
+      <pc:sldChg chg="addSp modSp mod ord">
+        <pc:chgData name="Hernan Ramirez Diaz" userId="0b0763af-8f1b-4303-84e1-6429285cc810" providerId="ADAL" clId="{42163F52-BB8D-4D37-ACEA-9F3481FEDAF8}" dt="2025-10-09T19:29:16.947" v="22953" actId="27918"/>
+        <pc:sldMkLst>
+          <pc:docMk/>
+          <pc:sldMk cId="3718838375" sldId="2147481253"/>
+        </pc:sldMkLst>
+      </pc:sldChg>
+      <pc:sldChg chg="addSp modSp new mod">
+        <pc:chgData name="Hernan Ramirez Diaz" userId="0b0763af-8f1b-4303-84e1-6429285cc810" providerId="ADAL" clId="{42163F52-BB8D-4D37-ACEA-9F3481FEDAF8}" dt="2025-10-04T05:38:27.615" v="18257" actId="20577"/>
+        <pc:sldMkLst>
+          <pc:docMk/>
+          <pc:sldMk cId="988488" sldId="2147481255"/>
+        </pc:sldMkLst>
+      </pc:sldChg>
+      <pc:sldChg chg="new del">
+        <pc:chgData name="Hernan Ramirez Diaz" userId="0b0763af-8f1b-4303-84e1-6429285cc810" providerId="ADAL" clId="{42163F52-BB8D-4D37-ACEA-9F3481FEDAF8}" dt="2025-10-04T00:12:44.661" v="16123" actId="47"/>
+        <pc:sldMkLst>
+          <pc:docMk/>
+          <pc:sldMk cId="2390622337" sldId="2147481256"/>
+        </pc:sldMkLst>
+      </pc:sldChg>
+      <pc:sldChg chg="delSp modSp add mod">
+        <pc:chgData name="Hernan Ramirez Diaz" userId="0b0763af-8f1b-4303-84e1-6429285cc810" providerId="ADAL" clId="{42163F52-BB8D-4D37-ACEA-9F3481FEDAF8}" dt="2025-10-09T18:48:15.920" v="22884" actId="20577"/>
+        <pc:sldMkLst>
+          <pc:docMk/>
+          <pc:sldMk cId="2682905776" sldId="2147481257"/>
+        </pc:sldMkLst>
+      </pc:sldChg>
+      <pc:sldChg chg="addSp delSp modSp add mod modNotesTx">
+        <pc:chgData name="Hernan Ramirez Diaz" userId="0b0763af-8f1b-4303-84e1-6429285cc810" providerId="ADAL" clId="{42163F52-BB8D-4D37-ACEA-9F3481FEDAF8}" dt="2025-10-09T19:06:07.148" v="22938" actId="20577"/>
+        <pc:sldMkLst>
+          <pc:docMk/>
+          <pc:sldMk cId="2763871" sldId="2147481258"/>
+        </pc:sldMkLst>
+      </pc:sldChg>
+      <pc:sldChg chg="delSp modSp del mod">
+        <pc:chgData name="Hernan Ramirez Diaz" userId="0b0763af-8f1b-4303-84e1-6429285cc810" providerId="ADAL" clId="{42163F52-BB8D-4D37-ACEA-9F3481FEDAF8}" dt="2025-10-03T16:59:58.268" v="11141" actId="47"/>
+        <pc:sldMkLst>
+          <pc:docMk/>
+          <pc:sldMk cId="2295337202" sldId="2147481259"/>
+        </pc:sldMkLst>
+      </pc:sldChg>
+      <pc:sldChg chg="addSp delSp modSp mod modNotesTx">
+        <pc:chgData name="Hernan Ramirez Diaz" userId="0b0763af-8f1b-4303-84e1-6429285cc810" providerId="ADAL" clId="{42163F52-BB8D-4D37-ACEA-9F3481FEDAF8}" dt="2025-10-09T19:21:31.977" v="22951" actId="20577"/>
+        <pc:sldMkLst>
+          <pc:docMk/>
+          <pc:sldMk cId="2022463905" sldId="2147481260"/>
+        </pc:sldMkLst>
+      </pc:sldChg>
+      <pc:sldChg chg="addSp delSp modSp mod">
+        <pc:chgData name="Hernan Ramirez Diaz" userId="0b0763af-8f1b-4303-84e1-6429285cc810" providerId="ADAL" clId="{42163F52-BB8D-4D37-ACEA-9F3481FEDAF8}" dt="2025-10-09T04:58:46.353" v="22549" actId="14100"/>
+        <pc:sldMkLst>
+          <pc:docMk/>
+          <pc:sldMk cId="648698299" sldId="2147481261"/>
+        </pc:sldMkLst>
+      </pc:sldChg>
+      <pc:sldChg chg="addSp delSp modSp add mod modNotesTx">
+        <pc:chgData name="Hernan Ramirez Diaz" userId="0b0763af-8f1b-4303-84e1-6429285cc810" providerId="ADAL" clId="{42163F52-BB8D-4D37-ACEA-9F3481FEDAF8}" dt="2025-10-09T04:59:29.596" v="22587" actId="1035"/>
+        <pc:sldMkLst>
+          <pc:docMk/>
+          <pc:sldMk cId="4145473322" sldId="2147481262"/>
+        </pc:sldMkLst>
+      </pc:sldChg>
+      <pc:sldChg chg="addSp delSp modSp add mod">
+        <pc:chgData name="Hernan Ramirez Diaz" userId="0b0763af-8f1b-4303-84e1-6429285cc810" providerId="ADAL" clId="{42163F52-BB8D-4D37-ACEA-9F3481FEDAF8}" dt="2025-10-09T05:00:17.277" v="22629" actId="1035"/>
+        <pc:sldMkLst>
+          <pc:docMk/>
+          <pc:sldMk cId="345488764" sldId="2147481264"/>
+        </pc:sldMkLst>
+      </pc:sldChg>
+      <pc:sldChg chg="addSp delSp modSp mod ord">
+        <pc:chgData name="Hernan Ramirez Diaz" userId="0b0763af-8f1b-4303-84e1-6429285cc810" providerId="ADAL" clId="{42163F52-BB8D-4D37-ACEA-9F3481FEDAF8}" dt="2025-10-04T04:45:30.488" v="17443"/>
+        <pc:sldMkLst>
+          <pc:docMk/>
+          <pc:sldMk cId="2503961039" sldId="2147481265"/>
+        </pc:sldMkLst>
+      </pc:sldChg>
+      <pc:sldChg chg="modSp add mod">
+        <pc:chgData name="Hernan Ramirez Diaz" userId="0b0763af-8f1b-4303-84e1-6429285cc810" providerId="ADAL" clId="{42163F52-BB8D-4D37-ACEA-9F3481FEDAF8}" dt="2025-10-03T19:58:37.894" v="12890" actId="14100"/>
+        <pc:sldMkLst>
+          <pc:docMk/>
+          <pc:sldMk cId="863687252" sldId="2147481266"/>
+        </pc:sldMkLst>
+      </pc:sldChg>
+      <pc:sldChg chg="modSp add mod">
+        <pc:chgData name="Hernan Ramirez Diaz" userId="0b0763af-8f1b-4303-84e1-6429285cc810" providerId="ADAL" clId="{42163F52-BB8D-4D37-ACEA-9F3481FEDAF8}" dt="2025-10-03T19:22:30.157" v="12629" actId="20577"/>
+        <pc:sldMkLst>
+          <pc:docMk/>
+          <pc:sldMk cId="1129400367" sldId="2147481267"/>
+        </pc:sldMkLst>
+      </pc:sldChg>
+      <pc:sldChg chg="modSp add mod">
+        <pc:chgData name="Hernan Ramirez Diaz" userId="0b0763af-8f1b-4303-84e1-6429285cc810" providerId="ADAL" clId="{42163F52-BB8D-4D37-ACEA-9F3481FEDAF8}" dt="2025-10-03T22:38:00.493" v="14302" actId="20577"/>
+        <pc:sldMkLst>
+          <pc:docMk/>
+          <pc:sldMk cId="645413853" sldId="2147481268"/>
+        </pc:sldMkLst>
+      </pc:sldChg>
+      <pc:sldChg chg="modSp add mod">
+        <pc:chgData name="Hernan Ramirez Diaz" userId="0b0763af-8f1b-4303-84e1-6429285cc810" providerId="ADAL" clId="{42163F52-BB8D-4D37-ACEA-9F3481FEDAF8}" dt="2025-10-03T19:58:45.624" v="12891" actId="14100"/>
+        <pc:sldMkLst>
+          <pc:docMk/>
+          <pc:sldMk cId="3907743225" sldId="2147481269"/>
+        </pc:sldMkLst>
+      </pc:sldChg>
+      <pc:sldChg chg="modSp add mod">
+        <pc:chgData name="Hernan Ramirez Diaz" userId="0b0763af-8f1b-4303-84e1-6429285cc810" providerId="ADAL" clId="{42163F52-BB8D-4D37-ACEA-9F3481FEDAF8}" dt="2025-10-03T19:58:54.074" v="12892" actId="14100"/>
+        <pc:sldMkLst>
+          <pc:docMk/>
+          <pc:sldMk cId="2080702279" sldId="2147481270"/>
+        </pc:sldMkLst>
+      </pc:sldChg>
+      <pc:sldChg chg="addSp delSp modSp mod ord">
+        <pc:chgData name="Hernan Ramirez Diaz" userId="0b0763af-8f1b-4303-84e1-6429285cc810" providerId="ADAL" clId="{42163F52-BB8D-4D37-ACEA-9F3481FEDAF8}" dt="2025-10-09T04:58:07.039" v="22505" actId="1035"/>
+        <pc:sldMkLst>
+          <pc:docMk/>
+          <pc:sldMk cId="869299062" sldId="2147481271"/>
+        </pc:sldMkLst>
+      </pc:sldChg>
+      <pc:sldChg chg="modSp new del mod">
+        <pc:chgData name="Hernan Ramirez Diaz" userId="0b0763af-8f1b-4303-84e1-6429285cc810" providerId="ADAL" clId="{42163F52-BB8D-4D37-ACEA-9F3481FEDAF8}" dt="2025-10-04T06:03:41.892" v="18453" actId="47"/>
+        <pc:sldMkLst>
+          <pc:docMk/>
+          <pc:sldMk cId="3779341304" sldId="2147481272"/>
+        </pc:sldMkLst>
+      </pc:sldChg>
+      <pc:sldChg chg="new">
+        <pc:chgData name="Hernan Ramirez Diaz" userId="0b0763af-8f1b-4303-84e1-6429285cc810" providerId="ADAL" clId="{42163F52-BB8D-4D37-ACEA-9F3481FEDAF8}" dt="2025-10-03T22:57:27.833" v="14445" actId="680"/>
+        <pc:sldMkLst>
+          <pc:docMk/>
+          <pc:sldMk cId="1252616050" sldId="2147481273"/>
+        </pc:sldMkLst>
+      </pc:sldChg>
+      <pc:sldChg chg="addSp delSp modSp add mod ord">
+        <pc:chgData name="Hernan Ramirez Diaz" userId="0b0763af-8f1b-4303-84e1-6429285cc810" providerId="ADAL" clId="{42163F52-BB8D-4D37-ACEA-9F3481FEDAF8}" dt="2025-10-04T00:27:05.972" v="16436" actId="1076"/>
+        <pc:sldMkLst>
+          <pc:docMk/>
+          <pc:sldMk cId="1976876559" sldId="2147481274"/>
+        </pc:sldMkLst>
+      </pc:sldChg>
+      <pc:sldChg chg="delSp add mod ord">
+        <pc:chgData name="Hernan Ramirez Diaz" userId="0b0763af-8f1b-4303-84e1-6429285cc810" providerId="ADAL" clId="{42163F52-BB8D-4D37-ACEA-9F3481FEDAF8}" dt="2025-10-04T00:21:17.826" v="16356"/>
+        <pc:sldMkLst>
+          <pc:docMk/>
+          <pc:sldMk cId="68822884" sldId="2147481275"/>
+        </pc:sldMkLst>
+      </pc:sldChg>
+      <pc:sldChg chg="addSp delSp modSp add mod">
+        <pc:chgData name="Hernan Ramirez Diaz" userId="0b0763af-8f1b-4303-84e1-6429285cc810" providerId="ADAL" clId="{42163F52-BB8D-4D37-ACEA-9F3481FEDAF8}" dt="2025-10-08T18:03:35.166" v="21342" actId="1076"/>
+        <pc:sldMkLst>
+          <pc:docMk/>
+          <pc:sldMk cId="926817997" sldId="2147481276"/>
+        </pc:sldMkLst>
+      </pc:sldChg>
+      <pc:sldChg chg="delSp modSp add del mod ord">
+        <pc:chgData name="Hernan Ramirez Diaz" userId="0b0763af-8f1b-4303-84e1-6429285cc810" providerId="ADAL" clId="{42163F52-BB8D-4D37-ACEA-9F3481FEDAF8}" dt="2025-10-04T06:05:30.878" v="18628" actId="47"/>
+        <pc:sldMkLst>
+          <pc:docMk/>
+          <pc:sldMk cId="938116946" sldId="2147481277"/>
+        </pc:sldMkLst>
+      </pc:sldChg>
+      <pc:sldChg chg="addSp delSp modSp add mod ord">
+        <pc:chgData name="Hernan Ramirez Diaz" userId="0b0763af-8f1b-4303-84e1-6429285cc810" providerId="ADAL" clId="{42163F52-BB8D-4D37-ACEA-9F3481FEDAF8}" dt="2025-10-09T19:19:56.706" v="22940" actId="115"/>
+        <pc:sldMkLst>
+          <pc:docMk/>
+          <pc:sldMk cId="2350308366" sldId="2147481278"/>
+        </pc:sldMkLst>
+      </pc:sldChg>
+      <pc:sldChg chg="modSp mod">
+        <pc:chgData name="Hernan Ramirez Diaz" userId="0b0763af-8f1b-4303-84e1-6429285cc810" providerId="ADAL" clId="{42163F52-BB8D-4D37-ACEA-9F3481FEDAF8}" dt="2025-10-09T16:55:50.150" v="22770" actId="1035"/>
+        <pc:sldMkLst>
+          <pc:docMk/>
+          <pc:sldMk cId="1618464510" sldId="2147481280"/>
+        </pc:sldMkLst>
+      </pc:sldChg>
+      <pc:sldChg chg="modSp mod">
+        <pc:chgData name="Hernan Ramirez Diaz" userId="0b0763af-8f1b-4303-84e1-6429285cc810" providerId="ADAL" clId="{42163F52-BB8D-4D37-ACEA-9F3481FEDAF8}" dt="2025-10-09T17:04:19.208" v="22794" actId="20577"/>
+        <pc:sldMkLst>
+          <pc:docMk/>
+          <pc:sldMk cId="2379161747" sldId="2147481286"/>
+        </pc:sldMkLst>
+      </pc:sldChg>
+      <pc:sldChg chg="modSp mod">
+        <pc:chgData name="Hernan Ramirez Diaz" userId="0b0763af-8f1b-4303-84e1-6429285cc810" providerId="ADAL" clId="{42163F52-BB8D-4D37-ACEA-9F3481FEDAF8}" dt="2025-10-09T17:04:16.565" v="22793" actId="20577"/>
+        <pc:sldMkLst>
+          <pc:docMk/>
+          <pc:sldMk cId="2042423855" sldId="2147481287"/>
+        </pc:sldMkLst>
+      </pc:sldChg>
+      <pc:sldChg chg="modSp mod">
+        <pc:chgData name="Hernan Ramirez Diaz" userId="0b0763af-8f1b-4303-84e1-6429285cc810" providerId="ADAL" clId="{42163F52-BB8D-4D37-ACEA-9F3481FEDAF8}" dt="2025-10-08T18:04:09.094" v="21366" actId="1076"/>
+        <pc:sldMkLst>
+          <pc:docMk/>
+          <pc:sldMk cId="1156650361" sldId="2147481291"/>
+        </pc:sldMkLst>
+      </pc:sldChg>
+      <pc:sldChg chg="modSp mod ord">
+        <pc:chgData name="Hernan Ramirez Diaz" userId="0b0763af-8f1b-4303-84e1-6429285cc810" providerId="ADAL" clId="{42163F52-BB8D-4D37-ACEA-9F3481FEDAF8}" dt="2025-10-08T18:09:50.816" v="21544"/>
+        <pc:sldMkLst>
+          <pc:docMk/>
+          <pc:sldMk cId="277216321" sldId="2147481295"/>
+        </pc:sldMkLst>
+      </pc:sldChg>
+      <pc:sldChg chg="add del">
+        <pc:chgData name="Hernan Ramirez Diaz" userId="0b0763af-8f1b-4303-84e1-6429285cc810" providerId="ADAL" clId="{42163F52-BB8D-4D37-ACEA-9F3481FEDAF8}" dt="2025-10-09T23:46:55.071" v="23066" actId="47"/>
+        <pc:sldMkLst>
+          <pc:docMk/>
+          <pc:sldMk cId="3933677755" sldId="2147481297"/>
+        </pc:sldMkLst>
+      </pc:sldChg>
+    </pc:docChg>
+  </pc:docChgLst>
+  <pc:docChgLst>
     <pc:chgData name="Shubhangi Verma" userId="c0355bd3-af2b-4be5-9724-d992cd36b32e" providerId="ADAL" clId="{C10E5BAD-77AF-5A72-8623-CDC46286E166}"/>
     <pc:docChg chg="undo custSel addSld modSld sldOrd modSection">
       <pc:chgData name="Shubhangi Verma" userId="c0355bd3-af2b-4be5-9724-d992cd36b32e" providerId="ADAL" clId="{C10E5BAD-77AF-5A72-8623-CDC46286E166}" dt="2025-10-07T20:09:57.553" v="2693" actId="729"/>
@@ -3066,7 +2828,7 @@
         </pc:sldMkLst>
         <pc:extLst>
           <p:ext xmlns:p="http://schemas.openxmlformats.org/presentationml/2006/main" uri="{D6D511B9-2390-475A-947B-AFAB55BFBCF1}">
-            <pc226:cmChg xmlns:pc226="http://schemas.microsoft.com/office/powerpoint/2022/06/main/command" chg="mod">
+            <pc226:cmChg xmlns:pc226="http://schemas.microsoft.com/office/powerpoint/2022/06/main/command" xmlns="" chg="mod">
               <pc226:chgData name="Shubhangi Verma" userId="c0355bd3-af2b-4be5-9724-d992cd36b32e" providerId="ADAL" clId="{C10E5BAD-77AF-5A72-8623-CDC46286E166}" dt="2025-10-07T20:07:04.556" v="2664" actId="20577"/>
               <pc2:cmMkLst xmlns:pc2="http://schemas.microsoft.com/office/powerpoint/2019/9/main/command">
                 <pc:docMk/>
@@ -3077,6 +2839,244 @@
           </p:ext>
         </pc:extLst>
       </pc:sldChg>
+    </pc:docChg>
+  </pc:docChgLst>
+  <pc:docChgLst>
+    <pc:chgData name="Michael Bruno" userId="ed6069a4-1fcb-46c4-b4b7-85c279acb11e" providerId="ADAL" clId="{613589E5-1A9A-41C5-92C9-D44D19F40B73}"/>
+    <pc:docChg chg="custSel modSld">
+      <pc:chgData name="Michael Bruno" userId="ed6069a4-1fcb-46c4-b4b7-85c279acb11e" providerId="ADAL" clId="{613589E5-1A9A-41C5-92C9-D44D19F40B73}" dt="2025-10-10T20:06:34.494" v="3" actId="13926"/>
+      <pc:docMkLst>
+        <pc:docMk/>
+      </pc:docMkLst>
+      <pc:sldChg chg="delSp modSp mod">
+        <pc:chgData name="Michael Bruno" userId="ed6069a4-1fcb-46c4-b4b7-85c279acb11e" providerId="ADAL" clId="{613589E5-1A9A-41C5-92C9-D44D19F40B73}" dt="2025-10-09T23:11:36.343" v="2" actId="478"/>
+        <pc:sldMkLst>
+          <pc:docMk/>
+          <pc:sldMk cId="0" sldId="260"/>
+        </pc:sldMkLst>
+      </pc:sldChg>
+      <pc:sldChg chg="modSp mod">
+        <pc:chgData name="Michael Bruno" userId="ed6069a4-1fcb-46c4-b4b7-85c279acb11e" providerId="ADAL" clId="{613589E5-1A9A-41C5-92C9-D44D19F40B73}" dt="2025-10-10T20:06:34.494" v="3" actId="13926"/>
+        <pc:sldMkLst>
+          <pc:docMk/>
+          <pc:sldMk cId="829862625" sldId="2147481206"/>
+        </pc:sldMkLst>
+      </pc:sldChg>
+    </pc:docChg>
+  </pc:docChgLst>
+  <pc:docChgLst>
+    <pc:chgData name="Ridhima Dhawan" userId="41b5bd7b-df07-43ed-9321-8df1cf164a12" providerId="ADAL" clId="{454EBA3A-CFA7-4557-80A3-8406924164EC}"/>
+    <pc:docChg chg="undo custSel addSld delSld modSld sldOrd delSection modSection">
+      <pc:chgData name="Ridhima Dhawan" userId="41b5bd7b-df07-43ed-9321-8df1cf164a12" providerId="ADAL" clId="{454EBA3A-CFA7-4557-80A3-8406924164EC}" dt="2025-09-26T16:50:09.182" v="9258" actId="20577"/>
+      <pc:docMkLst>
+        <pc:docMk/>
+      </pc:docMkLst>
+      <pc:sldChg chg="modSp mod">
+        <pc:chgData name="Ridhima Dhawan" userId="41b5bd7b-df07-43ed-9321-8df1cf164a12" providerId="ADAL" clId="{454EBA3A-CFA7-4557-80A3-8406924164EC}" dt="2025-09-19T04:20:02.730" v="1329" actId="20577"/>
+        <pc:sldMkLst>
+          <pc:docMk/>
+          <pc:sldMk cId="0" sldId="274"/>
+        </pc:sldMkLst>
+      </pc:sldChg>
+      <pc:sldChg chg="modSp mod">
+        <pc:chgData name="Ridhima Dhawan" userId="41b5bd7b-df07-43ed-9321-8df1cf164a12" providerId="ADAL" clId="{454EBA3A-CFA7-4557-80A3-8406924164EC}" dt="2025-09-17T17:37:21.941" v="5" actId="20577"/>
+        <pc:sldMkLst>
+          <pc:docMk/>
+          <pc:sldMk cId="0" sldId="275"/>
+        </pc:sldMkLst>
+      </pc:sldChg>
+      <pc:sldChg chg="addSp delSp modSp mod">
+        <pc:chgData name="Ridhima Dhawan" userId="41b5bd7b-df07-43ed-9321-8df1cf164a12" providerId="ADAL" clId="{454EBA3A-CFA7-4557-80A3-8406924164EC}" dt="2025-09-23T16:11:19.018" v="2066" actId="14100"/>
+        <pc:sldMkLst>
+          <pc:docMk/>
+          <pc:sldMk cId="1694384516" sldId="285"/>
+        </pc:sldMkLst>
+      </pc:sldChg>
+      <pc:sldChg chg="addSp delSp modSp mod modNotesTx">
+        <pc:chgData name="Ridhima Dhawan" userId="41b5bd7b-df07-43ed-9321-8df1cf164a12" providerId="ADAL" clId="{454EBA3A-CFA7-4557-80A3-8406924164EC}" dt="2025-09-19T03:52:27.481" v="1232" actId="20577"/>
+        <pc:sldMkLst>
+          <pc:docMk/>
+          <pc:sldMk cId="3180984745" sldId="333"/>
+        </pc:sldMkLst>
+      </pc:sldChg>
+      <pc:sldChg chg="addSp delSp modSp mod ord modNotesTx">
+        <pc:chgData name="Ridhima Dhawan" userId="41b5bd7b-df07-43ed-9321-8df1cf164a12" providerId="ADAL" clId="{454EBA3A-CFA7-4557-80A3-8406924164EC}" dt="2025-09-25T15:58:08.681" v="9002" actId="20577"/>
+        <pc:sldMkLst>
+          <pc:docMk/>
+          <pc:sldMk cId="2675615646" sldId="419"/>
+        </pc:sldMkLst>
+      </pc:sldChg>
+      <pc:sldChg chg="del">
+        <pc:chgData name="Ridhima Dhawan" userId="41b5bd7b-df07-43ed-9321-8df1cf164a12" providerId="ADAL" clId="{454EBA3A-CFA7-4557-80A3-8406924164EC}" dt="2025-09-17T17:41:25.728" v="134" actId="47"/>
+        <pc:sldMkLst>
+          <pc:docMk/>
+          <pc:sldMk cId="1299622664" sldId="434"/>
+        </pc:sldMkLst>
+      </pc:sldChg>
+      <pc:sldChg chg="addSp delSp modSp add mod">
+        <pc:chgData name="Ridhima Dhawan" userId="41b5bd7b-df07-43ed-9321-8df1cf164a12" providerId="ADAL" clId="{454EBA3A-CFA7-4557-80A3-8406924164EC}" dt="2025-09-23T19:05:17.611" v="6364" actId="20577"/>
+        <pc:sldMkLst>
+          <pc:docMk/>
+          <pc:sldMk cId="2128657008" sldId="2147481209"/>
+        </pc:sldMkLst>
+      </pc:sldChg>
+      <pc:sldChg chg="addSp delSp modSp new mod ord">
+        <pc:chgData name="Ridhima Dhawan" userId="41b5bd7b-df07-43ed-9321-8df1cf164a12" providerId="ADAL" clId="{454EBA3A-CFA7-4557-80A3-8406924164EC}" dt="2025-09-25T15:39:08.861" v="8952" actId="1076"/>
+        <pc:sldMkLst>
+          <pc:docMk/>
+          <pc:sldMk cId="1105021549" sldId="2147481210"/>
+        </pc:sldMkLst>
+      </pc:sldChg>
+      <pc:sldChg chg="addSp delSp modSp add mod">
+        <pc:chgData name="Ridhima Dhawan" userId="41b5bd7b-df07-43ed-9321-8df1cf164a12" providerId="ADAL" clId="{454EBA3A-CFA7-4557-80A3-8406924164EC}" dt="2025-09-26T06:42:10.782" v="9233" actId="20577"/>
+        <pc:sldMkLst>
+          <pc:docMk/>
+          <pc:sldMk cId="323746144" sldId="2147481211"/>
+        </pc:sldMkLst>
+      </pc:sldChg>
+      <pc:sldChg chg="addSp delSp modSp add mod">
+        <pc:chgData name="Ridhima Dhawan" userId="41b5bd7b-df07-43ed-9321-8df1cf164a12" providerId="ADAL" clId="{454EBA3A-CFA7-4557-80A3-8406924164EC}" dt="2025-09-23T16:39:12.998" v="3725" actId="1076"/>
+        <pc:sldMkLst>
+          <pc:docMk/>
+          <pc:sldMk cId="83366420" sldId="2147481212"/>
+        </pc:sldMkLst>
+      </pc:sldChg>
+      <pc:sldChg chg="addSp delSp modSp add mod">
+        <pc:chgData name="Ridhima Dhawan" userId="41b5bd7b-df07-43ed-9321-8df1cf164a12" providerId="ADAL" clId="{454EBA3A-CFA7-4557-80A3-8406924164EC}" dt="2025-09-26T06:45:21.549" v="9234" actId="1076"/>
+        <pc:sldMkLst>
+          <pc:docMk/>
+          <pc:sldMk cId="1270242671" sldId="2147481213"/>
+        </pc:sldMkLst>
+        <pc:spChg chg="mod">
+          <ac:chgData name="Ridhima Dhawan" userId="41b5bd7b-df07-43ed-9321-8df1cf164a12" providerId="ADAL" clId="{454EBA3A-CFA7-4557-80A3-8406924164EC}" dt="2025-09-23T16:51:56.192" v="3918" actId="20577"/>
+          <ac:spMkLst>
+            <pc:docMk/>
+            <pc:sldMk cId="1270242671" sldId="2147481213"/>
+            <ac:spMk id="3" creationId="{BF8AA7B9-40BC-BD5B-A38F-B69FFA6E6319}"/>
+          </ac:spMkLst>
+        </pc:spChg>
+        <pc:spChg chg="add mod">
+          <ac:chgData name="Ridhima Dhawan" userId="41b5bd7b-df07-43ed-9321-8df1cf164a12" providerId="ADAL" clId="{454EBA3A-CFA7-4557-80A3-8406924164EC}" dt="2025-09-26T06:45:21.549" v="9234" actId="1076"/>
+          <ac:spMkLst>
+            <pc:docMk/>
+            <pc:sldMk cId="1270242671" sldId="2147481213"/>
+            <ac:spMk id="4" creationId="{F93D6D7D-FF3F-82F6-14A4-6285C0323998}"/>
+          </ac:spMkLst>
+        </pc:spChg>
+        <pc:graphicFrameChg chg="add mod modGraphic">
+          <ac:chgData name="Ridhima Dhawan" userId="41b5bd7b-df07-43ed-9321-8df1cf164a12" providerId="ADAL" clId="{454EBA3A-CFA7-4557-80A3-8406924164EC}" dt="2025-09-23T23:14:56.318" v="7961" actId="1076"/>
+          <ac:graphicFrameMkLst>
+            <pc:docMk/>
+            <pc:sldMk cId="1270242671" sldId="2147481213"/>
+            <ac:graphicFrameMk id="2" creationId="{38F22EE9-DEDC-E1DA-1E19-E1758E9C192D}"/>
+          </ac:graphicFrameMkLst>
+        </pc:graphicFrameChg>
+      </pc:sldChg>
+      <pc:sldChg chg="addSp delSp modSp add mod">
+        <pc:chgData name="Ridhima Dhawan" userId="41b5bd7b-df07-43ed-9321-8df1cf164a12" providerId="ADAL" clId="{454EBA3A-CFA7-4557-80A3-8406924164EC}" dt="2025-09-23T18:42:17.814" v="6250" actId="20577"/>
+        <pc:sldMkLst>
+          <pc:docMk/>
+          <pc:sldMk cId="1389874235" sldId="2147481214"/>
+        </pc:sldMkLst>
+      </pc:sldChg>
+      <pc:sldChg chg="modSp add mod">
+        <pc:chgData name="Ridhima Dhawan" userId="41b5bd7b-df07-43ed-9321-8df1cf164a12" providerId="ADAL" clId="{454EBA3A-CFA7-4557-80A3-8406924164EC}" dt="2025-09-17T17:51:09.912" v="323" actId="20577"/>
+        <pc:sldMkLst>
+          <pc:docMk/>
+          <pc:sldMk cId="3040778351" sldId="2147481215"/>
+        </pc:sldMkLst>
+      </pc:sldChg>
+      <pc:sldChg chg="delSp modSp add mod ord">
+        <pc:chgData name="Ridhima Dhawan" userId="41b5bd7b-df07-43ed-9321-8df1cf164a12" providerId="ADAL" clId="{454EBA3A-CFA7-4557-80A3-8406924164EC}" dt="2025-09-17T20:05:15.773" v="1049" actId="313"/>
+        <pc:sldMkLst>
+          <pc:docMk/>
+          <pc:sldMk cId="1707149320" sldId="2147481216"/>
+        </pc:sldMkLst>
+      </pc:sldChg>
+      <pc:sldChg chg="add">
+        <pc:chgData name="Ridhima Dhawan" userId="41b5bd7b-df07-43ed-9321-8df1cf164a12" providerId="ADAL" clId="{454EBA3A-CFA7-4557-80A3-8406924164EC}" dt="2025-09-19T04:19:51.802" v="1315" actId="2890"/>
+        <pc:sldMkLst>
+          <pc:docMk/>
+          <pc:sldMk cId="2307073506" sldId="2147481217"/>
+        </pc:sldMkLst>
+      </pc:sldChg>
+      <pc:sldChg chg="addSp delSp modSp add mod">
+        <pc:chgData name="Ridhima Dhawan" userId="41b5bd7b-df07-43ed-9321-8df1cf164a12" providerId="ADAL" clId="{454EBA3A-CFA7-4557-80A3-8406924164EC}" dt="2025-09-23T19:06:18.876" v="6365" actId="14100"/>
+        <pc:sldMkLst>
+          <pc:docMk/>
+          <pc:sldMk cId="145336846" sldId="2147481218"/>
+        </pc:sldMkLst>
+      </pc:sldChg>
+      <pc:sldChg chg="addSp delSp modSp new mod">
+        <pc:chgData name="Ridhima Dhawan" userId="41b5bd7b-df07-43ed-9321-8df1cf164a12" providerId="ADAL" clId="{454EBA3A-CFA7-4557-80A3-8406924164EC}" dt="2025-09-25T15:21:33.063" v="8938" actId="20577"/>
+        <pc:sldMkLst>
+          <pc:docMk/>
+          <pc:sldMk cId="2449955966" sldId="2147481220"/>
+        </pc:sldMkLst>
+      </pc:sldChg>
+      <pc:sldChg chg="addSp delSp modSp add mod">
+        <pc:chgData name="Ridhima Dhawan" userId="41b5bd7b-df07-43ed-9321-8df1cf164a12" providerId="ADAL" clId="{454EBA3A-CFA7-4557-80A3-8406924164EC}" dt="2025-09-23T23:12:20.625" v="7960" actId="1076"/>
+        <pc:sldMkLst>
+          <pc:docMk/>
+          <pc:sldMk cId="3753532281" sldId="2147481221"/>
+        </pc:sldMkLst>
+      </pc:sldChg>
+      <pc:sldChg chg="addSp delSp modSp add mod ord">
+        <pc:chgData name="Ridhima Dhawan" userId="41b5bd7b-df07-43ed-9321-8df1cf164a12" providerId="ADAL" clId="{454EBA3A-CFA7-4557-80A3-8406924164EC}" dt="2025-09-26T16:50:09.182" v="9258" actId="20577"/>
+        <pc:sldMkLst>
+          <pc:docMk/>
+          <pc:sldMk cId="1157813500" sldId="2147481222"/>
+        </pc:sldMkLst>
+      </pc:sldChg>
+      <pc:sldChg chg="addSp delSp modSp add mod ord replId">
+        <pc:chgData name="Ridhima Dhawan" userId="41b5bd7b-df07-43ed-9321-8df1cf164a12" providerId="ADAL" clId="{454EBA3A-CFA7-4557-80A3-8406924164EC}" dt="2025-09-23T18:24:32.029" v="5732" actId="20577"/>
+        <pc:sldMkLst>
+          <pc:docMk/>
+          <pc:sldMk cId="4242413873" sldId="2147481223"/>
+        </pc:sldMkLst>
+      </pc:sldChg>
+      <pc:sldChg chg="addSp delSp modSp add mod">
+        <pc:chgData name="Ridhima Dhawan" userId="41b5bd7b-df07-43ed-9321-8df1cf164a12" providerId="ADAL" clId="{454EBA3A-CFA7-4557-80A3-8406924164EC}" dt="2025-09-26T06:40:51.484" v="9216" actId="404"/>
+        <pc:sldMkLst>
+          <pc:docMk/>
+          <pc:sldMk cId="3621352377" sldId="2147481224"/>
+        </pc:sldMkLst>
+      </pc:sldChg>
+      <pc:sldChg chg="addSp delSp modSp add mod">
+        <pc:chgData name="Ridhima Dhawan" userId="41b5bd7b-df07-43ed-9321-8df1cf164a12" providerId="ADAL" clId="{454EBA3A-CFA7-4557-80A3-8406924164EC}" dt="2025-09-25T15:39:35.496" v="8966" actId="20577"/>
+        <pc:sldMkLst>
+          <pc:docMk/>
+          <pc:sldMk cId="2178493738" sldId="2147481225"/>
+        </pc:sldMkLst>
+      </pc:sldChg>
+      <pc:sldChg chg="delSp modSp add mod">
+        <pc:chgData name="Ridhima Dhawan" userId="41b5bd7b-df07-43ed-9321-8df1cf164a12" providerId="ADAL" clId="{454EBA3A-CFA7-4557-80A3-8406924164EC}" dt="2025-09-25T18:48:13.249" v="9135" actId="20577"/>
+        <pc:sldMkLst>
+          <pc:docMk/>
+          <pc:sldMk cId="1394883244" sldId="2147481226"/>
+        </pc:sldMkLst>
+      </pc:sldChg>
+      <pc:sldChg chg="addSp delSp modSp add mod">
+        <pc:chgData name="Ridhima Dhawan" userId="41b5bd7b-df07-43ed-9321-8df1cf164a12" providerId="ADAL" clId="{454EBA3A-CFA7-4557-80A3-8406924164EC}" dt="2025-09-25T15:59:22.730" v="9080" actId="20577"/>
+        <pc:sldMkLst>
+          <pc:docMk/>
+          <pc:sldMk cId="2560992972" sldId="2147481227"/>
+        </pc:sldMkLst>
+      </pc:sldChg>
+      <pc:sldChg chg="modSp add mod">
+        <pc:chgData name="Ridhima Dhawan" userId="41b5bd7b-df07-43ed-9321-8df1cf164a12" providerId="ADAL" clId="{454EBA3A-CFA7-4557-80A3-8406924164EC}" dt="2025-09-25T15:59:30.763" v="9087" actId="20577"/>
+        <pc:sldMkLst>
+          <pc:docMk/>
+          <pc:sldMk cId="427855662" sldId="2147481228"/>
+        </pc:sldMkLst>
+      </pc:sldChg>
+      <pc:sldMasterChg chg="delSldLayout">
+        <pc:chgData name="Ridhima Dhawan" userId="41b5bd7b-df07-43ed-9321-8df1cf164a12" providerId="ADAL" clId="{454EBA3A-CFA7-4557-80A3-8406924164EC}" dt="2025-09-23T16:11:22.319" v="2067" actId="47"/>
+        <pc:sldMasterMkLst>
+          <pc:docMk/>
+          <pc:sldMasterMk cId="1804289383" sldId="2147483648"/>
+        </pc:sldMasterMkLst>
+      </pc:sldMasterChg>
     </pc:docChg>
   </pc:docChgLst>
 </pc:chgInfo>
@@ -3236,7 +3236,7 @@
           <a:p>
             <a:fld id="{C2486858-BEB2-AA4A-AEF7-6C259965A833}" type="datetimeFigureOut">
               <a:rPr lang="en-US" smtClean="0"/>
-              <a:t>10/20/25</a:t>
+              <a:t>1/13/26</a:t>
             </a:fld>
             <a:endParaRPr lang="en-US"/>
           </a:p>
@@ -3335,7 +3335,7 @@
           <a:p>
             <a:fld id="{DE650B3E-2EAB-E847-9859-1E8EF3D97F17}" type="datetimeFigureOut">
               <a:rPr lang="en-US" smtClean="0"/>
-              <a:t>10/20/25</a:t>
+              <a:t>1/13/26</a:t>
             </a:fld>
             <a:endParaRPr lang="en-US"/>
           </a:p>
@@ -4610,7 +4610,7 @@
           </p:cNvGraphicFramePr>
           <p:nvPr userDrawn="1">
             <p:custDataLst>
-              <p:tags r:id="rId1"/>
+              <p:tags r:id="rId2"/>
             </p:custDataLst>
           </p:nvPr>
         </p:nvGraphicFramePr>
@@ -4622,12 +4622,12 @@
           <a:graphicData uri="http://schemas.openxmlformats.org/presentationml/2006/ole">
             <mc:AlternateContent xmlns:mc="http://schemas.openxmlformats.org/markup-compatibility/2006">
               <mc:Choice xmlns:v="urn:schemas-microsoft-com:vml" Requires="v">
-                <p:oleObj name="think-cell Slide" r:id="rId3" imgW="592" imgH="595" progId="TCLayout.ActiveDocument.1">
+                <p:oleObj spid="_x0000_s1025" name="think-cell Slide" r:id="rId4" imgW="592" imgH="595" progId="TCLayout.ActiveDocument.1">
                   <p:embed/>
                 </p:oleObj>
               </mc:Choice>
               <mc:Fallback>
-                <p:oleObj name="think-cell Slide" r:id="rId3" imgW="592" imgH="595" progId="TCLayout.ActiveDocument.1">
+                <p:oleObj name="think-cell Slide" r:id="rId4" imgW="592" imgH="595" progId="TCLayout.ActiveDocument.1">
                   <p:embed/>
                   <p:pic>
                     <p:nvPicPr>
@@ -4642,7 +4642,7 @@
                       <p:nvPr/>
                     </p:nvPicPr>
                     <p:blipFill>
-                      <a:blip r:embed="rId4"/>
+                      <a:blip r:embed="rId5"/>
                       <a:stretch>
                         <a:fillRect/>
                       </a:stretch>
@@ -4952,7 +4952,7 @@
             <p:nvPr userDrawn="1"/>
           </p:nvPicPr>
           <p:blipFill>
-            <a:blip r:embed="rId5"/>
+            <a:blip r:embed="rId6"/>
             <a:stretch>
               <a:fillRect/>
             </a:stretch>
@@ -12984,7 +12984,7 @@
             <a:fld id="{ADA417E5-1A75-45D7-BDE0-29E7A6B38811}" type="datetimeFigureOut">
               <a:rPr lang="en-US" smtClean="0"/>
               <a:pPr/>
-              <a:t>10/20/25</a:t>
+              <a:t>1/13/26</a:t>
             </a:fld>
             <a:endParaRPr lang="en-US"/>
           </a:p>
@@ -16208,14 +16208,14 @@
           <p:nvPr>
             <p:extLst>
               <p:ext uri="{D42A27DB-BD31-4B8C-83A1-F6EECF244321}">
-                <p14:modId xmlns:p14="http://schemas.microsoft.com/office/powerpoint/2010/main" val="1548320033"/>
+                <p14:modId xmlns:p14="http://schemas.microsoft.com/office/powerpoint/2010/main" val="972250586"/>
               </p:ext>
             </p:extLst>
           </p:nvPr>
         </p:nvGraphicFramePr>
         <p:xfrm>
-          <a:off x="4183094" y="457202"/>
-          <a:ext cx="7505700" cy="6139772"/>
+          <a:off x="3174101" y="457202"/>
+          <a:ext cx="7505702" cy="6232607"/>
         </p:xfrm>
         <a:graphic>
           <a:graphicData uri="http://schemas.openxmlformats.org/drawingml/2006/table">
@@ -16224,38 +16224,73 @@
                 <a:tableStyleId>{72833802-FEF1-4C79-8D5D-14CF1EAF98D9}</a:tableStyleId>
               </a:tblPr>
               <a:tblGrid>
-                <a:gridCol w="864020">
+                <a:gridCol w="300454">
                   <a:extLst>
                     <a:ext uri="{9D8B030D-6E8A-4147-A177-3AD203B41FA5}">
                       <a16:colId xmlns:a16="http://schemas.microsoft.com/office/drawing/2014/main" val="4043450700"/>
                     </a:ext>
                   </a:extLst>
                 </a:gridCol>
-                <a:gridCol w="921609">
+                <a:gridCol w="320480">
                   <a:extLst>
                     <a:ext uri="{9D8B030D-6E8A-4147-A177-3AD203B41FA5}">
                       <a16:colId xmlns:a16="http://schemas.microsoft.com/office/drawing/2014/main" val="3892022578"/>
                     </a:ext>
                   </a:extLst>
                 </a:gridCol>
-                <a:gridCol w="4167484">
+                <a:gridCol w="1449199">
                   <a:extLst>
                     <a:ext uri="{9D8B030D-6E8A-4147-A177-3AD203B41FA5}">
                       <a16:colId xmlns:a16="http://schemas.microsoft.com/office/drawing/2014/main" val="1855649917"/>
                     </a:ext>
                   </a:extLst>
                 </a:gridCol>
-                <a:gridCol w="764532">
+                <a:gridCol w="1449199">
+                  <a:extLst>
+                    <a:ext uri="{9D8B030D-6E8A-4147-A177-3AD203B41FA5}">
+                      <a16:colId xmlns:a16="http://schemas.microsoft.com/office/drawing/2014/main" val="2553423217"/>
+                    </a:ext>
+                  </a:extLst>
+                </a:gridCol>
+                <a:gridCol w="1449199">
+                  <a:extLst>
+                    <a:ext uri="{9D8B030D-6E8A-4147-A177-3AD203B41FA5}">
+                      <a16:colId xmlns:a16="http://schemas.microsoft.com/office/drawing/2014/main" val="4289153929"/>
+                    </a:ext>
+                  </a:extLst>
+                </a:gridCol>
+                <a:gridCol w="1449199">
+                  <a:extLst>
+                    <a:ext uri="{9D8B030D-6E8A-4147-A177-3AD203B41FA5}">
+                      <a16:colId xmlns:a16="http://schemas.microsoft.com/office/drawing/2014/main" val="3706998436"/>
+                    </a:ext>
+                  </a:extLst>
+                </a:gridCol>
+                <a:gridCol w="265858">
                   <a:extLst>
                     <a:ext uri="{9D8B030D-6E8A-4147-A177-3AD203B41FA5}">
                       <a16:colId xmlns:a16="http://schemas.microsoft.com/office/drawing/2014/main" val="2220294652"/>
                     </a:ext>
                   </a:extLst>
                 </a:gridCol>
-                <a:gridCol w="788055">
+                <a:gridCol w="274038">
                   <a:extLst>
                     <a:ext uri="{9D8B030D-6E8A-4147-A177-3AD203B41FA5}">
                       <a16:colId xmlns:a16="http://schemas.microsoft.com/office/drawing/2014/main" val="273073370"/>
+                    </a:ext>
+                  </a:extLst>
+                </a:gridCol>
+                <a:gridCol w="274038">
+                  <a:extLst>
+                    <a:ext uri="{9D8B030D-6E8A-4147-A177-3AD203B41FA5}">
+                      <a16:colId xmlns:a16="http://schemas.microsoft.com/office/drawing/2014/main" val="1662952939"/>
+                    </a:ext>
+                  </a:extLst>
+                </a:gridCol>
+                <a:gridCol w="274038">
+                  <a:extLst>
+                    <a:ext uri="{9D8B030D-6E8A-4147-A177-3AD203B41FA5}">
+                      <a16:colId xmlns:a16="http://schemas.microsoft.com/office/drawing/2014/main" val="3276163194"/>
                     </a:ext>
                   </a:extLst>
                 </a:gridCol>
@@ -16345,6 +16380,75 @@
                     <a:lstStyle/>
                     <a:p>
                       <a:pPr marL="0" algn="ctr" defTabSz="914400" rtl="0" eaLnBrk="1" fontAlgn="b" latinLnBrk="0" hangingPunct="1"/>
+                      <a:endParaRPr lang="en-US" sz="1200" b="1" u="none" strike="noStrike" kern="1200" dirty="0">
+                        <a:solidFill>
+                          <a:schemeClr val="bg1"/>
+                        </a:solidFill>
+                        <a:effectLst/>
+                        <a:latin typeface="+mn-lt"/>
+                        <a:ea typeface="+mn-ea"/>
+                        <a:cs typeface="+mn-cs"/>
+                      </a:endParaRPr>
+                    </a:p>
+                  </a:txBody>
+                  <a:tcPr marL="4778" marR="4778" marT="4778" marB="0" anchor="ctr">
+                    <a:solidFill>
+                      <a:schemeClr val="accent6"/>
+                    </a:solidFill>
+                  </a:tcPr>
+                </a:tc>
+                <a:tc>
+                  <a:txBody>
+                    <a:bodyPr/>
+                    <a:lstStyle/>
+                    <a:p>
+                      <a:pPr marL="0" algn="ctr" defTabSz="914400" rtl="0" eaLnBrk="1" fontAlgn="b" latinLnBrk="0" hangingPunct="1"/>
+                      <a:endParaRPr lang="en-US" sz="1200" b="1" u="none" strike="noStrike" kern="1200" dirty="0">
+                        <a:solidFill>
+                          <a:schemeClr val="bg1"/>
+                        </a:solidFill>
+                        <a:effectLst/>
+                        <a:latin typeface="+mn-lt"/>
+                        <a:ea typeface="+mn-ea"/>
+                        <a:cs typeface="+mn-cs"/>
+                      </a:endParaRPr>
+                    </a:p>
+                  </a:txBody>
+                  <a:tcPr marL="4778" marR="4778" marT="4778" marB="0" anchor="ctr">
+                    <a:solidFill>
+                      <a:schemeClr val="accent6"/>
+                    </a:solidFill>
+                  </a:tcPr>
+                </a:tc>
+                <a:tc>
+                  <a:txBody>
+                    <a:bodyPr/>
+                    <a:lstStyle/>
+                    <a:p>
+                      <a:pPr marL="0" algn="ctr" defTabSz="914400" rtl="0" eaLnBrk="1" fontAlgn="b" latinLnBrk="0" hangingPunct="1"/>
+                      <a:endParaRPr lang="en-US" sz="1200" b="1" u="none" strike="noStrike" kern="1200" dirty="0">
+                        <a:solidFill>
+                          <a:schemeClr val="bg1"/>
+                        </a:solidFill>
+                        <a:effectLst/>
+                        <a:latin typeface="+mn-lt"/>
+                        <a:ea typeface="+mn-ea"/>
+                        <a:cs typeface="+mn-cs"/>
+                      </a:endParaRPr>
+                    </a:p>
+                  </a:txBody>
+                  <a:tcPr marL="4778" marR="4778" marT="4778" marB="0" anchor="ctr">
+                    <a:solidFill>
+                      <a:schemeClr val="accent6"/>
+                    </a:solidFill>
+                  </a:tcPr>
+                </a:tc>
+                <a:tc>
+                  <a:txBody>
+                    <a:bodyPr/>
+                    <a:lstStyle/>
+                    <a:p>
+                      <a:pPr marL="0" algn="ctr" defTabSz="914400" rtl="0" eaLnBrk="1" fontAlgn="b" latinLnBrk="0" hangingPunct="1"/>
                       <a:r>
                         <a:rPr lang="en-US" sz="1200" b="1" u="none" strike="noStrike" kern="1200" dirty="0">
                           <a:solidFill>
@@ -16383,6 +16487,52 @@
                         </a:rPr>
                         <a:t>CTR</a:t>
                       </a:r>
+                    </a:p>
+                  </a:txBody>
+                  <a:tcPr marL="4778" marR="4778" marT="4778" marB="0" anchor="ctr">
+                    <a:solidFill>
+                      <a:schemeClr val="accent6"/>
+                    </a:solidFill>
+                  </a:tcPr>
+                </a:tc>
+                <a:tc>
+                  <a:txBody>
+                    <a:bodyPr/>
+                    <a:lstStyle/>
+                    <a:p>
+                      <a:pPr marL="0" algn="ctr" defTabSz="914400" rtl="0" eaLnBrk="1" fontAlgn="b" latinLnBrk="0" hangingPunct="1"/>
+                      <a:endParaRPr lang="en-US" sz="1200" b="1" u="none" strike="noStrike" kern="1200" dirty="0">
+                        <a:solidFill>
+                          <a:schemeClr val="bg1"/>
+                        </a:solidFill>
+                        <a:effectLst/>
+                        <a:latin typeface="+mn-lt"/>
+                        <a:ea typeface="+mn-ea"/>
+                        <a:cs typeface="+mn-cs"/>
+                      </a:endParaRPr>
+                    </a:p>
+                  </a:txBody>
+                  <a:tcPr marL="4778" marR="4778" marT="4778" marB="0" anchor="ctr">
+                    <a:solidFill>
+                      <a:schemeClr val="accent6"/>
+                    </a:solidFill>
+                  </a:tcPr>
+                </a:tc>
+                <a:tc>
+                  <a:txBody>
+                    <a:bodyPr/>
+                    <a:lstStyle/>
+                    <a:p>
+                      <a:pPr marL="0" algn="ctr" defTabSz="914400" rtl="0" eaLnBrk="1" fontAlgn="b" latinLnBrk="0" hangingPunct="1"/>
+                      <a:endParaRPr lang="en-US" sz="1200" b="1" u="none" strike="noStrike" kern="1200" dirty="0">
+                        <a:solidFill>
+                          <a:schemeClr val="bg1"/>
+                        </a:solidFill>
+                        <a:effectLst/>
+                        <a:latin typeface="+mn-lt"/>
+                        <a:ea typeface="+mn-ea"/>
+                        <a:cs typeface="+mn-cs"/>
+                      </a:endParaRPr>
                     </a:p>
                   </a:txBody>
                   <a:tcPr marL="4778" marR="4778" marT="4778" marB="0" anchor="ctr">
@@ -16475,6 +16625,63 @@
                     <a:bodyPr/>
                     <a:lstStyle/>
                     <a:p>
+                      <a:pPr algn="ctr" fontAlgn="t"/>
+                      <a:endParaRPr lang="en-US" sz="1200" b="0" i="0" u="none" strike="noStrike" kern="1200" dirty="0">
+                        <a:solidFill>
+                          <a:schemeClr val="tx1"/>
+                        </a:solidFill>
+                        <a:effectLst/>
+                        <a:latin typeface="+mn-lt"/>
+                        <a:ea typeface="+mn-ea"/>
+                        <a:cs typeface="Calibri" panose="020F0502020204030204" pitchFamily="34" charset="0"/>
+                      </a:endParaRPr>
+                    </a:p>
+                  </a:txBody>
+                  <a:tcPr anchor="ctr"/>
+                </a:tc>
+                <a:tc>
+                  <a:txBody>
+                    <a:bodyPr/>
+                    <a:lstStyle/>
+                    <a:p>
+                      <a:pPr algn="ctr" fontAlgn="t"/>
+                      <a:endParaRPr lang="en-US" sz="1200" b="0" i="0" u="none" strike="noStrike" kern="1200" dirty="0">
+                        <a:solidFill>
+                          <a:schemeClr val="tx1"/>
+                        </a:solidFill>
+                        <a:effectLst/>
+                        <a:latin typeface="+mn-lt"/>
+                        <a:ea typeface="+mn-ea"/>
+                        <a:cs typeface="Calibri" panose="020F0502020204030204" pitchFamily="34" charset="0"/>
+                      </a:endParaRPr>
+                    </a:p>
+                  </a:txBody>
+                  <a:tcPr anchor="ctr"/>
+                </a:tc>
+                <a:tc>
+                  <a:txBody>
+                    <a:bodyPr/>
+                    <a:lstStyle/>
+                    <a:p>
+                      <a:pPr algn="ctr" fontAlgn="t"/>
+                      <a:endParaRPr lang="en-US" sz="1200" b="0" i="0" u="none" strike="noStrike" kern="1200" dirty="0">
+                        <a:solidFill>
+                          <a:schemeClr val="tx1"/>
+                        </a:solidFill>
+                        <a:effectLst/>
+                        <a:latin typeface="+mn-lt"/>
+                        <a:ea typeface="+mn-ea"/>
+                        <a:cs typeface="Calibri" panose="020F0502020204030204" pitchFamily="34" charset="0"/>
+                      </a:endParaRPr>
+                    </a:p>
+                  </a:txBody>
+                  <a:tcPr anchor="ctr"/>
+                </a:tc>
+                <a:tc>
+                  <a:txBody>
+                    <a:bodyPr/>
+                    <a:lstStyle/>
+                    <a:p>
                       <a:pPr algn="ctr" fontAlgn="b"/>
                       <a:r>
                         <a:rPr lang="en-US" sz="1200" b="0" i="0" u="none" strike="noStrike" dirty="0">
@@ -16516,6 +16723,42 @@
                         </a:rPr>
                         <a:t>insert</a:t>
                       </a:r>
+                      <a:endParaRPr lang="en-US" sz="1200" b="0" i="0" u="none" strike="noStrike" dirty="0">
+                        <a:solidFill>
+                          <a:srgbClr val="000000"/>
+                        </a:solidFill>
+                        <a:effectLst/>
+                        <a:latin typeface="+mn-lt"/>
+                        <a:cs typeface="Calibri" panose="020F0502020204030204" pitchFamily="34" charset="0"/>
+                      </a:endParaRPr>
+                    </a:p>
+                  </a:txBody>
+                  <a:tcPr marL="0" marR="0" marT="0" marB="0" anchor="ctr"/>
+                </a:tc>
+                <a:tc>
+                  <a:txBody>
+                    <a:bodyPr/>
+                    <a:lstStyle/>
+                    <a:p>
+                      <a:pPr algn="ctr" fontAlgn="b"/>
+                      <a:endParaRPr lang="en-US" sz="1200" b="0" i="0" u="none" strike="noStrike" dirty="0">
+                        <a:solidFill>
+                          <a:srgbClr val="000000"/>
+                        </a:solidFill>
+                        <a:effectLst/>
+                        <a:latin typeface="+mn-lt"/>
+                        <a:cs typeface="Calibri" panose="020F0502020204030204" pitchFamily="34" charset="0"/>
+                      </a:endParaRPr>
+                    </a:p>
+                  </a:txBody>
+                  <a:tcPr marL="0" marR="0" marT="0" marB="0" anchor="ctr"/>
+                </a:tc>
+                <a:tc>
+                  <a:txBody>
+                    <a:bodyPr/>
+                    <a:lstStyle/>
+                    <a:p>
+                      <a:pPr algn="ctr" fontAlgn="b"/>
                       <a:endParaRPr lang="en-US" sz="1200" b="0" i="0" u="none" strike="noStrike" dirty="0">
                         <a:solidFill>
                           <a:srgbClr val="000000"/>
@@ -16624,6 +16867,75 @@
                     <a:bodyPr/>
                     <a:lstStyle/>
                     <a:p>
+                      <a:pPr algn="ctr" fontAlgn="t"/>
+                      <a:endParaRPr lang="en-US" sz="1200" b="0" i="0" u="none" strike="noStrike" kern="1200" dirty="0">
+                        <a:solidFill>
+                          <a:schemeClr val="tx1"/>
+                        </a:solidFill>
+                        <a:effectLst/>
+                        <a:latin typeface="+mn-lt"/>
+                        <a:ea typeface="+mn-ea"/>
+                        <a:cs typeface="Calibri" panose="020F0502020204030204" pitchFamily="34" charset="0"/>
+                      </a:endParaRPr>
+                    </a:p>
+                  </a:txBody>
+                  <a:tcPr anchor="ctr">
+                    <a:solidFill>
+                      <a:schemeClr val="bg2"/>
+                    </a:solidFill>
+                  </a:tcPr>
+                </a:tc>
+                <a:tc>
+                  <a:txBody>
+                    <a:bodyPr/>
+                    <a:lstStyle/>
+                    <a:p>
+                      <a:pPr algn="ctr" fontAlgn="t"/>
+                      <a:endParaRPr lang="en-US" sz="1200" b="0" i="0" u="none" strike="noStrike" kern="1200" dirty="0">
+                        <a:solidFill>
+                          <a:schemeClr val="tx1"/>
+                        </a:solidFill>
+                        <a:effectLst/>
+                        <a:latin typeface="+mn-lt"/>
+                        <a:ea typeface="+mn-ea"/>
+                        <a:cs typeface="Calibri" panose="020F0502020204030204" pitchFamily="34" charset="0"/>
+                      </a:endParaRPr>
+                    </a:p>
+                  </a:txBody>
+                  <a:tcPr anchor="ctr">
+                    <a:solidFill>
+                      <a:schemeClr val="bg2"/>
+                    </a:solidFill>
+                  </a:tcPr>
+                </a:tc>
+                <a:tc>
+                  <a:txBody>
+                    <a:bodyPr/>
+                    <a:lstStyle/>
+                    <a:p>
+                      <a:pPr algn="ctr" fontAlgn="t"/>
+                      <a:endParaRPr lang="en-US" sz="1200" b="0" i="0" u="none" strike="noStrike" kern="1200" dirty="0">
+                        <a:solidFill>
+                          <a:schemeClr val="tx1"/>
+                        </a:solidFill>
+                        <a:effectLst/>
+                        <a:latin typeface="+mn-lt"/>
+                        <a:ea typeface="+mn-ea"/>
+                        <a:cs typeface="Calibri" panose="020F0502020204030204" pitchFamily="34" charset="0"/>
+                      </a:endParaRPr>
+                    </a:p>
+                  </a:txBody>
+                  <a:tcPr anchor="ctr">
+                    <a:solidFill>
+                      <a:schemeClr val="bg2"/>
+                    </a:solidFill>
+                  </a:tcPr>
+                </a:tc>
+                <a:tc>
+                  <a:txBody>
+                    <a:bodyPr/>
+                    <a:lstStyle/>
+                    <a:p>
                       <a:pPr algn="ctr" fontAlgn="b"/>
                       <a:r>
                         <a:rPr lang="en-US" sz="1200" b="0" i="0" u="none" strike="noStrike" dirty="0">
@@ -16669,6 +16981,50 @@
                         </a:rPr>
                         <a:t>insert</a:t>
                       </a:r>
+                      <a:endParaRPr lang="en-US" sz="1200" b="0" i="0" u="none" strike="noStrike" dirty="0">
+                        <a:solidFill>
+                          <a:srgbClr val="000000"/>
+                        </a:solidFill>
+                        <a:effectLst/>
+                        <a:latin typeface="+mn-lt"/>
+                        <a:cs typeface="Calibri" panose="020F0502020204030204" pitchFamily="34" charset="0"/>
+                      </a:endParaRPr>
+                    </a:p>
+                  </a:txBody>
+                  <a:tcPr marL="0" marR="0" marT="0" marB="0" anchor="ctr">
+                    <a:solidFill>
+                      <a:schemeClr val="bg2"/>
+                    </a:solidFill>
+                  </a:tcPr>
+                </a:tc>
+                <a:tc>
+                  <a:txBody>
+                    <a:bodyPr/>
+                    <a:lstStyle/>
+                    <a:p>
+                      <a:pPr algn="ctr" fontAlgn="b"/>
+                      <a:endParaRPr lang="en-US" sz="1200" b="0" i="0" u="none" strike="noStrike" dirty="0">
+                        <a:solidFill>
+                          <a:srgbClr val="000000"/>
+                        </a:solidFill>
+                        <a:effectLst/>
+                        <a:latin typeface="+mn-lt"/>
+                        <a:cs typeface="Calibri" panose="020F0502020204030204" pitchFamily="34" charset="0"/>
+                      </a:endParaRPr>
+                    </a:p>
+                  </a:txBody>
+                  <a:tcPr marL="0" marR="0" marT="0" marB="0" anchor="ctr">
+                    <a:solidFill>
+                      <a:schemeClr val="bg2"/>
+                    </a:solidFill>
+                  </a:tcPr>
+                </a:tc>
+                <a:tc>
+                  <a:txBody>
+                    <a:bodyPr/>
+                    <a:lstStyle/>
+                    <a:p>
+                      <a:pPr algn="ctr" fontAlgn="b"/>
                       <a:endParaRPr lang="en-US" sz="1200" b="0" i="0" u="none" strike="noStrike" dirty="0">
                         <a:solidFill>
                           <a:srgbClr val="000000"/>
@@ -16769,6 +17125,63 @@
                     <a:bodyPr/>
                     <a:lstStyle/>
                     <a:p>
+                      <a:pPr algn="ctr" fontAlgn="t"/>
+                      <a:endParaRPr lang="en-US" sz="1200" b="0" i="0" u="none" strike="noStrike" kern="1200" dirty="0">
+                        <a:solidFill>
+                          <a:schemeClr val="tx1"/>
+                        </a:solidFill>
+                        <a:effectLst/>
+                        <a:latin typeface="+mn-lt"/>
+                        <a:ea typeface="+mn-ea"/>
+                        <a:cs typeface="Calibri" panose="020F0502020204030204" pitchFamily="34" charset="0"/>
+                      </a:endParaRPr>
+                    </a:p>
+                  </a:txBody>
+                  <a:tcPr anchor="ctr"/>
+                </a:tc>
+                <a:tc>
+                  <a:txBody>
+                    <a:bodyPr/>
+                    <a:lstStyle/>
+                    <a:p>
+                      <a:pPr algn="ctr" fontAlgn="t"/>
+                      <a:endParaRPr lang="en-US" sz="1200" b="0" i="0" u="none" strike="noStrike" kern="1200" dirty="0">
+                        <a:solidFill>
+                          <a:schemeClr val="tx1"/>
+                        </a:solidFill>
+                        <a:effectLst/>
+                        <a:latin typeface="+mn-lt"/>
+                        <a:ea typeface="+mn-ea"/>
+                        <a:cs typeface="Calibri" panose="020F0502020204030204" pitchFamily="34" charset="0"/>
+                      </a:endParaRPr>
+                    </a:p>
+                  </a:txBody>
+                  <a:tcPr anchor="ctr"/>
+                </a:tc>
+                <a:tc>
+                  <a:txBody>
+                    <a:bodyPr/>
+                    <a:lstStyle/>
+                    <a:p>
+                      <a:pPr algn="ctr" fontAlgn="t"/>
+                      <a:endParaRPr lang="en-US" sz="1200" b="0" i="0" u="none" strike="noStrike" kern="1200" dirty="0">
+                        <a:solidFill>
+                          <a:schemeClr val="tx1"/>
+                        </a:solidFill>
+                        <a:effectLst/>
+                        <a:latin typeface="+mn-lt"/>
+                        <a:ea typeface="+mn-ea"/>
+                        <a:cs typeface="Calibri" panose="020F0502020204030204" pitchFamily="34" charset="0"/>
+                      </a:endParaRPr>
+                    </a:p>
+                  </a:txBody>
+                  <a:tcPr anchor="ctr"/>
+                </a:tc>
+                <a:tc>
+                  <a:txBody>
+                    <a:bodyPr/>
+                    <a:lstStyle/>
+                    <a:p>
                       <a:pPr algn="ctr" fontAlgn="b"/>
                       <a:r>
                         <a:rPr lang="en-US" sz="1200" b="0" i="0" u="none" strike="noStrike" dirty="0">
@@ -16810,6 +17223,42 @@
                         </a:rPr>
                         <a:t>insert</a:t>
                       </a:r>
+                      <a:endParaRPr lang="en-US" sz="1200" b="0" i="0" u="none" strike="noStrike" dirty="0">
+                        <a:solidFill>
+                          <a:srgbClr val="000000"/>
+                        </a:solidFill>
+                        <a:effectLst/>
+                        <a:latin typeface="+mn-lt"/>
+                        <a:cs typeface="Calibri" panose="020F0502020204030204" pitchFamily="34" charset="0"/>
+                      </a:endParaRPr>
+                    </a:p>
+                  </a:txBody>
+                  <a:tcPr marL="0" marR="0" marT="0" marB="0" anchor="ctr"/>
+                </a:tc>
+                <a:tc>
+                  <a:txBody>
+                    <a:bodyPr/>
+                    <a:lstStyle/>
+                    <a:p>
+                      <a:pPr algn="ctr" fontAlgn="b"/>
+                      <a:endParaRPr lang="en-US" sz="1200" b="0" i="0" u="none" strike="noStrike" dirty="0">
+                        <a:solidFill>
+                          <a:srgbClr val="000000"/>
+                        </a:solidFill>
+                        <a:effectLst/>
+                        <a:latin typeface="+mn-lt"/>
+                        <a:cs typeface="Calibri" panose="020F0502020204030204" pitchFamily="34" charset="0"/>
+                      </a:endParaRPr>
+                    </a:p>
+                  </a:txBody>
+                  <a:tcPr marL="0" marR="0" marT="0" marB="0" anchor="ctr"/>
+                </a:tc>
+                <a:tc>
+                  <a:txBody>
+                    <a:bodyPr/>
+                    <a:lstStyle/>
+                    <a:p>
+                      <a:pPr algn="ctr" fontAlgn="b"/>
                       <a:endParaRPr lang="en-US" sz="1200" b="0" i="0" u="none" strike="noStrike" dirty="0">
                         <a:solidFill>
                           <a:srgbClr val="000000"/>
@@ -16918,6 +17367,75 @@
                     <a:bodyPr/>
                     <a:lstStyle/>
                     <a:p>
+                      <a:pPr algn="ctr" fontAlgn="t"/>
+                      <a:endParaRPr lang="en-US" sz="1200" b="0" i="0" u="none" strike="noStrike" kern="1200" dirty="0">
+                        <a:solidFill>
+                          <a:schemeClr val="tx1"/>
+                        </a:solidFill>
+                        <a:effectLst/>
+                        <a:latin typeface="+mn-lt"/>
+                        <a:ea typeface="+mn-ea"/>
+                        <a:cs typeface="Calibri" panose="020F0502020204030204" pitchFamily="34" charset="0"/>
+                      </a:endParaRPr>
+                    </a:p>
+                  </a:txBody>
+                  <a:tcPr anchor="ctr">
+                    <a:solidFill>
+                      <a:schemeClr val="bg2"/>
+                    </a:solidFill>
+                  </a:tcPr>
+                </a:tc>
+                <a:tc>
+                  <a:txBody>
+                    <a:bodyPr/>
+                    <a:lstStyle/>
+                    <a:p>
+                      <a:pPr algn="ctr" fontAlgn="t"/>
+                      <a:endParaRPr lang="en-US" sz="1200" b="0" i="0" u="none" strike="noStrike" kern="1200" dirty="0">
+                        <a:solidFill>
+                          <a:schemeClr val="tx1"/>
+                        </a:solidFill>
+                        <a:effectLst/>
+                        <a:latin typeface="+mn-lt"/>
+                        <a:ea typeface="+mn-ea"/>
+                        <a:cs typeface="Calibri" panose="020F0502020204030204" pitchFamily="34" charset="0"/>
+                      </a:endParaRPr>
+                    </a:p>
+                  </a:txBody>
+                  <a:tcPr anchor="ctr">
+                    <a:solidFill>
+                      <a:schemeClr val="bg2"/>
+                    </a:solidFill>
+                  </a:tcPr>
+                </a:tc>
+                <a:tc>
+                  <a:txBody>
+                    <a:bodyPr/>
+                    <a:lstStyle/>
+                    <a:p>
+                      <a:pPr algn="ctr" fontAlgn="t"/>
+                      <a:endParaRPr lang="en-US" sz="1200" b="0" i="0" u="none" strike="noStrike" kern="1200" dirty="0">
+                        <a:solidFill>
+                          <a:schemeClr val="tx1"/>
+                        </a:solidFill>
+                        <a:effectLst/>
+                        <a:latin typeface="+mn-lt"/>
+                        <a:ea typeface="+mn-ea"/>
+                        <a:cs typeface="Calibri" panose="020F0502020204030204" pitchFamily="34" charset="0"/>
+                      </a:endParaRPr>
+                    </a:p>
+                  </a:txBody>
+                  <a:tcPr anchor="ctr">
+                    <a:solidFill>
+                      <a:schemeClr val="bg2"/>
+                    </a:solidFill>
+                  </a:tcPr>
+                </a:tc>
+                <a:tc>
+                  <a:txBody>
+                    <a:bodyPr/>
+                    <a:lstStyle/>
+                    <a:p>
                       <a:pPr algn="ctr" fontAlgn="b"/>
                       <a:r>
                         <a:rPr lang="en-US" sz="1200" b="0" i="0" u="none" strike="noStrike" dirty="0">
@@ -16963,6 +17481,50 @@
                         </a:rPr>
                         <a:t>insert</a:t>
                       </a:r>
+                      <a:endParaRPr lang="en-US" sz="1200" b="0" i="0" u="none" strike="noStrike" dirty="0">
+                        <a:solidFill>
+                          <a:srgbClr val="000000"/>
+                        </a:solidFill>
+                        <a:effectLst/>
+                        <a:latin typeface="+mn-lt"/>
+                        <a:cs typeface="Calibri" panose="020F0502020204030204" pitchFamily="34" charset="0"/>
+                      </a:endParaRPr>
+                    </a:p>
+                  </a:txBody>
+                  <a:tcPr marL="0" marR="0" marT="0" marB="0" anchor="ctr">
+                    <a:solidFill>
+                      <a:schemeClr val="bg2"/>
+                    </a:solidFill>
+                  </a:tcPr>
+                </a:tc>
+                <a:tc>
+                  <a:txBody>
+                    <a:bodyPr/>
+                    <a:lstStyle/>
+                    <a:p>
+                      <a:pPr algn="ctr" fontAlgn="b"/>
+                      <a:endParaRPr lang="en-US" sz="1200" b="0" i="0" u="none" strike="noStrike" dirty="0">
+                        <a:solidFill>
+                          <a:srgbClr val="000000"/>
+                        </a:solidFill>
+                        <a:effectLst/>
+                        <a:latin typeface="+mn-lt"/>
+                        <a:cs typeface="Calibri" panose="020F0502020204030204" pitchFamily="34" charset="0"/>
+                      </a:endParaRPr>
+                    </a:p>
+                  </a:txBody>
+                  <a:tcPr marL="0" marR="0" marT="0" marB="0" anchor="ctr">
+                    <a:solidFill>
+                      <a:schemeClr val="bg2"/>
+                    </a:solidFill>
+                  </a:tcPr>
+                </a:tc>
+                <a:tc>
+                  <a:txBody>
+                    <a:bodyPr/>
+                    <a:lstStyle/>
+                    <a:p>
+                      <a:pPr algn="ctr" fontAlgn="b"/>
                       <a:endParaRPr lang="en-US" sz="1200" b="0" i="0" u="none" strike="noStrike" dirty="0">
                         <a:solidFill>
                           <a:srgbClr val="000000"/>
@@ -18767,17 +19329,6 @@
 </file>
 
 <file path=customXml/item2.xml><?xml version="1.0" encoding="utf-8"?>
-<p:properties xmlns:p="http://schemas.microsoft.com/office/2006/metadata/properties" xmlns:xsi="http://www.w3.org/2001/XMLSchema-instance" xmlns:pc="http://schemas.microsoft.com/office/infopath/2007/PartnerControls">
-  <documentManagement>
-    <lcf76f155ced4ddcb4097134ff3c332f xmlns="7114f878-0223-480d-a325-1373c6d0223b">
-      <Terms xmlns="http://schemas.microsoft.com/office/infopath/2007/PartnerControls"/>
-    </lcf76f155ced4ddcb4097134ff3c332f>
-    <TaxCatchAll xmlns="599183fe-bfa3-49f1-b3c6-3d50208c56e4" xsi:nil="true"/>
-  </documentManagement>
-</p:properties>
-</file>
-
-<file path=customXml/item3.xml><?xml version="1.0" encoding="utf-8"?>
 <ct:contentTypeSchema xmlns:ct="http://schemas.microsoft.com/office/2006/metadata/contentType" xmlns:ma="http://schemas.microsoft.com/office/2006/metadata/properties/metaAttributes" ct:_="" ma:_="" ma:contentTypeName="Document" ma:contentTypeID="0x010100DECEB3BBE86464488AD4A21F5C4B0058" ma:contentTypeVersion="14" ma:contentTypeDescription="Create a new document." ma:contentTypeScope="" ma:versionID="a7cc634175b1809f3343f27805d6d95a">
   <xsd:schema xmlns:xsd="http://www.w3.org/2001/XMLSchema" xmlns:xs="http://www.w3.org/2001/XMLSchema" xmlns:p="http://schemas.microsoft.com/office/2006/metadata/properties" xmlns:ns2="7114f878-0223-480d-a325-1373c6d0223b" xmlns:ns3="599183fe-bfa3-49f1-b3c6-3d50208c56e4" targetNamespace="http://schemas.microsoft.com/office/2006/metadata/properties" ma:root="true" ma:fieldsID="eae47b09d137326483c8116c39f5c3ec" ns2:_="" ns3:_="">
     <xsd:import namespace="7114f878-0223-480d-a325-1373c6d0223b"/>
@@ -18990,6 +19541,17 @@
 </ct:contentTypeSchema>
 </file>
 
+<file path=customXml/item3.xml><?xml version="1.0" encoding="utf-8"?>
+<p:properties xmlns:p="http://schemas.microsoft.com/office/2006/metadata/properties" xmlns:xsi="http://www.w3.org/2001/XMLSchema-instance" xmlns:pc="http://schemas.microsoft.com/office/infopath/2007/PartnerControls">
+  <documentManagement>
+    <lcf76f155ced4ddcb4097134ff3c332f xmlns="7114f878-0223-480d-a325-1373c6d0223b">
+      <Terms xmlns="http://schemas.microsoft.com/office/infopath/2007/PartnerControls"/>
+    </lcf76f155ced4ddcb4097134ff3c332f>
+    <TaxCatchAll xmlns="599183fe-bfa3-49f1-b3c6-3d50208c56e4" xsi:nil="true"/>
+  </documentManagement>
+</p:properties>
+</file>
+
 <file path=customXml/itemProps1.xml><?xml version="1.0" encoding="utf-8"?>
 <ds:datastoreItem xmlns:ds="http://schemas.openxmlformats.org/officeDocument/2006/customXml" ds:itemID="{5421F378-326F-4859-B6C8-701A3512AE1B}">
   <ds:schemaRefs>
@@ -18999,23 +19561,6 @@
 </file>
 
 <file path=customXml/itemProps2.xml><?xml version="1.0" encoding="utf-8"?>
-<ds:datastoreItem xmlns:ds="http://schemas.openxmlformats.org/officeDocument/2006/customXml" ds:itemID="{9DE45B87-9247-4103-B93A-84FCD96EFCA6}">
-  <ds:schemaRefs>
-    <ds:schemaRef ds:uri="http://schemas.openxmlformats.org/package/2006/metadata/core-properties"/>
-    <ds:schemaRef ds:uri="599183fe-bfa3-49f1-b3c6-3d50208c56e4"/>
-    <ds:schemaRef ds:uri="http://purl.org/dc/terms/"/>
-    <ds:schemaRef ds:uri="http://purl.org/dc/elements/1.1/"/>
-    <ds:schemaRef ds:uri="http://schemas.microsoft.com/office/2006/metadata/properties"/>
-    <ds:schemaRef ds:uri="http://schemas.microsoft.com/office/infopath/2007/PartnerControls"/>
-    <ds:schemaRef ds:uri="http://purl.org/dc/dcmitype/"/>
-    <ds:schemaRef ds:uri="http://schemas.microsoft.com/office/2006/documentManagement/types"/>
-    <ds:schemaRef ds:uri="7114f878-0223-480d-a325-1373c6d0223b"/>
-    <ds:schemaRef ds:uri="http://www.w3.org/XML/1998/namespace"/>
-  </ds:schemaRefs>
-</ds:datastoreItem>
-</file>
-
-<file path=customXml/itemProps3.xml><?xml version="1.0" encoding="utf-8"?>
 <ds:datastoreItem xmlns:ds="http://schemas.openxmlformats.org/officeDocument/2006/customXml" ds:itemID="{482D9DB4-ACE5-4817-ACA8-DC09E43D06D0}">
   <ds:schemaRefs>
     <ds:schemaRef ds:uri="599183fe-bfa3-49f1-b3c6-3d50208c56e4"/>
@@ -19032,4 +19577,21 @@
     <ds:schemaRef ds:uri="http://www.w3.org/2001/XMLSchema"/>
   </ds:schemaRefs>
 </ds:datastoreItem>
+</file>
+
+<file path=customXml/itemProps3.xml><?xml version="1.0" encoding="utf-8"?>
+<ds:datastoreItem xmlns:ds="http://schemas.openxmlformats.org/officeDocument/2006/customXml" ds:itemID="{9DE45B87-9247-4103-B93A-84FCD96EFCA6}">
+  <ds:schemaRefs>
+    <ds:schemaRef ds:uri="http://schemas.openxmlformats.org/package/2006/metadata/core-properties"/>
+    <ds:schemaRef ds:uri="599183fe-bfa3-49f1-b3c6-3d50208c56e4"/>
+    <ds:schemaRef ds:uri="http://purl.org/dc/terms/"/>
+    <ds:schemaRef ds:uri="http://purl.org/dc/elements/1.1/"/>
+    <ds:schemaRef ds:uri="http://schemas.microsoft.com/office/2006/metadata/properties"/>
+    <ds:schemaRef ds:uri="http://schemas.microsoft.com/office/infopath/2007/PartnerControls"/>
+    <ds:schemaRef ds:uri="http://purl.org/dc/dcmitype/"/>
+    <ds:schemaRef ds:uri="http://schemas.microsoft.com/office/2006/documentManagement/types"/>
+    <ds:schemaRef ds:uri="7114f878-0223-480d-a325-1373c6d0223b"/>
+    <ds:schemaRef ds:uri="http://www.w3.org/XML/1998/namespace"/>
+  </ds:schemaRefs>
+</ds:datastoreItem>
 </file>
</xml_diff>